<commit_message>
Fix poster font sizes and oversized text frames
- Switch TEXT_TO_FIT_SHAPE → SHAPE_TO_FIT_TEXT for small boxes so
  text renders at a readable size instead of being shrunk to fit
- Increase body font to 20-24pt, bullets to 17-18pt
- Shrink decision rule text frame from 15" to 6.5" (was 6 lines in
  a 15-inch box, leaving a huge blank)
- Shrink background containers for decision rule and examples sections
  to match actual content height

Co-Authored-By: Claude Sonnet 4.6 <noreply@anthropic.com>
</commit_message>
<xml_diff>
--- a/poster/poster_template.pptx
+++ b/poster/poster_template.pptx
@@ -1074,7 +1074,7 @@
         </p:spPr>
         <p:txBody>
           <a:bodyPr wrap="square" lIns="1016" tIns="1016" rIns="1016" bIns="1016" rtlCol="0" anchor="t">
-            <a:normAutofit/>
+            <a:spAutoFit/>
           </a:bodyPr>
           <a:lstStyle/>
           <a:p>
@@ -1088,7 +1088,7 @@
               <a:buNone/>
             </a:pPr>
             <a:r>
-              <a:rPr sz="1900"/>
+              <a:rPr sz="2000"/>
               <a:t>LLMs are increasingly used to evaluate causal claims, but real causal oversight is selective and adversarial under information asymmetry: claimants hold private information, exploit non-identifiability, and present persuasive but incomplete reasoning. Existing causal benchmarks treat unidentifiability as a degraded label and let oracle metadata leak into the verifier. We formalize the task, release a leakage-free benchmark, and propose a countermodel-grounded selective verifier.</a:t>
             </a:r>
             <a:endParaRPr lang="en-US" sz="2400" dirty="0"/>
@@ -1187,7 +1187,7 @@
         </p:spPr>
         <p:txBody>
           <a:bodyPr wrap="square" lIns="381" tIns="381" rIns="381" bIns="381" rtlCol="0" anchor="ctr">
-            <a:normAutofit/>
+            <a:spAutoFit/>
           </a:bodyPr>
           <a:lstStyle/>
           <a:p>
@@ -1199,7 +1199,7 @@
               <a:buChar char="•"/>
             </a:pPr>
             <a:r>
-              <a:rPr sz="1600"/>
+              <a:rPr sz="1800"/>
               <a:t>Hook: causal claim oversight is selective + adversarial under information asymmetry</a:t>
             </a:r>
             <a:endParaRPr lang="en-US" sz="2400" dirty="0"/>
@@ -1211,7 +1211,7 @@
               </a:spcAft>
             </a:pPr>
             <a:r>
-              <a:rPr sz="1600"/>
+              <a:rPr sz="1800"/>
               <a:t>Problem: unidentifiable is treated as a degraded label and oracle metadata leaks into verifiers</a:t>
             </a:r>
           </a:p>
@@ -1222,7 +1222,7 @@
               </a:spcAft>
             </a:pPr>
             <a:r>
-              <a:rPr sz="1600"/>
+              <a:rPr sz="1800"/>
               <a:t>Method: leakage-free benchmark + four-stage countermodel-grounded selective verifier</a:t>
             </a:r>
           </a:p>
@@ -1322,7 +1322,7 @@
         </p:spPr>
         <p:txBody>
           <a:bodyPr wrap="square" lIns="381" tIns="381" rIns="381" bIns="381" rtlCol="0" anchor="ctr">
-            <a:normAutofit/>
+            <a:spAutoFit/>
           </a:bodyPr>
           <a:lstStyle/>
           <a:p>
@@ -1334,7 +1334,7 @@
               <a:buChar char="•"/>
             </a:pPr>
             <a:r>
-              <a:rPr sz="1500"/>
+              <a:rPr sz="1700"/>
               <a:t>C1 (Task) - Selective adversarial causal oversight: three-way verdict {valid / invalid / unidentifiable} with structured assumption ledger, refusal reason, and witness slots.</a:t>
             </a:r>
             <a:endParaRPr lang="en-US" sz="2400" dirty="0"/>
@@ -1346,7 +1346,7 @@
               </a:spcAft>
             </a:pPr>
             <a:r>
-              <a:rPr sz="1500"/>
+              <a:rPr sz="1700"/>
               <a:t>C2 (Benchmark) - Twelve graph families across Pearl L1/L2/L3, schema-level public/gold partition, five-axis persuasion overlay, OOD design space.</a:t>
             </a:r>
           </a:p>
@@ -1357,7 +1357,7 @@
               </a:spcAft>
             </a:pPr>
             <a:r>
-              <a:rPr sz="1500"/>
+              <a:rPr sz="1700"/>
               <a:t>C3 (Verifier) - Four-stage pipeline (Parser -&gt; Ledger -&gt; Countermodel Search -&gt; Tool-backed Adjudication) with deterministic decision rule and abstention gate.</a:t>
             </a:r>
           </a:p>
@@ -1496,7 +1496,7 @@
         </p:spPr>
         <p:txBody>
           <a:bodyPr wrap="square" lIns="1016" tIns="1016" rIns="1016" bIns="1016" rtlCol="0" anchor="t">
-            <a:normAutofit/>
+            <a:spAutoFit/>
           </a:bodyPr>
           <a:lstStyle/>
           <a:p>
@@ -1510,7 +1510,7 @@
               <a:buNone/>
             </a:pPr>
             <a:r>
-              <a:rPr sz="1800"/>
+              <a:rPr sz="2000"/>
               <a:t>Four sequential stages turn a natural-language claim into a selective verdict. Stages 1-2 produce structured slots and an identifying-assumption ledger; Stage 3 searches for an observationally compatible counter-SCM that disagrees on the target query; Stage 4 consults Pearl-style identification tools only when no countermodel survives.</a:t>
             </a:r>
             <a:endParaRPr lang="en-US" sz="2400" dirty="0"/>
@@ -1757,7 +1757,7 @@
         </p:spPr>
         <p:txBody>
           <a:bodyPr wrap="square" lIns="381" tIns="381" rIns="381" bIns="381" rtlCol="0" anchor="ctr">
-            <a:normAutofit/>
+            <a:spAutoFit/>
           </a:bodyPr>
           <a:lstStyle/>
           <a:p>
@@ -1769,7 +1769,7 @@
               <a:buChar char="•"/>
             </a:pPr>
             <a:r>
-              <a:rPr sz="1500"/>
+              <a:rPr sz="1800"/>
               <a:t>Dataset: 12 graph families (4 L1, 5 L2, 3 L3); literature-grounded subset reserved</a:t>
             </a:r>
             <a:endParaRPr lang="en-US" sz="2400" dirty="0"/>
@@ -1781,7 +1781,7 @@
               </a:spcAft>
             </a:pPr>
             <a:r>
-              <a:rPr sz="1500"/>
+              <a:rPr sz="1800"/>
               <a:t>Splits: train / dev / test_iid / test_ood with five orthogonal holdout axes</a:t>
             </a:r>
           </a:p>
@@ -1792,7 +1792,7 @@
               </a:spcAft>
             </a:pPr>
             <a:r>
-              <a:rPr sz="1500"/>
+              <a:rPr sz="1800"/>
               <a:t>Task: three-way verdict + identification status + refusal reason + assumption ledger + 3 witness slots</a:t>
             </a:r>
           </a:p>
@@ -1803,7 +1803,7 @@
               </a:spcAft>
             </a:pPr>
             <a:r>
-              <a:rPr sz="1500"/>
+              <a:rPr sz="1800"/>
               <a:t>Baselines: Countermodel-Grounded, No-Tools, No-Countermodel, No-Ledger, No-Abstention, Claim-Only</a:t>
             </a:r>
           </a:p>
@@ -1814,7 +1814,7 @@
               </a:spcAft>
             </a:pPr>
             <a:r>
-              <a:rPr sz="1500"/>
+              <a:rPr sz="1800"/>
               <a:t>Budget: 3 seeds x 2 samples / family - exploratory</a:t>
             </a:r>
           </a:p>
@@ -1953,7 +1953,7 @@
         </p:spPr>
         <p:txBody>
           <a:bodyPr wrap="square" lIns="1016" tIns="1016" rIns="1016" bIns="1016" rtlCol="0" anchor="t">
-            <a:normAutofit/>
+            <a:spAutoFit/>
           </a:bodyPr>
           <a:lstStyle/>
           <a:p>
@@ -1967,7 +1967,7 @@
               <a:buNone/>
             </a:pPr>
             <a:r>
-              <a:rPr sz="1800"/>
+              <a:rPr sz="2000"/>
               <a:t>The third label is not cosmetic. Pearl hierarchy theorem: layer-k data underdetermines layer-(k+1) truth almost everywhere, so for many claims the correct answer under public evidence is to abstain with a structured reason.</a:t>
             </a:r>
             <a:endParaRPr lang="en-US" sz="2400" dirty="0"/>
@@ -2029,7 +2029,7 @@
         </p:spPr>
         <p:txBody>
           <a:bodyPr wrap="square" lIns="0" tIns="0" rIns="0" bIns="0" rtlCol="0" anchor="ctr">
-            <a:normAutofit/>
+            <a:spAutoFit/>
           </a:bodyPr>
           <a:lstStyle/>
           <a:p>
@@ -2040,7 +2040,7 @@
               <a:buNone/>
             </a:pPr>
             <a:r>
-              <a:rPr sz="1800" b="1"/>
+              <a:rPr sz="2000" b="1"/>
               <a:t>Proposition 1 (Abstention Necessity). If SCMs M1, M2 both induce public evidence E but disagree on target query q, then any verifier without an unidentifiable output is wrong on at least one of M1, M2.</a:t>
             </a:r>
             <a:endParaRPr lang="en-US" sz="2600" dirty="0"/>
@@ -2141,7 +2141,7 @@
         </p:spPr>
         <p:txBody>
           <a:bodyPr wrap="square" lIns="381" tIns="381" rIns="381" bIns="381" rtlCol="0" anchor="ctr">
-            <a:normAutofit/>
+            <a:spAutoFit/>
           </a:bodyPr>
           <a:lstStyle/>
           <a:p>
@@ -2153,7 +2153,7 @@
               <a:buChar char="•"/>
             </a:pPr>
             <a:r>
-              <a:rPr sz="1600"/>
+              <a:rPr sz="1800"/>
               <a:t>What it does: any yes/no-only verifier is provably wrong on observationally-equivalent samples</a:t>
             </a:r>
             <a:endParaRPr lang="en-US" sz="2400" dirty="0"/>
@@ -2165,7 +2165,7 @@
               </a:spcAft>
             </a:pPr>
             <a:r>
-              <a:rPr sz="1600"/>
+              <a:rPr sz="1800"/>
               <a:t>Why it is needed: Pearl hierarchy theorem shows layer-k data generically underdetermines layer-(k+1) truth</a:t>
             </a:r>
           </a:p>
@@ -2176,7 +2176,7 @@
               </a:spcAft>
             </a:pPr>
             <a:r>
-              <a:rPr sz="1600"/>
+              <a:rPr sz="1800"/>
               <a:t>Design choice: unidentifiable is a first-class label with structured refusal reason</a:t>
             </a:r>
           </a:p>
@@ -2191,7 +2191,7 @@
         <p:spPr>
           <a:xfrm>
             <a:off x="12225600" y="10764000"/>
-            <a:ext cx="10108800" cy="14349600"/>
+            <a:ext cx="10108800" cy="6400800"/>
           </a:xfrm>
           <a:prstGeom prst="roundRect">
             <a:avLst>
@@ -2225,7 +2225,7 @@
         <p:spPr>
           <a:xfrm>
             <a:off x="12528000" y="11592000"/>
-            <a:ext cx="9504000" cy="13845600"/>
+            <a:ext cx="9504000" cy="5943600"/>
           </a:xfrm>
           <a:prstGeom prst="rect">
             <a:avLst/>
@@ -2235,7 +2235,7 @@
         </p:spPr>
         <p:txBody>
           <a:bodyPr wrap="square" lIns="0" tIns="0" rIns="0" bIns="0" rtlCol="0" anchor="ctr">
-            <a:normAutofit/>
+            <a:noAutofit/>
           </a:bodyPr>
           <a:lstStyle/>
           <a:p>
@@ -2245,7 +2245,7 @@
               </a:spcAft>
             </a:pPr>
             <a:r>
-              <a:rPr sz="1800" b="1"/>
+              <a:rPr sz="2400" b="1"/>
               <a:t>Decision rule (fixed five-branch order):</a:t>
             </a:r>
           </a:p>
@@ -2256,7 +2256,7 @@
               </a:spcAft>
             </a:pPr>
             <a:r>
-              <a:rPr sz="1800"/>
+              <a:rPr sz="2400"/>
               <a:t>1. strong invalid countermodel -&gt; INVALID</a:t>
             </a:r>
           </a:p>
@@ -2267,7 +2267,7 @@
               </a:spcAft>
             </a:pPr>
             <a:r>
-              <a:rPr sz="1800"/>
+              <a:rPr sz="2400"/>
               <a:t>2. compatible models, disagree on q -&gt; UNIDENTIFIABLE (observational_equivalence)</a:t>
             </a:r>
           </a:p>
@@ -2278,7 +2278,7 @@
               </a:spcAft>
             </a:pPr>
             <a:r>
-              <a:rPr sz="1800"/>
+              <a:rPr sz="2400"/>
               <a:t>3a. assumption contradicted by tools -&gt; INVALID</a:t>
             </a:r>
           </a:p>
@@ -2289,7 +2289,7 @@
               </a:spcAft>
             </a:pPr>
             <a:r>
-              <a:rPr sz="1800"/>
+              <a:rPr sz="2400"/>
               <a:t>3b. ID assumption unsupported -&gt; UNIDENTIFIABLE (missing_identifying_support)</a:t>
             </a:r>
           </a:p>
@@ -2300,7 +2300,7 @@
               </a:spcAft>
             </a:pPr>
             <a:r>
-              <a:rPr sz="1800"/>
+              <a:rPr sz="2400"/>
               <a:t>4. tools + ledger jointly support -&gt; VALID</a:t>
             </a:r>
           </a:p>
@@ -2434,7 +2434,7 @@
         </p:spPr>
         <p:txBody>
           <a:bodyPr wrap="square" lIns="1016" tIns="1016" rIns="1016" bIns="1016" rtlCol="0" anchor="t">
-            <a:normAutofit/>
+            <a:spAutoFit/>
           </a:bodyPr>
           <a:lstStyle/>
           <a:p>
@@ -2444,7 +2444,7 @@
               </a:spcAft>
             </a:pPr>
             <a:r>
-              <a:rPr sz="1800"/>
+              <a:rPr sz="2000"/>
               <a:t>Main benchmark across the full pipeline and four ablations, on the schema-level public/gold partition. The full system reaches saturated accuracy on this exploratory budget.</a:t>
             </a:r>
           </a:p>
@@ -2576,7 +2576,7 @@
         </p:spPr>
         <p:txBody>
           <a:bodyPr wrap="square" lIns="381" tIns="381" rIns="381" bIns="381" rtlCol="0" anchor="ctr">
-            <a:normAutofit/>
+            <a:spAutoFit/>
           </a:bodyPr>
           <a:lstStyle/>
           <a:p>
@@ -2588,7 +2588,7 @@
               <a:buChar char="•"/>
             </a:pPr>
             <a:r>
-              <a:rPr sz="1600"/>
+              <a:rPr sz="1800"/>
               <a:t>Comparison: pipeline component ablations on same public/gold partition</a:t>
             </a:r>
             <a:endParaRPr lang="en-US" sz="2400" dirty="0"/>
@@ -2600,7 +2600,7 @@
               </a:spcAft>
             </a:pPr>
             <a:r>
-              <a:rPr sz="1600"/>
+              <a:rPr sz="1800"/>
               <a:t>Best: full system 1.00 / 1.00 (IID / OOD) vs 0.39-0.78 for ablations</a:t>
             </a:r>
           </a:p>
@@ -2611,7 +2611,7 @@
               </a:spcAft>
             </a:pPr>
             <a:r>
-              <a:rPr sz="1600"/>
+              <a:rPr sz="1800"/>
               <a:t>Key insight: No-Abstention keeps high raw accuracy but fails on unidentifiable cases</a:t>
             </a:r>
           </a:p>
@@ -2626,7 +2626,7 @@
         <p:spPr>
           <a:xfrm>
             <a:off x="23112000" y="13320000"/>
-            <a:ext cx="10656000" cy="12009600"/>
+            <a:ext cx="10656000" cy="8229600"/>
           </a:xfrm>
           <a:prstGeom prst="roundRect">
             <a:avLst>
@@ -2736,7 +2736,7 @@
         <p:spPr>
           <a:xfrm>
             <a:off x="23400000" y="14371200"/>
-            <a:ext cx="4968000" cy="7956000"/>
+            <a:ext cx="4968000" cy="4114800"/>
           </a:xfrm>
           <a:prstGeom prst="roundRect">
             <a:avLst>
@@ -2811,7 +2811,7 @@
         <p:spPr>
           <a:xfrm>
             <a:off x="23544000" y="14500800"/>
-            <a:ext cx="4651200" cy="7480800"/>
+            <a:ext cx="4651200" cy="3200400"/>
           </a:xfrm>
           <a:prstGeom prst="rect">
             <a:avLst/>
@@ -2821,7 +2821,7 @@
         </p:spPr>
         <p:txBody>
           <a:bodyPr wrap="square" lIns="381" tIns="381" rIns="381" bIns="381" rtlCol="0" anchor="ctr">
-            <a:normAutofit/>
+            <a:noAutofit/>
           </a:bodyPr>
           <a:lstStyle/>
           <a:p>
@@ -2833,7 +2833,7 @@
               <a:buChar char="•"/>
             </a:pPr>
             <a:r>
-              <a:rPr sz="1400"/>
+              <a:rPr sz="2000"/>
               <a:t>Setup: latent confounding (L1) - observed correlation plus proxy variable; gold label is unidentifiable</a:t>
             </a:r>
             <a:endParaRPr lang="en-US" sz="2400" dirty="0"/>
@@ -2845,7 +2845,7 @@
               </a:spcAft>
             </a:pPr>
             <a:r>
-              <a:rPr sz="1400"/>
+              <a:rPr sz="2000"/>
               <a:t>Output: Stage 3 finds counter-SCM with hidden confounder; verdict unidentifiable + observational_equivalence refusal reason</a:t>
             </a:r>
           </a:p>
@@ -2860,7 +2860,7 @@
         <p:spPr>
           <a:xfrm>
             <a:off x="28526400" y="14371200"/>
-            <a:ext cx="4968000" cy="7956000"/>
+            <a:ext cx="4968000" cy="4114800"/>
           </a:xfrm>
           <a:prstGeom prst="roundRect">
             <a:avLst>
@@ -2935,7 +2935,7 @@
         <p:spPr>
           <a:xfrm>
             <a:off x="28684800" y="14500800"/>
-            <a:ext cx="4651200" cy="7480800"/>
+            <a:ext cx="4651200" cy="3200400"/>
           </a:xfrm>
           <a:prstGeom prst="rect">
             <a:avLst/>
@@ -2945,7 +2945,7 @@
         </p:spPr>
         <p:txBody>
           <a:bodyPr wrap="square" lIns="381" tIns="381" rIns="381" bIns="381" rtlCol="0" anchor="ctr">
-            <a:normAutofit/>
+            <a:noAutofit/>
           </a:bodyPr>
           <a:lstStyle/>
           <a:p>
@@ -2957,7 +2957,7 @@
               <a:buChar char="•"/>
             </a:pPr>
             <a:r>
-              <a:rPr sz="1400"/>
+              <a:rPr sz="2000"/>
               <a:t>Setup: positive-control verifier with access to one gold-only field on attack-only benchmark</a:t>
             </a:r>
             <a:endParaRPr lang="en-US" sz="2400" dirty="0"/>
@@ -2969,7 +2969,7 @@
               </a:spcAft>
             </a:pPr>
             <a:r>
-              <a:rPr sz="1400"/>
+              <a:rPr sz="2000"/>
               <a:t>Effect: leaking control reaches 1.00 IID accuracy vs 0.33 for clean public verifier (delta = +0.67)</a:t>
             </a:r>
           </a:p>

</xml_diff>

<commit_message>
Add three visualization charts to fill poster blank space
- Section 4: obs_equivalence diagram (Proposition 1 cartoon - two
  observationally equivalent SCMs that disagree on do(X))
- Section 4: ablation_chart bar chart (5 systems x IID/OOD)
- Section 5: ood_chart bar chart (per-bucket OOD generalization;
  graph-family shift collapses verdict accuracy)

Co-Authored-By: Claude Opus 4.7 <noreply@anthropic.com>
</commit_message>
<xml_diff>
--- a/poster/poster_template.pptx
+++ b/poster/poster_template.pptx
@@ -3302,6 +3302,78 @@
           </a:graphicData>
         </a:graphic>
       </p:graphicFrame>
+      <p:pic>
+        <p:nvPicPr>
+          <p:cNvPr id="84" name="Picture 83" descr="image.png"/>
+          <p:cNvPicPr>
+            <a:picLocks noChangeAspect="1"/>
+          </p:cNvPicPr>
+          <p:nvPr/>
+        </p:nvPicPr>
+        <p:blipFill>
+          <a:blip r:embed="rId5"/>
+          <a:stretch>
+            <a:fillRect/>
+          </a:stretch>
+        </p:blipFill>
+        <p:spPr>
+          <a:xfrm>
+            <a:off x="12801600" y="17373600"/>
+            <a:ext cx="8229600" cy="3263366"/>
+          </a:xfrm>
+          <a:prstGeom prst="rect">
+            <a:avLst/>
+          </a:prstGeom>
+        </p:spPr>
+      </p:pic>
+      <p:pic>
+        <p:nvPicPr>
+          <p:cNvPr id="85" name="Picture 84" descr="image.png"/>
+          <p:cNvPicPr>
+            <a:picLocks noChangeAspect="1"/>
+          </p:cNvPicPr>
+          <p:nvPr/>
+        </p:nvPicPr>
+        <p:blipFill>
+          <a:blip r:embed="rId6"/>
+          <a:stretch>
+            <a:fillRect/>
+          </a:stretch>
+        </p:blipFill>
+        <p:spPr>
+          <a:xfrm>
+            <a:off x="12344400" y="20819845"/>
+            <a:ext cx="9144000" cy="4522286"/>
+          </a:xfrm>
+          <a:prstGeom prst="rect">
+            <a:avLst/>
+          </a:prstGeom>
+        </p:spPr>
+      </p:pic>
+      <p:pic>
+        <p:nvPicPr>
+          <p:cNvPr id="86" name="Picture 85" descr="image.png"/>
+          <p:cNvPicPr>
+            <a:picLocks noChangeAspect="1"/>
+          </p:cNvPicPr>
+          <p:nvPr/>
+        </p:nvPicPr>
+        <p:blipFill>
+          <a:blip r:embed="rId7"/>
+          <a:stretch>
+            <a:fillRect/>
+          </a:stretch>
+        </p:blipFill>
+        <p:spPr>
+          <a:xfrm>
+            <a:off x="23317200" y="19202400"/>
+            <a:ext cx="10058400" cy="4405496"/>
+          </a:xfrm>
+          <a:prstGeom prst="rect">
+            <a:avLst/>
+          </a:prstGeom>
+        </p:spPr>
+      </p:pic>
     </p:spTree>
   </p:cSld>
   <p:clrMapOvr>

</xml_diff>

<commit_message>
Update authors: Jingbei Niu, Zeyuan Tong, Yuhang Li
Replace anonymous author placeholders in both the paper (LaTeX,
affiliation = Zhejiang University) and the poster (PPTX author line).

Co-Authored-By: Claude Sonnet 4.6 <noreply@anthropic.com>
</commit_message>
<xml_diff>
--- a/poster/poster_template.pptx
+++ b/poster/poster_template.pptx
@@ -855,8 +855,8 @@
           <a:ln/>
         </p:spPr>
         <p:txBody>
-          <a:bodyPr wrap="square" lIns="0" tIns="0" rIns="0" bIns="0" rtlCol="0" anchor="ctr">
-            <a:normAutofit/>
+          <a:bodyPr wrap="none" lIns="0" tIns="0" rIns="0" bIns="0" rtlCol="0" anchor="ctr">
+            <a:noAutofit/>
           </a:bodyPr>
           <a:lstStyle/>
           <a:p>
@@ -868,7 +868,7 @@
             </a:pPr>
             <a:r>
               <a:rPr sz="2300"/>
-              <a:t>Authors anonymized for course submission</a:t>
+              <a:t>Jingbei Niu   Zeyuan Tong   Yuhang Li</a:t>
             </a:r>
             <a:endParaRPr lang="en-US" sz="3200" dirty="0"/>
           </a:p>

</xml_diff>

<commit_message>
modified:   experiments/benchmark_harness.py 	modified:   game/llm_service.py 	modified:   poster/ablation_chart.png 	modified:   poster/icml2026/example_paper.bib 	modified:   poster/icml2026/example_paper.pdf 	modified:   poster/icml2026/example_paper.tex 	modified:   poster/ood_chart.png 	new file:   poster/poster_template.pdf 	modified:   poster/poster_template.pptx 	modified:   tests/test_benchmark_harness.py 	new file:   tests/test_llm_service.py
</commit_message>
<xml_diff>
--- a/poster/poster_template.pptx
+++ b/poster/poster_template.pptx
@@ -818,22 +818,16 @@
           <a:ln/>
         </p:spPr>
         <p:txBody>
-          <a:bodyPr wrap="square" lIns="0" tIns="0" rIns="0" bIns="0" rtlCol="0" anchor="ctr">
+          <a:bodyPr wrap="square" lIns="50800" tIns="0" rIns="50800" bIns="0" rtlCol="0" anchor="ctr">
             <a:normAutofit/>
           </a:bodyPr>
           <a:lstStyle/>
           <a:p>
-            <a:pPr marL="0" indent="0">
-              <a:spcAft>
-                <a:spcPts val="300"/>
-              </a:spcAft>
-              <a:buNone/>
-            </a:pPr>
+            <a:pPr algn="l"/>
             <a:r>
-              <a:rPr sz="3400" b="1"/>
-              <a:t>Selective Adversarial Causal Oversight: A Leakage-Free Benchmark and Countermodel-Grounded Verifier under Information Asymmetry</a:t>
+              <a:rPr sz="2800" b="1"/>
+              <a:t>Selective Adversarial Causal Oversight: Information-Partitioned Benchmark Contract and Countermodel-Grounded Reference Verifier</a:t>
             </a:r>
-            <a:endParaRPr lang="en-US" sz="6000" dirty="0"/>
           </a:p>
         </p:txBody>
       </p:sp>
@@ -892,22 +886,16 @@
           <a:ln/>
         </p:spPr>
         <p:txBody>
-          <a:bodyPr wrap="square" lIns="0" tIns="0" rIns="0" bIns="0" rtlCol="0" anchor="ctr">
+          <a:bodyPr wrap="square" lIns="50800" tIns="0" rIns="50800" bIns="0" rtlCol="0" anchor="ctr">
             <a:normAutofit/>
           </a:bodyPr>
           <a:lstStyle/>
           <a:p>
-            <a:pPr marL="0" indent="0">
-              <a:spcAft>
-                <a:spcPts val="300"/>
-              </a:spcAft>
-              <a:buNone/>
-            </a:pPr>
+            <a:pPr algn="l"/>
             <a:r>
-              <a:rPr sz="1800"/>
-              <a:t>Course project - Causal Reasoning - Spring-Summer 2026</a:t>
+              <a:rPr sz="1200"/>
+              <a:t>Course project - Causal Reasoning - Spring-Summer 2026 - fixed-code exploratory snapshot</a:t>
             </a:r>
-            <a:endParaRPr lang="en-US" sz="2400" dirty="0"/>
           </a:p>
         </p:txBody>
       </p:sp>
@@ -1073,25 +1061,16 @@
           <a:ln/>
         </p:spPr>
         <p:txBody>
-          <a:bodyPr wrap="square" lIns="1016" tIns="1016" rIns="1016" bIns="1016" rtlCol="0" anchor="t">
+          <a:bodyPr wrap="square" lIns="50800" tIns="1016" rIns="50800" bIns="1016" rtlCol="0" anchor="t">
             <a:spAutoFit/>
           </a:bodyPr>
           <a:lstStyle/>
           <a:p>
-            <a:pPr marL="0" indent="0" algn="l">
-              <a:lnSpc>
-                <a:spcPct val="108000"/>
-              </a:lnSpc>
-              <a:spcAft>
-                <a:spcPts val="300"/>
-              </a:spcAft>
-              <a:buNone/>
-            </a:pPr>
+            <a:pPr algn="l"/>
             <a:r>
-              <a:rPr sz="2000"/>
-              <a:t>Causal claim oversight is hard because the claimant may know more than the verifier. Under public evidence alone, some claims are valid, some are invalid, and some are genuinely unidentifiable. Existing benchmarks often leak oracle metadata or force a yes/no answer. We instead formalize selective adversarial causal oversight, build a leakage-free benchmark, and evaluate a countermodel-grounded verifier.</a:t>
+              <a:rPr sz="1200"/>
+              <a:t>Causal claim oversight is public-view verification under private information. Some claims are valid, some are invalid, and some are genuinely unidentifiable from public evidence alone. We formalize selective adversarial causal oversight and treat correct refusal as a causal-identification requirement rather than a generic uncertainty fallback.</a:t>
             </a:r>
-            <a:endParaRPr lang="en-US" sz="2400" dirty="0"/>
           </a:p>
         </p:txBody>
       </p:sp>
@@ -1186,51 +1165,16 @@
           <a:ln/>
         </p:spPr>
         <p:txBody>
-          <a:bodyPr wrap="square" lIns="381" tIns="381" rIns="381" bIns="381" rtlCol="0" anchor="ctr">
+          <a:bodyPr wrap="square" lIns="50800" tIns="381" rIns="50800" bIns="381" rtlCol="0" anchor="ctr">
             <a:spAutoFit/>
           </a:bodyPr>
           <a:lstStyle/>
           <a:p>
-            <a:pPr marL="152400" indent="-152400">
-              <a:spcAft>
-                <a:spcPts val="300"/>
-              </a:spcAft>
-              <a:buSzPct val="100000"/>
-              <a:buChar char="•"/>
-            </a:pPr>
+            <a:pPr algn="l"/>
             <a:r>
-              <a:rPr sz="1800"/>
-              <a:t>Hook: causal oversight is public-view verification under private information</a:t>
+              <a:rPr sz="1200"/>
+              <a:t>Hook: causal oversight is public-view verification under private information | Problem: yes/no judges unsafe-accept under non-identifiability; leakage can fake competence | Current evidence: schema partition + synthetic fixed-code snapshot; real-grounded human audit pending</a:t>
             </a:r>
-            <a:endParaRPr lang="en-US" sz="2400" dirty="0"/>
-          </a:p>
-          <a:p>
-            <a:pPr marL="152400" indent="-152400">
-              <a:spcAft>
-                <a:spcPts val="300"/>
-              </a:spcAft>
-              <a:buSzPct val="100000"/>
-              <a:buChar char="•"/>
-            </a:pPr>
-            <a:r>
-              <a:rPr sz="1800"/>
-              <a:t>Problem: yes/no judges over-accept; leaked metadata can fake competence</a:t>
-            </a:r>
-            <a:endParaRPr lang="en-US" sz="2400" dirty="0"/>
-          </a:p>
-          <a:p>
-            <a:pPr marL="152400" indent="-152400">
-              <a:spcAft>
-                <a:spcPts val="300"/>
-              </a:spcAft>
-              <a:buSzPct val="100000"/>
-              <a:buChar char="•"/>
-            </a:pPr>
-            <a:r>
-              <a:rPr sz="1800"/>
-              <a:t>Answer: leakage-free benchmark + countermodel-grounded verifier</a:t>
-            </a:r>
-            <a:endParaRPr lang="en-US" sz="2400" dirty="0"/>
           </a:p>
         </p:txBody>
       </p:sp>
@@ -1327,51 +1271,16 @@
           <a:ln/>
         </p:spPr>
         <p:txBody>
-          <a:bodyPr wrap="square" lIns="381" tIns="381" rIns="381" bIns="381" rtlCol="0" anchor="ctr">
+          <a:bodyPr wrap="square" lIns="50800" tIns="381" rIns="50800" bIns="381" rtlCol="0" anchor="ctr">
             <a:spAutoFit/>
           </a:bodyPr>
           <a:lstStyle/>
           <a:p>
-            <a:pPr marL="152400" indent="-152400">
-              <a:spcAft>
-                <a:spcPts val="300"/>
-              </a:spcAft>
-              <a:buSzPct val="100000"/>
-              <a:buChar char="•"/>
-            </a:pPr>
+            <a:pPr algn="l"/>
             <a:r>
-              <a:rPr sz="1700"/>
-              <a:t>C1 Task: three-way verdict {valid / invalid / unidentifiable} with structured refusal</a:t>
+              <a:rPr sz="1200"/>
+              <a:t>C1 Task: three-way verdict {valid / invalid / unidentifiable} with structured refusal | C2 Benchmark contract: 12 graph families, public/gold partition, persuasion overlay, OOD buckets | C3 Reference verifier: Parser -&gt; Ledger -&gt; Countermodel -&gt; Tools with fixed decision rule</a:t>
             </a:r>
-            <a:endParaRPr lang="en-US" sz="2400" dirty="0"/>
-          </a:p>
-          <a:p>
-            <a:pPr marL="152400" indent="-152400">
-              <a:spcAft>
-                <a:spcPts val="300"/>
-              </a:spcAft>
-              <a:buSzPct val="100000"/>
-              <a:buChar char="•"/>
-            </a:pPr>
-            <a:r>
-              <a:rPr sz="1700"/>
-              <a:t>C2 Benchmark: 12 graph families, public/gold partition, persuasion overlay, OOD buckets</a:t>
-            </a:r>
-            <a:endParaRPr lang="en-US" sz="2400" dirty="0"/>
-          </a:p>
-          <a:p>
-            <a:pPr marL="152400" indent="-152400">
-              <a:spcAft>
-                <a:spcPts val="300"/>
-              </a:spcAft>
-              <a:buSzPct val="100000"/>
-              <a:buChar char="•"/>
-            </a:pPr>
-            <a:r>
-              <a:rPr sz="1700"/>
-              <a:t>C3 Verifier: Parser -&gt; Ledger -&gt; Countermodel -&gt; Tools with fixed decision rule</a:t>
-            </a:r>
-            <a:endParaRPr lang="en-US" sz="2400" dirty="0"/>
           </a:p>
         </p:txBody>
       </p:sp>
@@ -1507,25 +1416,16 @@
           <a:ln/>
         </p:spPr>
         <p:txBody>
-          <a:bodyPr wrap="square" lIns="1016" tIns="1016" rIns="1016" bIns="1016" rtlCol="0" anchor="t">
+          <a:bodyPr wrap="square" lIns="50800" tIns="1016" rIns="50800" bIns="1016" rtlCol="0" anchor="t">
             <a:spAutoFit/>
           </a:bodyPr>
           <a:lstStyle/>
           <a:p>
-            <a:pPr marL="0" indent="0" algn="l">
-              <a:lnSpc>
-                <a:spcPct val="108000"/>
-              </a:lnSpc>
-              <a:spcAft>
-                <a:spcPts val="300"/>
-              </a:spcAft>
-              <a:buNone/>
-            </a:pPr>
+            <a:pPr algn="l"/>
             <a:r>
-              <a:rPr sz="2000"/>
-              <a:t>Four stages turn a claim into a selective verdict. Parser + ledger surface the identifying assumptions; countermodel search tests whether public evidence supports incompatible SCMs; tools are consulted only when no countermodel survives.</a:t>
+              <a:rPr sz="1200"/>
+              <a:t>Four stages turn a public claim into a selective verdict. Parser + ledger surface identifying assumptions; countermodel search tests whether public evidence admits incompatible SCMs; tools are supporting evidence rather than an oracle answer channel.</a:t>
             </a:r>
-            <a:endParaRPr lang="en-US" sz="2400" dirty="0"/>
           </a:p>
         </p:txBody>
       </p:sp>
@@ -1768,121 +1668,16 @@
           <a:ln/>
         </p:spPr>
         <p:txBody>
-          <a:bodyPr wrap="square" lIns="381" tIns="300" rIns="381" bIns="300" rtlCol="0" anchor="t">
+          <a:bodyPr wrap="square" lIns="50800" tIns="300" rIns="50800" bIns="300" rtlCol="0" anchor="t">
             <a:spAutoFit/>
           </a:bodyPr>
           <a:lstStyle/>
           <a:p>
-            <a:pPr marL="152400" indent="-152400">
-              <a:spcAft>
-                <a:spcPts val="280"/>
-              </a:spcAft>
-              <a:buSzPct val="100000"/>
-              <a:buChar char="•"/>
-            </a:pPr>
+            <a:pPr algn="l"/>
             <a:r>
-              <a:rPr sz="1750"/>
-              <a:t>Attacker -&gt; gold SCM + full data</a:t>
+              <a:rPr sz="1200"/>
+              <a:t>Attacker -&gt; gold SCM + full data | Verifier -&gt; public scenario + claim only | Evaluator -&gt; gold + verifier outputs | Verdict -&gt; valid / invalid / unidentifiable | Extras -&gt; refusal reason + witness + evidence gap | Leakage control -&gt; protocol-violating control must inflate scores | OOD -&gt; graph / mechanism / attack / context / paired-flip</a:t>
             </a:r>
-            <a:endParaRPr lang="en-US"/>
-          </a:p>
-          <a:p>
-            <a:pPr marL="152400" indent="-152400">
-              <a:spcAft>
-                <a:spcPts val="280"/>
-              </a:spcAft>
-              <a:buSzPct val="100000"/>
-              <a:buChar char="•"/>
-            </a:pPr>
-            <a:r>
-              <a:rPr sz="1750"/>
-              <a:t>Verifier -&gt; public scenario + claim</a:t>
-            </a:r>
-            <a:endParaRPr lang="en-US"/>
-          </a:p>
-          <a:p>
-            <a:pPr marL="152400" indent="-152400">
-              <a:spcAft>
-                <a:spcPts val="280"/>
-              </a:spcAft>
-              <a:buSzPct val="100000"/>
-              <a:buChar char="•"/>
-            </a:pPr>
-            <a:r>
-              <a:rPr sz="1750"/>
-              <a:t>Evaluator -&gt; gold + verifier outputs</a:t>
-            </a:r>
-            <a:endParaRPr lang="en-US"/>
-          </a:p>
-          <a:p>
-            <a:pPr marL="152400" indent="-152400">
-              <a:spcAft>
-                <a:spcPts val="280"/>
-              </a:spcAft>
-              <a:buSzPct val="100000"/>
-              <a:buChar char="•"/>
-            </a:pPr>
-            <a:r>
-              <a:rPr sz="1750"/>
-              <a:t>Verdict -&gt; valid / invalid / unidentifiable</a:t>
-            </a:r>
-            <a:endParaRPr lang="en-US"/>
-          </a:p>
-          <a:p>
-            <a:pPr marL="152400" indent="-152400">
-              <a:spcAft>
-                <a:spcPts val="280"/>
-              </a:spcAft>
-              <a:buSzPct val="100000"/>
-              <a:buChar char="•"/>
-            </a:pPr>
-            <a:r>
-              <a:rPr sz="1750"/>
-              <a:t>Extras -&gt; refusal reason + witness + evidence gap</a:t>
-            </a:r>
-            <a:endParaRPr lang="en-US"/>
-          </a:p>
-          <a:p>
-            <a:pPr marL="152400" indent="-152400">
-              <a:spcAft>
-                <a:spcPts val="280"/>
-              </a:spcAft>
-              <a:buSzPct val="100000"/>
-              <a:buChar char="•"/>
-            </a:pPr>
-            <a:r>
-              <a:rPr sz="1750"/>
-              <a:t>Leakage control -&gt; gold leaks should help the control</a:t>
-            </a:r>
-            <a:endParaRPr lang="en-US"/>
-          </a:p>
-          <a:p>
-            <a:pPr marL="152400" indent="-152400">
-              <a:spcAft>
-                <a:spcPts val="280"/>
-              </a:spcAft>
-              <a:buSzPct val="100000"/>
-              <a:buChar char="•"/>
-            </a:pPr>
-            <a:r>
-              <a:rPr sz="1750"/>
-              <a:t>OOD -&gt; family / mechanism / attack / context / paired-flip</a:t>
-            </a:r>
-            <a:endParaRPr lang="en-US"/>
-          </a:p>
-          <a:p>
-            <a:pPr marL="152400" indent="-152400">
-              <a:spcAft>
-                <a:spcPts val="280"/>
-              </a:spcAft>
-              <a:buSzPct val="100000"/>
-              <a:buChar char="•"/>
-            </a:pPr>
-            <a:r>
-              <a:rPr sz="1750"/>
-              <a:t>Budget -&gt; 3 x 10/family; Direct / CoT / Debate / Tool / Refusal-Aware / Ours</a:t>
-            </a:r>
-            <a:endParaRPr lang="en-US"/>
           </a:p>
         </p:txBody>
       </p:sp>
@@ -2018,25 +1813,16 @@
           <a:ln/>
         </p:spPr>
         <p:txBody>
-          <a:bodyPr wrap="square" lIns="1016" tIns="1016" rIns="1016" bIns="1016" rtlCol="0" anchor="t">
+          <a:bodyPr wrap="square" lIns="50800" tIns="1016" rIns="50800" bIns="1016" rtlCol="0" anchor="t">
             <a:spAutoFit/>
           </a:bodyPr>
           <a:lstStyle/>
           <a:p>
-            <a:pPr marL="0" indent="0" algn="l">
-              <a:lnSpc>
-                <a:spcPct val="108000"/>
-              </a:lnSpc>
-              <a:spcAft>
-                <a:spcPts val="300"/>
-              </a:spcAft>
-              <a:buNone/>
-            </a:pPr>
+            <a:pPr algn="l"/>
             <a:r>
-              <a:rPr sz="2000"/>
-              <a:t>The third label is essential. Pearl's hierarchy implies that layer-k evidence generically underdetermines layer-(k+1) truth, so some public-view claims must be refused with a structured reason.</a:t>
+              <a:rPr sz="1200"/>
+              <a:t>The third label is essential. Pearl's hierarchy implies that public observational evidence can underdetermine interventional or counterfactual truth, so some public-view causal claims must be refused with a structured reason.</a:t>
             </a:r>
-            <a:endParaRPr lang="en-US" sz="2400" dirty="0"/>
           </a:p>
         </p:txBody>
       </p:sp>
@@ -2206,51 +1992,16 @@
           <a:ln/>
         </p:spPr>
         <p:txBody>
-          <a:bodyPr wrap="square" lIns="381" tIns="381" rIns="381" bIns="381" rtlCol="0" anchor="ctr">
+          <a:bodyPr wrap="square" lIns="50800" tIns="381" rIns="50800" bIns="381" rtlCol="0" anchor="ctr">
             <a:spAutoFit/>
           </a:bodyPr>
           <a:lstStyle/>
           <a:p>
-            <a:pPr marL="152400" indent="-152400">
-              <a:spcAft>
-                <a:spcPts val="300"/>
-              </a:spcAft>
-              <a:buSzPct val="100000"/>
-              <a:buChar char="•"/>
-            </a:pPr>
+            <a:pPr algn="l"/>
             <a:r>
-              <a:rPr sz="1800"/>
-              <a:t>Guarantee: yes/no-only verifiers must fail on observationally equivalent cases</a:t>
+              <a:rPr sz="1200"/>
+              <a:t>Guarantee: yes/no-only verifiers must fail on observationally equivalent cases | Mechanism: countermodel + ledger separate invalid from unidentifiable | Output: refusal returns a reason plus a missing-information spec</a:t>
             </a:r>
-            <a:endParaRPr lang="en-US" sz="2400" dirty="0"/>
-          </a:p>
-          <a:p>
-            <a:pPr marL="152400" indent="-152400">
-              <a:spcAft>
-                <a:spcPts val="300"/>
-              </a:spcAft>
-              <a:buSzPct val="100000"/>
-              <a:buChar char="•"/>
-            </a:pPr>
-            <a:r>
-              <a:rPr sz="1800"/>
-              <a:t>Mechanism: countermodel + ledger separate invalid from unidentifiable</a:t>
-            </a:r>
-            <a:endParaRPr lang="en-US" sz="2400" dirty="0"/>
-          </a:p>
-          <a:p>
-            <a:pPr marL="152400" indent="-152400">
-              <a:spcAft>
-                <a:spcPts val="300"/>
-              </a:spcAft>
-              <a:buSzPct val="100000"/>
-              <a:buChar char="•"/>
-            </a:pPr>
-            <a:r>
-              <a:rPr sz="1800"/>
-              <a:t>Output: refusal returns a reason plus a missing-information spec</a:t>
-            </a:r>
-            <a:endParaRPr lang="en-US" sz="2400" dirty="0"/>
           </a:p>
         </p:txBody>
       </p:sp>
@@ -2505,19 +2256,15 @@
           <a:ln/>
         </p:spPr>
         <p:txBody>
-          <a:bodyPr wrap="square" lIns="1016" tIns="1016" rIns="1016" bIns="1016" rtlCol="0" anchor="t">
+          <a:bodyPr wrap="square" lIns="50800" tIns="1016" rIns="50800" bIns="1016" rtlCol="0" anchor="t">
             <a:spAutoFit/>
           </a:bodyPr>
           <a:lstStyle/>
           <a:p>
-            <a:pPr>
-              <a:spcAft>
-                <a:spcPts val="300"/>
-              </a:spcAft>
-            </a:pPr>
+            <a:pPr algn="l"/>
             <a:r>
-              <a:rPr sz="2000"/>
-              <a:t>Baselines solve different parts of the task. We compare them under the same public/gold contract and read performance through verdict accuracy, unsafe acceptance, and wise refusal.</a:t>
+              <a:rPr sz="1200"/>
+              <a:t>Exploratory fixed-code snapshot: 3 seeds x 10 samples/family, difficulty 0.55. Metrics should be read as contract/reference-verifier evidence, not as final benchmark-release evidence.</a:t>
             </a:r>
           </a:p>
         </p:txBody>
@@ -2647,51 +2394,16 @@
           <a:ln/>
         </p:spPr>
         <p:txBody>
-          <a:bodyPr wrap="square" lIns="381" tIns="381" rIns="381" bIns="381" rtlCol="0" anchor="ctr">
+          <a:bodyPr wrap="square" lIns="50800" tIns="381" rIns="50800" bIns="381" rtlCol="0" anchor="ctr">
             <a:spAutoFit/>
           </a:bodyPr>
           <a:lstStyle/>
           <a:p>
-            <a:pPr marL="152400" indent="-152400">
-              <a:spcAft>
-                <a:spcPts val="300"/>
-              </a:spcAft>
-              <a:buSzPct val="100000"/>
-              <a:buChar char="•"/>
-            </a:pPr>
+            <a:pPr algn="l"/>
             <a:r>
-              <a:rPr sz="1800"/>
-              <a:t>Ours: 0.83 / 0.85 with 0 unsafe acceptance</a:t>
+              <a:rPr sz="1200"/>
+              <a:t>Ours: IID/OOD accuracy 1.00 / 0.89 with 0 unsafe acceptance | Direct Judge: 0.50 / 0.16 and unsafe acceptance 0.89 / 0.97 | No-Abstention: high IID raw accuracy but 0 unidentifiable-awareness</a:t>
             </a:r>
-            <a:endParaRPr lang="en-US" sz="2400" dirty="0"/>
-          </a:p>
-          <a:p>
-            <a:pPr marL="152400" indent="-152400">
-              <a:spcAft>
-                <a:spcPts val="300"/>
-              </a:spcAft>
-              <a:buSzPct val="100000"/>
-              <a:buChar char="•"/>
-            </a:pPr>
-            <a:r>
-              <a:rPr sz="1800"/>
-              <a:t>Direct Judge: over-accepts under public evidence</a:t>
-            </a:r>
-            <a:endParaRPr lang="en-US" sz="2400" dirty="0"/>
-          </a:p>
-          <a:p>
-            <a:pPr marL="152400" indent="-152400">
-              <a:spcAft>
-                <a:spcPts val="300"/>
-              </a:spcAft>
-              <a:buSzPct val="100000"/>
-              <a:buChar char="•"/>
-            </a:pPr>
-            <a:r>
-              <a:rPr sz="1800"/>
-              <a:t>No-Abstention: removes wise refusal entirely</a:t>
-            </a:r>
-            <a:endParaRPr lang="en-US" sz="2400" dirty="0"/>
           </a:p>
         </p:txBody>
       </p:sp>
@@ -2898,37 +2610,16 @@
           <a:ln/>
         </p:spPr>
         <p:txBody>
-          <a:bodyPr wrap="square" lIns="381" tIns="381" rIns="381" bIns="381" rtlCol="0" anchor="ctr">
+          <a:bodyPr wrap="square" lIns="50800" tIns="381" rIns="50800" bIns="381" rtlCol="0" anchor="ctr">
             <a:noAutofit/>
           </a:bodyPr>
           <a:lstStyle/>
           <a:p>
-            <a:pPr marL="152400" indent="-152400">
-              <a:spcAft>
-                <a:spcPts val="300"/>
-              </a:spcAft>
-              <a:buSzPct val="100000"/>
-              <a:buChar char="•"/>
-            </a:pPr>
+            <a:pPr algn="l"/>
             <a:r>
-              <a:rPr sz="2000"/>
-              <a:t>Why third label matters: latent confounding leaves two public-compatible SCMs</a:t>
+              <a:rPr sz="1200"/>
+              <a:t>Why third label matters: latent confounding leaves two public-compatible SCMs | Output: counter-SCM disagrees on effect -&gt; UNIDENTIFIABLE + observational_equivalence</a:t>
             </a:r>
-            <a:endParaRPr lang="en-US" sz="2400" dirty="0"/>
-          </a:p>
-          <a:p>
-            <a:pPr marL="152400" indent="-152400">
-              <a:spcAft>
-                <a:spcPts val="300"/>
-              </a:spcAft>
-              <a:buSzPct val="100000"/>
-              <a:buChar char="•"/>
-            </a:pPr>
-            <a:r>
-              <a:rPr sz="2000"/>
-              <a:t>Output: counter-SCM disagrees on effect -&gt; UNIDENTIFIABLE + observational_equivalence</a:t>
-            </a:r>
-            <a:endParaRPr lang="en-US" sz="2400" dirty="0"/>
           </a:p>
         </p:txBody>
       </p:sp>
@@ -3025,37 +2716,16 @@
           <a:ln/>
         </p:spPr>
         <p:txBody>
-          <a:bodyPr wrap="square" lIns="381" tIns="381" rIns="381" bIns="381" rtlCol="0" anchor="ctr">
+          <a:bodyPr wrap="square" lIns="50800" tIns="381" rIns="50800" bIns="381" rtlCol="0" anchor="ctr">
             <a:noAutofit/>
           </a:bodyPr>
           <a:lstStyle/>
           <a:p>
-            <a:pPr marL="152400" indent="-152400">
-              <a:spcAft>
-                <a:spcPts val="300"/>
-              </a:spcAft>
-              <a:buSzPct val="100000"/>
-              <a:buChar char="•"/>
-            </a:pPr>
+            <a:pPr algn="l"/>
             <a:r>
-              <a:rPr sz="2000"/>
-              <a:t>Why partition matters: one gold-only field saturates the attack-only control</a:t>
+              <a:rPr sz="1200"/>
+              <a:t>Why partition matters: a protocol-violating leakage control reaches 1.00 / 1.00 | Clean public verifier: 0.58 / 0.84 | Effect: score inflation is contamination, not oversight ability</a:t>
             </a:r>
-            <a:endParaRPr lang="en-US" sz="2400" dirty="0"/>
-          </a:p>
-          <a:p>
-            <a:pPr marL="152400" indent="-152400">
-              <a:spcAft>
-                <a:spcPts val="300"/>
-              </a:spcAft>
-              <a:buSzPct val="100000"/>
-              <a:buChar char="•"/>
-            </a:pPr>
-            <a:r>
-              <a:rPr sz="2000"/>
-              <a:t>Effect: clean 0.81 / 0.88 -&gt; leak 1.00 / 1.00; contamination, not oversight</a:t>
-            </a:r>
-            <a:endParaRPr lang="en-US" sz="2400" dirty="0"/>
           </a:p>
         </p:txBody>
       </p:sp>
@@ -3142,8 +2812,9 @@
                     <a:bodyPr/>
                     <a:lstStyle/>
                     <a:p>
+                      <a:pPr algn="l"/>
                       <a:r>
-                        <a:rPr sz="1500" b="1"/>
+                        <a:rPr sz="1200" b="1"/>
                         <a:t>System</a:t>
                       </a:r>
                     </a:p>
@@ -3155,9 +2826,10 @@
                     <a:bodyPr/>
                     <a:lstStyle/>
                     <a:p>
+                      <a:pPr algn="ctr"/>
                       <a:r>
-                        <a:rPr sz="1500" b="1"/>
-                        <a:t>IID</a:t>
+                        <a:rPr sz="1200" b="1"/>
+                        <a:t>IID Acc</a:t>
                       </a:r>
                     </a:p>
                   </a:txBody>
@@ -3168,9 +2840,10 @@
                     <a:bodyPr/>
                     <a:lstStyle/>
                     <a:p>
+                      <a:pPr algn="ctr"/>
                       <a:r>
-                        <a:rPr sz="1500" b="1"/>
-                        <a:t>OOD</a:t>
+                        <a:rPr sz="1200" b="1"/>
+                        <a:t>OOD Acc</a:t>
                       </a:r>
                     </a:p>
                   </a:txBody>
@@ -3183,9 +2856,10 @@
                     <a:bodyPr/>
                     <a:lstStyle/>
                     <a:p>
+                      <a:pPr algn="l"/>
                       <a:r>
-                        <a:rPr sz="1500" b="1"/>
-                        <a:t>Countermodel-Grounded</a:t>
+                        <a:rPr sz="1200" b="1"/>
+                        <a:t>Ours</a:t>
                       </a:r>
                     </a:p>
                   </a:txBody>
@@ -3196,9 +2870,10 @@
                     <a:bodyPr/>
                     <a:lstStyle/>
                     <a:p>
+                      <a:pPr algn="ctr"/>
                       <a:r>
-                        <a:rPr sz="1500" b="1"/>
-                        <a:t>0.83</a:t>
+                        <a:rPr sz="1200" b="1"/>
+                        <a:t>1.00</a:t>
                       </a:r>
                     </a:p>
                   </a:txBody>
@@ -3209,9 +2884,10 @@
                     <a:bodyPr/>
                     <a:lstStyle/>
                     <a:p>
+                      <a:pPr algn="ctr"/>
                       <a:r>
-                        <a:rPr sz="1500" b="1"/>
-                        <a:t>0.85</a:t>
+                        <a:rPr sz="1200" b="1"/>
+                        <a:t>0.89</a:t>
                       </a:r>
                     </a:p>
                   </a:txBody>
@@ -3224,8 +2900,9 @@
                     <a:bodyPr/>
                     <a:lstStyle/>
                     <a:p>
+                      <a:pPr algn="l"/>
                       <a:r>
-                        <a:rPr sz="1500" b="0"/>
+                        <a:rPr sz="1200" b="0"/>
                         <a:t>Direct Judge</a:t>
                       </a:r>
                     </a:p>
@@ -3237,8 +2914,9 @@
                     <a:bodyPr/>
                     <a:lstStyle/>
                     <a:p>
+                      <a:pPr algn="ctr"/>
                       <a:r>
-                        <a:rPr sz="1500" b="0"/>
+                        <a:rPr sz="1200" b="0"/>
                         <a:t>0.50</a:t>
                       </a:r>
                     </a:p>
@@ -3250,8 +2928,9 @@
                     <a:bodyPr/>
                     <a:lstStyle/>
                     <a:p>
+                      <a:pPr algn="ctr"/>
                       <a:r>
-                        <a:rPr sz="1500" b="0"/>
+                        <a:rPr sz="1200" b="0"/>
                         <a:t>0.16</a:t>
                       </a:r>
                     </a:p>
@@ -3265,8 +2944,9 @@
                     <a:bodyPr/>
                     <a:lstStyle/>
                     <a:p>
+                      <a:pPr algn="l"/>
                       <a:r>
-                        <a:rPr sz="1500" b="0"/>
+                        <a:rPr sz="1200" b="0"/>
                         <a:t>CoT Judge</a:t>
                       </a:r>
                     </a:p>
@@ -3278,9 +2958,10 @@
                     <a:bodyPr/>
                     <a:lstStyle/>
                     <a:p>
+                      <a:pPr algn="ctr"/>
                       <a:r>
-                        <a:rPr sz="1500" b="0"/>
-                        <a:t>0.29</a:t>
+                        <a:rPr sz="1200" b="0"/>
+                        <a:t>0.32</a:t>
                       </a:r>
                     </a:p>
                   </a:txBody>
@@ -3291,9 +2972,10 @@
                     <a:bodyPr/>
                     <a:lstStyle/>
                     <a:p>
+                      <a:pPr algn="ctr"/>
                       <a:r>
-                        <a:rPr sz="1500" b="0"/>
-                        <a:t>0.57</a:t>
+                        <a:rPr sz="1200" b="0"/>
+                        <a:t>0.59</a:t>
                       </a:r>
                     </a:p>
                   </a:txBody>
@@ -3306,8 +2988,9 @@
                     <a:bodyPr/>
                     <a:lstStyle/>
                     <a:p>
+                      <a:pPr algn="l"/>
                       <a:r>
-                        <a:rPr sz="1500" b="0"/>
+                        <a:rPr sz="1200" b="0"/>
                         <a:t>Tool Baseline</a:t>
                       </a:r>
                     </a:p>
@@ -3319,8 +3002,9 @@
                     <a:bodyPr/>
                     <a:lstStyle/>
                     <a:p>
+                      <a:pPr algn="ctr"/>
                       <a:r>
-                        <a:rPr sz="1500" b="0"/>
+                        <a:rPr sz="1200" b="0"/>
                         <a:t>0.54</a:t>
                       </a:r>
                     </a:p>
@@ -3332,9 +3016,10 @@
                     <a:bodyPr/>
                     <a:lstStyle/>
                     <a:p>
+                      <a:pPr algn="ctr"/>
                       <a:r>
-                        <a:rPr sz="1500" b="0"/>
-                        <a:t>0.36</a:t>
+                        <a:rPr sz="1200" b="0"/>
+                        <a:t>0.35</a:t>
                       </a:r>
                     </a:p>
                   </a:txBody>
@@ -3347,8 +3032,9 @@
                     <a:bodyPr/>
                     <a:lstStyle/>
                     <a:p>
+                      <a:pPr algn="l"/>
                       <a:r>
-                        <a:rPr sz="1500" b="0"/>
+                        <a:rPr sz="1200" b="0"/>
                         <a:t>Refusal-Aware</a:t>
                       </a:r>
                     </a:p>
@@ -3360,9 +3046,10 @@
                     <a:bodyPr/>
                     <a:lstStyle/>
                     <a:p>
+                      <a:pPr algn="ctr"/>
                       <a:r>
-                        <a:rPr sz="1500" b="0"/>
-                        <a:t>0.61</a:t>
+                        <a:rPr sz="1200" b="0"/>
+                        <a:t>0.75</a:t>
                       </a:r>
                     </a:p>
                   </a:txBody>
@@ -3373,9 +3060,10 @@
                     <a:bodyPr/>
                     <a:lstStyle/>
                     <a:p>
+                      <a:pPr algn="ctr"/>
                       <a:r>
-                        <a:rPr sz="1500" b="0"/>
-                        <a:t>0.47</a:t>
+                        <a:rPr sz="1200" b="0"/>
+                        <a:t>0.50</a:t>
                       </a:r>
                     </a:p>
                   </a:txBody>
@@ -3412,14 +3100,14 @@
       </p:pic>
       <p:pic>
         <p:nvPicPr>
-          <p:cNvPr id="85" name="Picture 84" descr="image.png"/>
+          <p:cNvPr id="87" name="Picture 86" descr="ablation_chart.png"/>
           <p:cNvPicPr>
             <a:picLocks noChangeAspect="1"/>
           </p:cNvPicPr>
           <p:nvPr/>
         </p:nvPicPr>
         <p:blipFill>
-          <a:blip r:embed="rId6"/>
+          <a:blip r:embed="rId8"/>
           <a:stretch>
             <a:fillRect/>
           </a:stretch>
@@ -3436,14 +3124,14 @@
       </p:pic>
       <p:pic>
         <p:nvPicPr>
-          <p:cNvPr id="86" name="Picture 85" descr="image.png"/>
+          <p:cNvPr id="88" name="Picture 87" descr="ood_chart.png"/>
           <p:cNvPicPr>
             <a:picLocks noChangeAspect="1"/>
           </p:cNvPicPr>
           <p:nvPr/>
         </p:nvPicPr>
         <p:blipFill>
-          <a:blip r:embed="rId7"/>
+          <a:blip r:embed="rId9"/>
           <a:stretch>
             <a:fillRect/>
           </a:stretch>

</xml_diff>

<commit_message>
modified:   experiments/paper_artifacts.py 	modified:   poster/icml2026/example_paper.pdf 	modified:   poster/icml2026/example_paper.tex 	modified:   poster/poster_template.pdf 	modified:   poster/poster_template.pptx 	modified:   tests/test_paper_artifacts.py
</commit_message>
<xml_diff>
--- a/poster/poster_template.pptx
+++ b/poster/poster_template.pptx
@@ -3894,7 +3894,7 @@
               </a:defRPr>
             </a:pPr>
             <a:r>
-              <a:t>Direct Judge: OOD acc 0.161, unsafe accept 0.970.</a:t>
+              <a:t>Best strong LLM: GPT-5.5 OOD acc 0.545, unsafe accept 0.071.</a:t>
             </a:r>
           </a:p>
           <a:p>
@@ -3910,7 +3910,7 @@
               </a:defRPr>
             </a:pPr>
             <a:r>
-              <a:t>Interpretation: the main signal is the accuracy/refusal tradeoff, not a final benchmark claim.</a:t>
+              <a:t>Interpretation: public-view LLM judges still miss the benchmark's selective-refusal contract.</a:t>
             </a:r>
           </a:p>
         </p:txBody>
@@ -4344,7 +4344,7 @@
               </a:defRPr>
             </a:pPr>
             <a:r>
-              <a:t>API smoke: qwen2.5-7b, IID n=9/OOD n=12, raw response, fallback=0; full matrix pending.</a:t>
+              <a:t>LLM matrix: 5 models, n=1245, failed=0, parse=0, fallback=0; best OOD GPT-5.5 acc=0.545, unsafe=0.071.</a:t>
             </a:r>
           </a:p>
           <a:p>
@@ -4395,7 +4395,7 @@
                 </a:solidFill>
                 <a:latin typeface="Aptos"/>
               </a:rPr>
-              <a:t>Manifest: outputs/paper_facing/manifest.json | API smoke: 2026-05-07T16:51:48Z | Poster generated from frozen JSON artifacts</a:t>
+              <a:t>Manifest: outputs/paper_facing/manifest.json | LLM matrix: full_llm_baseline_matrix_completed | Poster generated from frozen JSON artifacts</a:t>
             </a:r>
           </a:p>
         </p:txBody>

</xml_diff>

<commit_message>
modified:   .gitignore 	modified:   poster/ablation_chart.png 	new file:   poster/build_poster.py 	modified:   poster/icml2026/example_paper.pdf 	modified:   poster/icml2026/example_paper.tex 	modified:   poster/main_chart.png 	modified:   poster/ood_chart.png 	modified:   poster/poster_template.pdf 	modified:   poster/poster_template.pptx
</commit_message>
<xml_diff>
--- a/poster/poster_template.pptx
+++ b/poster/poster_template.pptx
@@ -3202,7 +3202,7 @@
                 </a:solidFill>
                 <a:latin typeface="Aptos"/>
               </a:rPr>
-              <a:t>Information-partitioned benchmark contract + countermodel-grounded verifier</a:t>
+              <a:t>Benchmark prototype + countermodel-grounded reference verifier</a:t>
             </a:r>
           </a:p>
         </p:txBody>
@@ -3272,7 +3272,7 @@
                 </a:solidFill>
                 <a:latin typeface="Aptos"/>
               </a:rPr>
-              <a:t>Fixed-code exploratory snapshot | seeds=[0, 1, 2] | 10 samples/family | difficulty=0.55 | error bars: 95% CI over seed means</a:t>
+              <a:t>Exploratory snapshot | seeds=[0, 1, 2] | 10/family | diff=0.55 | 95% CI where shown</a:t>
             </a:r>
           </a:p>
         </p:txBody>
@@ -3894,7 +3894,7 @@
               </a:defRPr>
             </a:pPr>
             <a:r>
-              <a:t>Best strong LLM: GPT-5.5 OOD acc 0.545, unsafe accept 0.071.</a:t>
+              <a:t>GPT-5.5 prompt baseline: OOD acc 0.545, unsafe accept 0.071.</a:t>
             </a:r>
           </a:p>
           <a:p>
@@ -3910,7 +3910,7 @@
               </a:defRPr>
             </a:pPr>
             <a:r>
-              <a:t>Interpretation: public-view LLM judges still miss the benchmark's selective-refusal contract.</a:t>
+              <a:t>Interpretation: current prompt baselines expose the selective-refusal gap.</a:t>
             </a:r>
           </a:p>
         </p:txBody>
@@ -4167,7 +4167,7 @@
               </a:defRPr>
             </a:pPr>
             <a:r>
-              <a:t>Graph/mechanism buckets are saturated in this small snapshot.</a:t>
+              <a:t>Graph/mechanism buckets are saturated smoke tests, not headline robustness evidence.</a:t>
             </a:r>
           </a:p>
         </p:txBody>
@@ -4320,7 +4320,7 @@
               <a:spcAft>
                 <a:spcPts val="400"/>
               </a:spcAft>
-              <a:defRPr sz="900">
+              <a:defRPr sz="800">
                 <a:solidFill>
                   <a:srgbClr val="1F2328"/>
                 </a:solidFill>
@@ -4336,7 +4336,7 @@
               <a:spcAft>
                 <a:spcPts val="400"/>
               </a:spcAft>
-              <a:defRPr sz="900">
+              <a:defRPr sz="800">
                 <a:solidFill>
                   <a:srgbClr val="1F2328"/>
                 </a:solidFill>
@@ -4352,7 +4352,7 @@
               <a:spcAft>
                 <a:spcPts val="400"/>
               </a:spcAft>
-              <a:defRPr sz="900">
+              <a:defRPr sz="800">
                 <a:solidFill>
                   <a:srgbClr val="1F2328"/>
                 </a:solidFill>
@@ -4360,7 +4360,23 @@
               </a:defRPr>
             </a:pPr>
             <a:r>
-              <a:t>Human audit: dual annotation pending; no real-grounded headline.</a:t>
+              <a:t>Release gates: larger synthetic runs, real-grounded dual audit, frozen model versions.</a:t>
+            </a:r>
+          </a:p>
+          <a:p>
+            <a:pPr>
+              <a:spcAft>
+                <a:spcPts val="400"/>
+              </a:spcAft>
+              <a:defRPr sz="800">
+                <a:solidFill>
+                  <a:srgbClr val="1F2328"/>
+                </a:solidFill>
+                <a:latin typeface="Aptos"/>
+              </a:defRPr>
+            </a:pPr>
+            <a:r>
+              <a:t>Current status: prototype evidence, not a mature benchmark release.</a:t>
             </a:r>
           </a:p>
         </p:txBody>

</xml_diff>

<commit_message>
modified:   poster/ablation_chart.png 	modified:   poster/build_poster.py 	modified:   poster/main_chart.png 	modified:   poster/ood_chart.png 	modified:   poster/poster_template.pdf 	modified:   poster/poster_template.pptx 	new file:   "poster/poster\345\217\202\350\200\203\346\250\241\346\235\277.pptx" 	new file:   poster/zju_template_logo.png
</commit_message>
<xml_diff>
--- a/poster/poster_template.pptx
+++ b/poster/poster_template.pptx
@@ -7,7 +7,7 @@
   <p:sldIdLst>
     <p:sldId id="256" r:id="rId7"/>
   </p:sldIdLst>
-  <p:sldSz cx="14630400" cy="8229600" type="screen4x3"/>
+  <p:sldSz cx="34564320" cy="25923240" type="screen4x3"/>
   <p:notesSz cx="6858000" cy="9144000"/>
   <p:defaultTextStyle>
     <a:defPPr>
@@ -3084,7 +3084,7 @@
     <p:bg>
       <p:bgPr>
         <a:solidFill>
-          <a:srgbClr val="FFFFFF"/>
+          <a:srgbClr val="F7F9FC"/>
         </a:solidFill>
         <a:effectLst/>
       </p:bgPr>
@@ -3105,13 +3105,13 @@
         <p:spPr>
           <a:xfrm>
             <a:off x="0" y="0"/>
-            <a:ext cx="14630400" cy="749808"/>
+            <a:ext cx="34564320" cy="832104"/>
           </a:xfrm>
           <a:prstGeom prst="rect">
             <a:avLst/>
           </a:prstGeom>
           <a:solidFill>
-            <a:srgbClr val="F5F8FC"/>
+            <a:srgbClr val="163B6C"/>
           </a:solidFill>
           <a:ln>
             <a:noFill/>
@@ -3141,192 +3141,20 @@
       </p:sp>
       <p:sp>
         <p:nvSpPr>
-          <p:cNvPr id="3" name="TextBox 2"/>
-          <p:cNvSpPr txBox="1"/>
-          <p:nvPr/>
-        </p:nvSpPr>
-        <p:spPr>
-          <a:xfrm>
-            <a:off x="411480" y="109728"/>
-            <a:ext cx="7955279" cy="347472"/>
+          <p:cNvPr id="3" name="Rectangle 2"/>
+          <p:cNvSpPr/>
+          <p:nvPr/>
+        </p:nvSpPr>
+        <p:spPr>
+          <a:xfrm>
+            <a:off x="0" y="25447752"/>
+            <a:ext cx="34564320" cy="466344"/>
           </a:xfrm>
           <a:prstGeom prst="rect">
             <a:avLst/>
           </a:prstGeom>
-          <a:noFill/>
-        </p:spPr>
-        <p:txBody>
-          <a:bodyPr wrap="none" lIns="36576" rIns="36576" tIns="18288" bIns="18288" anchor="t">
-            <a:spAutoFit/>
-          </a:bodyPr>
-          <a:lstStyle/>
-          <a:p>
-            <a:r>
-              <a:rPr sz="2700" b="1">
-                <a:solidFill>
-                  <a:srgbClr val="1F2328"/>
-                </a:solidFill>
-                <a:latin typeface="Aptos"/>
-              </a:rPr>
-              <a:t>Selective Adversarial Causal Oversight</a:t>
-            </a:r>
-          </a:p>
-        </p:txBody>
-      </p:sp>
-      <p:sp>
-        <p:nvSpPr>
-          <p:cNvPr id="4" name="TextBox 3"/>
-          <p:cNvSpPr txBox="1"/>
-          <p:nvPr/>
-        </p:nvSpPr>
-        <p:spPr>
-          <a:xfrm>
-            <a:off x="438912" y="475488"/>
-            <a:ext cx="7955279" cy="219456"/>
-          </a:xfrm>
-          <a:prstGeom prst="rect">
-            <a:avLst/>
-          </a:prstGeom>
-          <a:noFill/>
-        </p:spPr>
-        <p:txBody>
-          <a:bodyPr wrap="none" lIns="36576" rIns="36576" tIns="18288" bIns="18288" anchor="t">
-            <a:spAutoFit/>
-          </a:bodyPr>
-          <a:lstStyle/>
-          <a:p>
-            <a:r>
-              <a:rPr sz="1300" b="0">
-                <a:solidFill>
-                  <a:srgbClr val="5B636E"/>
-                </a:solidFill>
-                <a:latin typeface="Aptos"/>
-              </a:rPr>
-              <a:t>Benchmark prototype + countermodel-grounded reference verifier</a:t>
-            </a:r>
-          </a:p>
-        </p:txBody>
-      </p:sp>
-      <p:sp>
-        <p:nvSpPr>
-          <p:cNvPr id="5" name="TextBox 4"/>
-          <p:cNvSpPr txBox="1"/>
-          <p:nvPr/>
-        </p:nvSpPr>
-        <p:spPr>
-          <a:xfrm>
-            <a:off x="9601200" y="164592"/>
-            <a:ext cx="4480560" cy="219456"/>
-          </a:xfrm>
-          <a:prstGeom prst="rect">
-            <a:avLst/>
-          </a:prstGeom>
-          <a:noFill/>
-        </p:spPr>
-        <p:txBody>
-          <a:bodyPr wrap="none" lIns="36576" rIns="36576" tIns="18288" bIns="18288" anchor="t">
-            <a:spAutoFit/>
-          </a:bodyPr>
-          <a:lstStyle/>
-          <a:p>
-            <a:pPr algn="r"/>
-            <a:r>
-              <a:rPr sz="1200" b="0">
-                <a:solidFill>
-                  <a:srgbClr val="1F2328"/>
-                </a:solidFill>
-                <a:latin typeface="Aptos"/>
-              </a:rPr>
-              <a:t>Jingbei Niu   Zeyuan Tong   Yuhang Li | Zhejiang University</a:t>
-            </a:r>
-          </a:p>
-        </p:txBody>
-      </p:sp>
-      <p:sp>
-        <p:nvSpPr>
-          <p:cNvPr id="6" name="TextBox 5"/>
-          <p:cNvSpPr txBox="1"/>
-          <p:nvPr/>
-        </p:nvSpPr>
-        <p:spPr>
-          <a:xfrm>
-            <a:off x="8046720" y="475488"/>
-            <a:ext cx="6035040" cy="201168"/>
-          </a:xfrm>
-          <a:prstGeom prst="rect">
-            <a:avLst/>
-          </a:prstGeom>
-          <a:noFill/>
-        </p:spPr>
-        <p:txBody>
-          <a:bodyPr wrap="none" lIns="36576" rIns="36576" tIns="18288" bIns="18288" anchor="t">
-            <a:spAutoFit/>
-          </a:bodyPr>
-          <a:lstStyle/>
-          <a:p>
-            <a:pPr algn="r"/>
-            <a:r>
-              <a:rPr sz="900" b="0">
-                <a:solidFill>
-                  <a:srgbClr val="5B636E"/>
-                </a:solidFill>
-                <a:latin typeface="Aptos"/>
-              </a:rPr>
-              <a:t>Exploratory snapshot | seeds=[0, 1, 2] | 10/family | diff=0.55 | 95% CI where shown</a:t>
-            </a:r>
-          </a:p>
-        </p:txBody>
-      </p:sp>
-      <p:sp>
-        <p:nvSpPr>
-          <p:cNvPr id="7" name="TextBox 6"/>
-          <p:cNvSpPr txBox="1"/>
-          <p:nvPr/>
-        </p:nvSpPr>
-        <p:spPr>
-          <a:xfrm>
-            <a:off x="411480" y="960120"/>
-            <a:ext cx="4251960" cy="228600"/>
-          </a:xfrm>
-          <a:prstGeom prst="rect">
-            <a:avLst/>
-          </a:prstGeom>
-          <a:noFill/>
-        </p:spPr>
-        <p:txBody>
-          <a:bodyPr wrap="none" lIns="36576" rIns="36576" tIns="18288" bIns="18288" anchor="t">
-            <a:spAutoFit/>
-          </a:bodyPr>
-          <a:lstStyle/>
-          <a:p>
-            <a:r>
-              <a:rPr sz="1600" b="1">
-                <a:solidFill>
-                  <a:srgbClr val="145388"/>
-                </a:solidFill>
-                <a:latin typeface="Aptos"/>
-              </a:rPr>
-              <a:t>Task &amp; Contract</a:t>
-            </a:r>
-          </a:p>
-        </p:txBody>
-      </p:sp>
-      <p:sp>
-        <p:nvSpPr>
-          <p:cNvPr id="8" name="Rectangle 7"/>
-          <p:cNvSpPr/>
-          <p:nvPr/>
-        </p:nvSpPr>
-        <p:spPr>
-          <a:xfrm>
-            <a:off x="411480" y="1216152"/>
-            <a:ext cx="4251960" cy="13716"/>
-          </a:xfrm>
-          <a:prstGeom prst="rect">
-            <a:avLst/>
-          </a:prstGeom>
           <a:solidFill>
-            <a:srgbClr val="145388"/>
+            <a:srgbClr val="163B6C"/>
           </a:solidFill>
           <a:ln>
             <a:noFill/>
@@ -3356,109 +3184,24 @@
       </p:sp>
       <p:sp>
         <p:nvSpPr>
-          <p:cNvPr id="9" name="TextBox 8"/>
-          <p:cNvSpPr txBox="1"/>
-          <p:nvPr/>
-        </p:nvSpPr>
-        <p:spPr>
-          <a:xfrm>
-            <a:off x="411480" y="1325880"/>
-            <a:ext cx="4069080" cy="914400"/>
-          </a:xfrm>
-          <a:prstGeom prst="rect">
-            <a:avLst/>
-          </a:prstGeom>
-          <a:noFill/>
-        </p:spPr>
-        <p:txBody>
-          <a:bodyPr wrap="none" lIns="45720" rIns="45720" tIns="18288">
-            <a:spAutoFit/>
-          </a:bodyPr>
-          <a:lstStyle/>
-          <a:p>
-            <a:pPr>
-              <a:spcAft>
-                <a:spcPts val="400"/>
-              </a:spcAft>
-              <a:defRPr sz="1300">
-                <a:solidFill>
-                  <a:srgbClr val="1F2328"/>
-                </a:solidFill>
-                <a:latin typeface="Aptos"/>
-              </a:defRPr>
-            </a:pPr>
-            <a:r>
-              <a:t>Verifier sees public scenario + claim only.</a:t>
-            </a:r>
-          </a:p>
-          <a:p>
-            <a:pPr>
-              <a:spcAft>
-                <a:spcPts val="400"/>
-              </a:spcAft>
-              <a:defRPr sz="1300">
-                <a:solidFill>
-                  <a:srgbClr val="1F2328"/>
-                </a:solidFill>
-                <a:latin typeface="Aptos"/>
-              </a:defRPr>
-            </a:pPr>
-            <a:r>
-              <a:t>Gold SCM, labels, hidden variables stay evaluator-only.</a:t>
-            </a:r>
-          </a:p>
-          <a:p>
-            <a:pPr>
-              <a:spcAft>
-                <a:spcPts val="400"/>
-              </a:spcAft>
-              <a:defRPr sz="1300">
-                <a:solidFill>
-                  <a:srgbClr val="1F2328"/>
-                </a:solidFill>
-                <a:latin typeface="Aptos"/>
-              </a:defRPr>
-            </a:pPr>
-            <a:r>
-              <a:t>Verdict space: VALID / INVALID / UNIDENTIFIABLE.</a:t>
-            </a:r>
-          </a:p>
-          <a:p>
-            <a:pPr>
-              <a:spcAft>
-                <a:spcPts val="400"/>
-              </a:spcAft>
-              <a:defRPr sz="1300">
-                <a:solidFill>
-                  <a:srgbClr val="1F2328"/>
-                </a:solidFill>
-                <a:latin typeface="Aptos"/>
-              </a:defRPr>
-            </a:pPr>
-            <a:r>
-              <a:t>Score includes unsafe acceptance and wise refusal.</a:t>
-            </a:r>
-          </a:p>
-        </p:txBody>
-      </p:sp>
-      <p:sp>
-        <p:nvSpPr>
-          <p:cNvPr id="10" name="Rounded Rectangle 9"/>
+          <p:cNvPr id="4" name="Rounded Rectangle 3"/>
           <p:cNvSpPr/>
           <p:nvPr/>
         </p:nvSpPr>
         <p:spPr>
           <a:xfrm>
-            <a:off x="411480" y="2331720"/>
-            <a:ext cx="4251960" cy="1234440"/>
+            <a:off x="795528" y="832104"/>
+            <a:ext cx="32973264" cy="2807208"/>
           </a:xfrm>
           <a:prstGeom prst="roundRect">
-            <a:avLst/>
+            <a:avLst>
+              <a:gd name="adj" fmla="val 4000"/>
+            </a:avLst>
           </a:prstGeom>
           <a:solidFill>
-            <a:srgbClr val="FAFCFF"/>
+            <a:srgbClr val="FFFFFF"/>
           </a:solidFill>
-          <a:ln w="9525">
+          <a:ln w="10160">
             <a:solidFill>
               <a:srgbClr val="D2D8E0"/>
             </a:solidFill>
@@ -3488,14 +3231,14 @@
       </p:sp>
       <p:sp>
         <p:nvSpPr>
-          <p:cNvPr id="11" name="TextBox 10"/>
+          <p:cNvPr id="5" name="TextBox 4"/>
           <p:cNvSpPr txBox="1"/>
           <p:nvPr/>
         </p:nvSpPr>
         <p:spPr>
           <a:xfrm>
-            <a:off x="594360" y="2487168"/>
-            <a:ext cx="1554480" cy="201168"/>
+            <a:off x="1188720" y="1078992"/>
+            <a:ext cx="25603200" cy="822960"/>
           </a:xfrm>
           <a:prstGeom prst="rect">
             <a:avLst/>
@@ -3503,33 +3246,33 @@
           <a:noFill/>
         </p:spPr>
         <p:txBody>
-          <a:bodyPr wrap="none" lIns="36576" rIns="36576" tIns="18288" bIns="18288" anchor="t">
+          <a:bodyPr wrap="square" lIns="36576" rIns="36576" tIns="18288" bIns="18288" anchor="t">
             <a:spAutoFit/>
           </a:bodyPr>
           <a:lstStyle/>
           <a:p>
             <a:r>
-              <a:rPr sz="1300" b="1">
-                <a:solidFill>
-                  <a:srgbClr val="145388"/>
+              <a:rPr sz="4400" b="1">
+                <a:solidFill>
+                  <a:srgbClr val="163B6C"/>
                 </a:solidFill>
                 <a:latin typeface="Aptos"/>
               </a:rPr>
-              <a:t>Generated Case</a:t>
-            </a:r>
-          </a:p>
-        </p:txBody>
-      </p:sp>
-      <p:sp>
-        <p:nvSpPr>
-          <p:cNvPr id="12" name="TextBox 11"/>
+              <a:t>Selective Adversarial Causal Oversight</a:t>
+            </a:r>
+          </a:p>
+        </p:txBody>
+      </p:sp>
+      <p:sp>
+        <p:nvSpPr>
+          <p:cNvPr id="6" name="TextBox 5"/>
           <p:cNvSpPr txBox="1"/>
           <p:nvPr/>
         </p:nvSpPr>
         <p:spPr>
           <a:xfrm>
-            <a:off x="594360" y="2743200"/>
-            <a:ext cx="3886200" cy="658368"/>
+            <a:off x="1234440" y="1956816"/>
+            <a:ext cx="24688800" cy="320040"/>
           </a:xfrm>
           <a:prstGeom prst="rect">
             <a:avLst/>
@@ -3537,34 +3280,33 @@
           <a:noFill/>
         </p:spPr>
         <p:txBody>
-          <a:bodyPr wrap="none" lIns="36576" rIns="36576" tIns="18288" bIns="18288" anchor="t">
+          <a:bodyPr wrap="square" lIns="36576" rIns="36576" tIns="18288" bIns="18288" anchor="t">
             <a:spAutoFit/>
           </a:bodyPr>
           <a:lstStyle/>
           <a:p>
             <a:r>
-              <a:rPr sz="1100" b="0">
+              <a:rPr sz="2200" b="1">
                 <a:solidFill>
                   <a:srgbClr val="1F2328"/>
                 </a:solidFill>
                 <a:latin typeface="Aptos"/>
               </a:rPr>
-              <a:t>Claim: observed association between therapy_flag and yield_score is enough for a causal conclusion.
-Correct label: UNIDENTIFIABLE, because public evidence leaves reverse causality/confounding open.</a:t>
-            </a:r>
-          </a:p>
-        </p:txBody>
-      </p:sp>
-      <p:sp>
-        <p:nvSpPr>
-          <p:cNvPr id="13" name="TextBox 12"/>
+              <a:t>Benchmark prototype + countermodel-grounded reference verifier for selective causal refusal</a:t>
+            </a:r>
+          </a:p>
+        </p:txBody>
+      </p:sp>
+      <p:sp>
+        <p:nvSpPr>
+          <p:cNvPr id="7" name="TextBox 6"/>
           <p:cNvSpPr txBox="1"/>
           <p:nvPr/>
         </p:nvSpPr>
         <p:spPr>
           <a:xfrm>
-            <a:off x="411480" y="3840480"/>
-            <a:ext cx="4251960" cy="228600"/>
+            <a:off x="1234440" y="2377440"/>
+            <a:ext cx="17830800" cy="320040"/>
           </a:xfrm>
           <a:prstGeom prst="rect">
             <a:avLst/>
@@ -3572,76 +3314,67 @@
           <a:noFill/>
         </p:spPr>
         <p:txBody>
-          <a:bodyPr wrap="none" lIns="36576" rIns="36576" tIns="18288" bIns="18288" anchor="t">
+          <a:bodyPr wrap="square" lIns="36576" rIns="36576" tIns="18288" bIns="18288" anchor="t">
             <a:spAutoFit/>
           </a:bodyPr>
           <a:lstStyle/>
           <a:p>
             <a:r>
-              <a:rPr sz="1600" b="1">
-                <a:solidFill>
-                  <a:srgbClr val="145388"/>
+              <a:rPr sz="1800" b="1">
+                <a:solidFill>
+                  <a:srgbClr val="1F2328"/>
                 </a:solidFill>
                 <a:latin typeface="Aptos"/>
               </a:rPr>
-              <a:t>Reference Verifier</a:t>
-            </a:r>
-          </a:p>
-        </p:txBody>
-      </p:sp>
-      <p:sp>
-        <p:nvSpPr>
-          <p:cNvPr id="14" name="Rectangle 13"/>
-          <p:cNvSpPr/>
-          <p:nvPr/>
-        </p:nvSpPr>
-        <p:spPr>
-          <a:xfrm>
-            <a:off x="411480" y="4096512"/>
-            <a:ext cx="4251960" cy="13716"/>
+              <a:t>Jingbei Niu  •  Zeyuan Tong  •  Yuhang Li</a:t>
+            </a:r>
+          </a:p>
+        </p:txBody>
+      </p:sp>
+      <p:sp>
+        <p:nvSpPr>
+          <p:cNvPr id="8" name="TextBox 7"/>
+          <p:cNvSpPr txBox="1"/>
+          <p:nvPr/>
+        </p:nvSpPr>
+        <p:spPr>
+          <a:xfrm>
+            <a:off x="1234440" y="2743200"/>
+            <a:ext cx="18745200" cy="283464"/>
           </a:xfrm>
           <a:prstGeom prst="rect">
             <a:avLst/>
           </a:prstGeom>
-          <a:solidFill>
-            <a:srgbClr val="145388"/>
-          </a:solidFill>
-          <a:ln>
-            <a:noFill/>
-          </a:ln>
-        </p:spPr>
-        <p:style>
-          <a:lnRef idx="1">
-            <a:schemeClr val="accent1"/>
-          </a:lnRef>
-          <a:fillRef idx="3">
-            <a:schemeClr val="accent1"/>
-          </a:fillRef>
-          <a:effectRef idx="2">
-            <a:schemeClr val="accent1"/>
-          </a:effectRef>
-          <a:fontRef idx="minor">
-            <a:schemeClr val="lt1"/>
-          </a:fontRef>
-        </p:style>
-        <p:txBody>
-          <a:bodyPr rtlCol="0" anchor="ctr"/>
-          <a:lstStyle/>
-          <a:p>
-            <a:pPr algn="ctr"/>
-          </a:p>
-        </p:txBody>
-      </p:sp>
-      <p:sp>
-        <p:nvSpPr>
-          <p:cNvPr id="15" name="TextBox 14"/>
+          <a:noFill/>
+        </p:spPr>
+        <p:txBody>
+          <a:bodyPr wrap="square" lIns="36576" rIns="36576" tIns="18288" bIns="18288" anchor="t">
+            <a:spAutoFit/>
+          </a:bodyPr>
+          <a:lstStyle/>
+          <a:p>
+            <a:r>
+              <a:rPr sz="1500" b="0">
+                <a:solidFill>
+                  <a:srgbClr val="5B636E"/>
+                </a:solidFill>
+                <a:latin typeface="Aptos"/>
+              </a:rPr>
+              <a:t>Zhejiang University, College of Computer Science and Technology</a:t>
+            </a:r>
+          </a:p>
+        </p:txBody>
+      </p:sp>
+      <p:sp>
+        <p:nvSpPr>
+          <p:cNvPr id="9" name="TextBox 8"/>
           <p:cNvSpPr txBox="1"/>
           <p:nvPr/>
         </p:nvSpPr>
         <p:spPr>
           <a:xfrm>
-            <a:off x="411480" y="4206240"/>
-            <a:ext cx="4160520" cy="960120"/>
+            <a:off x="1234440" y="3044952"/>
+            <a:ext cx="14630400" cy="237744"/>
           </a:xfrm>
           <a:prstGeom prst="rect">
             <a:avLst/>
@@ -3649,79 +3382,26 @@
           <a:noFill/>
         </p:spPr>
         <p:txBody>
-          <a:bodyPr wrap="none" lIns="45720" rIns="45720" tIns="18288">
+          <a:bodyPr wrap="square" lIns="36576" rIns="36576" tIns="18288" bIns="18288" anchor="t">
             <a:spAutoFit/>
           </a:bodyPr>
           <a:lstStyle/>
           <a:p>
-            <a:pPr>
-              <a:spcAft>
-                <a:spcPts val="400"/>
-              </a:spcAft>
-              <a:defRPr sz="1300">
-                <a:solidFill>
-                  <a:srgbClr val="1F2328"/>
+            <a:r>
+              <a:rPr sz="1300" b="0">
+                <a:solidFill>
+                  <a:srgbClr val="2060B4"/>
                 </a:solidFill>
                 <a:latin typeface="Aptos"/>
-              </a:defRPr>
-            </a:pPr>
-            <a:r>
-              <a:t>Parse claim -&gt; build identifying-assumption ledger.</a:t>
-            </a:r>
-          </a:p>
-          <a:p>
-            <a:pPr>
-              <a:spcAft>
-                <a:spcPts val="400"/>
-              </a:spcAft>
-              <a:defRPr sz="1300">
-                <a:solidFill>
-                  <a:srgbClr val="1F2328"/>
-                </a:solidFill>
-                <a:latin typeface="Aptos"/>
-              </a:defRPr>
-            </a:pPr>
-            <a:r>
-              <a:t>Search public-compatible counter-SCMs.</a:t>
-            </a:r>
-          </a:p>
-          <a:p>
-            <a:pPr>
-              <a:spcAft>
-                <a:spcPts val="400"/>
-              </a:spcAft>
-              <a:defRPr sz="1300">
-                <a:solidFill>
-                  <a:srgbClr val="1F2328"/>
-                </a:solidFill>
-                <a:latin typeface="Aptos"/>
-              </a:defRPr>
-            </a:pPr>
-            <a:r>
-              <a:t>Run Pearl-style tools as supporting evidence.</a:t>
-            </a:r>
-          </a:p>
-          <a:p>
-            <a:pPr>
-              <a:spcAft>
-                <a:spcPts val="400"/>
-              </a:spcAft>
-              <a:defRPr sz="1300">
-                <a:solidFill>
-                  <a:srgbClr val="1F2328"/>
-                </a:solidFill>
-                <a:latin typeface="Aptos"/>
-              </a:defRPr>
-            </a:pPr>
-            <a:r>
-              <a:t>Return verdict + refusal reason + witness.</a:t>
+              </a:rPr>
+              <a:t>Exploratory snapshot | 3 seeds | 10/family | diff=0.55 | 95% CI</a:t>
             </a:r>
           </a:p>
         </p:txBody>
       </p:sp>
       <p:pic>
         <p:nvPicPr>
-          <p:cNvPr id="16" name="Picture 15" descr="method_pipeline.png"/>
+          <p:cNvPr id="10" name="Picture 9" descr="zju_template_logo.png"/>
           <p:cNvPicPr>
             <a:picLocks noChangeAspect="1"/>
           </p:cNvPicPr>
@@ -3735,8 +3415,8 @@
         </p:blipFill>
         <p:spPr>
           <a:xfrm>
-            <a:off x="411480" y="5349240"/>
-            <a:ext cx="4251960" cy="1366701"/>
+            <a:off x="27934920" y="1225296"/>
+            <a:ext cx="5650992" cy="1538978"/>
           </a:xfrm>
           <a:prstGeom prst="rect">
             <a:avLst/>
@@ -3745,57 +3425,27 @@
       </p:pic>
       <p:sp>
         <p:nvSpPr>
-          <p:cNvPr id="17" name="TextBox 16"/>
-          <p:cNvSpPr txBox="1"/>
-          <p:nvPr/>
-        </p:nvSpPr>
-        <p:spPr>
-          <a:xfrm>
-            <a:off x="4983480" y="960120"/>
-            <a:ext cx="4572000" cy="228600"/>
-          </a:xfrm>
-          <a:prstGeom prst="rect">
-            <a:avLst/>
-          </a:prstGeom>
-          <a:noFill/>
-        </p:spPr>
-        <p:txBody>
-          <a:bodyPr wrap="none" lIns="36576" rIns="36576" tIns="18288" bIns="18288" anchor="t">
-            <a:spAutoFit/>
-          </a:bodyPr>
-          <a:lstStyle/>
-          <a:p>
-            <a:r>
-              <a:rPr sz="1600" b="1">
-                <a:solidFill>
-                  <a:srgbClr val="145388"/>
-                </a:solidFill>
-                <a:latin typeface="Aptos"/>
-              </a:rPr>
-              <a:t>Main Result</a:t>
-            </a:r>
-          </a:p>
-        </p:txBody>
-      </p:sp>
-      <p:sp>
-        <p:nvSpPr>
-          <p:cNvPr id="18" name="Rectangle 17"/>
+          <p:cNvPr id="11" name="Rounded Rectangle 10"/>
           <p:cNvSpPr/>
           <p:nvPr/>
         </p:nvSpPr>
         <p:spPr>
           <a:xfrm>
-            <a:off x="4983480" y="1216152"/>
-            <a:ext cx="4572000" cy="13716"/>
-          </a:xfrm>
-          <a:prstGeom prst="rect">
-            <a:avLst/>
+            <a:off x="795528" y="3995928"/>
+            <a:ext cx="10652760" cy="7342631"/>
+          </a:xfrm>
+          <a:prstGeom prst="roundRect">
+            <a:avLst>
+              <a:gd name="adj" fmla="val 4000"/>
+            </a:avLst>
           </a:prstGeom>
           <a:solidFill>
-            <a:srgbClr val="145388"/>
+            <a:srgbClr val="FFFFFF"/>
           </a:solidFill>
-          <a:ln>
-            <a:noFill/>
+          <a:ln w="10160">
+            <a:solidFill>
+              <a:srgbClr val="D2D8E0"/>
+            </a:solidFill>
           </a:ln>
         </p:spPr>
         <p:style>
@@ -3820,9 +3470,2017 @@
           </a:p>
         </p:txBody>
       </p:sp>
+      <p:sp>
+        <p:nvSpPr>
+          <p:cNvPr id="12" name="Rounded Rectangle 11"/>
+          <p:cNvSpPr/>
+          <p:nvPr/>
+        </p:nvSpPr>
+        <p:spPr>
+          <a:xfrm>
+            <a:off x="969264" y="4197096"/>
+            <a:ext cx="10305288" cy="557784"/>
+          </a:xfrm>
+          <a:prstGeom prst="roundRect">
+            <a:avLst>
+              <a:gd name="adj" fmla="val 8000"/>
+            </a:avLst>
+          </a:prstGeom>
+          <a:solidFill>
+            <a:srgbClr val="EAF2FF"/>
+          </a:solidFill>
+          <a:ln>
+            <a:solidFill>
+              <a:srgbClr val="EAF2FF"/>
+            </a:solidFill>
+          </a:ln>
+        </p:spPr>
+        <p:style>
+          <a:lnRef idx="1">
+            <a:schemeClr val="accent1"/>
+          </a:lnRef>
+          <a:fillRef idx="3">
+            <a:schemeClr val="accent1"/>
+          </a:fillRef>
+          <a:effectRef idx="2">
+            <a:schemeClr val="accent1"/>
+          </a:effectRef>
+          <a:fontRef idx="minor">
+            <a:schemeClr val="lt1"/>
+          </a:fontRef>
+        </p:style>
+        <p:txBody>
+          <a:bodyPr rtlCol="0" anchor="ctr"/>
+          <a:lstStyle/>
+          <a:p>
+            <a:pPr algn="ctr"/>
+          </a:p>
+        </p:txBody>
+      </p:sp>
+      <p:sp>
+        <p:nvSpPr>
+          <p:cNvPr id="13" name="TextBox 12"/>
+          <p:cNvSpPr txBox="1"/>
+          <p:nvPr/>
+        </p:nvSpPr>
+        <p:spPr>
+          <a:xfrm>
+            <a:off x="1124712" y="4242816"/>
+            <a:ext cx="9994392" cy="402336"/>
+          </a:xfrm>
+          <a:prstGeom prst="rect">
+            <a:avLst/>
+          </a:prstGeom>
+          <a:noFill/>
+        </p:spPr>
+        <p:txBody>
+          <a:bodyPr wrap="square" lIns="36576" rIns="36576" tIns="18288" bIns="18288" anchor="t">
+            <a:spAutoFit/>
+          </a:bodyPr>
+          <a:lstStyle/>
+          <a:p>
+            <a:r>
+              <a:rPr sz="2500" b="1">
+                <a:solidFill>
+                  <a:srgbClr val="163B6C"/>
+                </a:solidFill>
+                <a:latin typeface="Aptos"/>
+              </a:rPr>
+              <a:t>1. Motivation &amp; Abstract</a:t>
+            </a:r>
+          </a:p>
+        </p:txBody>
+      </p:sp>
+      <p:sp>
+        <p:nvSpPr>
+          <p:cNvPr id="14" name="TextBox 13"/>
+          <p:cNvSpPr txBox="1"/>
+          <p:nvPr/>
+        </p:nvSpPr>
+        <p:spPr>
+          <a:xfrm>
+            <a:off x="1078992" y="4791456"/>
+            <a:ext cx="10076688" cy="1691640"/>
+          </a:xfrm>
+          <a:prstGeom prst="rect">
+            <a:avLst/>
+          </a:prstGeom>
+          <a:noFill/>
+        </p:spPr>
+        <p:txBody>
+          <a:bodyPr wrap="square" lIns="36576" rIns="36576" tIns="18288" bIns="18288" anchor="t">
+            <a:spAutoFit/>
+          </a:bodyPr>
+          <a:lstStyle/>
+          <a:p>
+            <a:r>
+              <a:rPr sz="1700" b="0">
+                <a:solidFill>
+                  <a:srgbClr val="1F2328"/>
+                </a:solidFill>
+                <a:latin typeface="Aptos"/>
+              </a:rPr>
+              <a:t>Causal oversight systems must decide when a public causal claim is valid and when the available evidence is insufficient. Current prompt-only and heuristic judges often trade unsafe acceptance against over-refusal. We study this tension as a benchmark-first problem: the verifier receives only public scenario evidence, while gold SCMs and labels remain evaluator-only. The current artifact is an exploratory prototype, not a mature benchmark release.</a:t>
+            </a:r>
+          </a:p>
+        </p:txBody>
+      </p:sp>
+      <p:sp>
+        <p:nvSpPr>
+          <p:cNvPr id="15" name="Rounded Rectangle 14"/>
+          <p:cNvSpPr/>
+          <p:nvPr/>
+        </p:nvSpPr>
+        <p:spPr>
+          <a:xfrm>
+            <a:off x="1069848" y="6812280"/>
+            <a:ext cx="10113264" cy="1645920"/>
+          </a:xfrm>
+          <a:prstGeom prst="roundRect">
+            <a:avLst>
+              <a:gd name="adj" fmla="val 4000"/>
+            </a:avLst>
+          </a:prstGeom>
+          <a:solidFill>
+            <a:srgbClr val="EAF7EE"/>
+          </a:solidFill>
+          <a:ln w="8255">
+            <a:solidFill>
+              <a:srgbClr val="D2D8E0"/>
+            </a:solidFill>
+          </a:ln>
+        </p:spPr>
+        <p:style>
+          <a:lnRef idx="1">
+            <a:schemeClr val="accent1"/>
+          </a:lnRef>
+          <a:fillRef idx="3">
+            <a:schemeClr val="accent1"/>
+          </a:fillRef>
+          <a:effectRef idx="2">
+            <a:schemeClr val="accent1"/>
+          </a:effectRef>
+          <a:fontRef idx="minor">
+            <a:schemeClr val="lt1"/>
+          </a:fontRef>
+        </p:style>
+        <p:txBody>
+          <a:bodyPr rtlCol="0" anchor="ctr"/>
+          <a:lstStyle/>
+          <a:p>
+            <a:pPr algn="ctr"/>
+          </a:p>
+        </p:txBody>
+      </p:sp>
+      <p:sp>
+        <p:nvSpPr>
+          <p:cNvPr id="16" name="TextBox 15"/>
+          <p:cNvSpPr txBox="1"/>
+          <p:nvPr/>
+        </p:nvSpPr>
+        <p:spPr>
+          <a:xfrm>
+            <a:off x="1234439" y="6940296"/>
+            <a:ext cx="9784080" cy="320040"/>
+          </a:xfrm>
+          <a:prstGeom prst="rect">
+            <a:avLst/>
+          </a:prstGeom>
+          <a:noFill/>
+        </p:spPr>
+        <p:txBody>
+          <a:bodyPr wrap="square" lIns="36576" rIns="36576" tIns="18288" bIns="18288" anchor="t">
+            <a:spAutoFit/>
+          </a:bodyPr>
+          <a:lstStyle/>
+          <a:p>
+            <a:r>
+              <a:rPr sz="1800" b="1">
+                <a:solidFill>
+                  <a:srgbClr val="5B636E"/>
+                </a:solidFill>
+                <a:latin typeface="Aptos"/>
+              </a:rPr>
+              <a:t>Key contributions</a:t>
+            </a:r>
+          </a:p>
+        </p:txBody>
+      </p:sp>
+      <p:sp>
+        <p:nvSpPr>
+          <p:cNvPr id="17" name="TextBox 16"/>
+          <p:cNvSpPr txBox="1"/>
+          <p:nvPr/>
+        </p:nvSpPr>
+        <p:spPr>
+          <a:xfrm>
+            <a:off x="1234439" y="7315200"/>
+            <a:ext cx="9784080" cy="1051560"/>
+          </a:xfrm>
+          <a:prstGeom prst="rect">
+            <a:avLst/>
+          </a:prstGeom>
+          <a:noFill/>
+        </p:spPr>
+        <p:txBody>
+          <a:bodyPr wrap="square" lIns="45720" rIns="45720" tIns="18288">
+            <a:spAutoFit/>
+          </a:bodyPr>
+          <a:lstStyle/>
+          <a:p>
+            <a:pPr>
+              <a:spcAft>
+                <a:spcPts val="400"/>
+              </a:spcAft>
+              <a:defRPr sz="1400">
+                <a:solidFill>
+                  <a:srgbClr val="1F2328"/>
+                </a:solidFill>
+                <a:latin typeface="Aptos"/>
+              </a:defRPr>
+            </a:pPr>
+            <a:r>
+              <a:t>Selective verdict contract: VALID / INVALID / UNIDENTIFIABLE.</a:t>
+            </a:r>
+          </a:p>
+          <a:p>
+            <a:pPr>
+              <a:spcAft>
+                <a:spcPts val="400"/>
+              </a:spcAft>
+              <a:defRPr sz="1400">
+                <a:solidFill>
+                  <a:srgbClr val="1F2328"/>
+                </a:solidFill>
+                <a:latin typeface="Aptos"/>
+              </a:defRPr>
+            </a:pPr>
+            <a:r>
+              <a:t>Countermodel-grounded verifier with evaluator-only gold labels.</a:t>
+            </a:r>
+          </a:p>
+          <a:p>
+            <a:pPr>
+              <a:spcAft>
+                <a:spcPts val="400"/>
+              </a:spcAft>
+              <a:defRPr sz="1400">
+                <a:solidFill>
+                  <a:srgbClr val="1F2328"/>
+                </a:solidFill>
+                <a:latin typeface="Aptos"/>
+              </a:defRPr>
+            </a:pPr>
+            <a:r>
+              <a:t>Frozen evidence package: main tradeoff, API baselines, OOD buckets, and ablations.</a:t>
+            </a:r>
+          </a:p>
+        </p:txBody>
+      </p:sp>
+      <p:sp>
+        <p:nvSpPr>
+          <p:cNvPr id="18" name="Rounded Rectangle 17"/>
+          <p:cNvSpPr/>
+          <p:nvPr/>
+        </p:nvSpPr>
+        <p:spPr>
+          <a:xfrm>
+            <a:off x="1069848" y="8732520"/>
+            <a:ext cx="10113264" cy="2148840"/>
+          </a:xfrm>
+          <a:prstGeom prst="roundRect">
+            <a:avLst>
+              <a:gd name="adj" fmla="val 4000"/>
+            </a:avLst>
+          </a:prstGeom>
+          <a:solidFill>
+            <a:srgbClr val="EAF2FF"/>
+          </a:solidFill>
+          <a:ln w="8255">
+            <a:solidFill>
+              <a:srgbClr val="D2D8E0"/>
+            </a:solidFill>
+          </a:ln>
+        </p:spPr>
+        <p:style>
+          <a:lnRef idx="1">
+            <a:schemeClr val="accent1"/>
+          </a:lnRef>
+          <a:fillRef idx="3">
+            <a:schemeClr val="accent1"/>
+          </a:fillRef>
+          <a:effectRef idx="2">
+            <a:schemeClr val="accent1"/>
+          </a:effectRef>
+          <a:fontRef idx="minor">
+            <a:schemeClr val="lt1"/>
+          </a:fontRef>
+        </p:style>
+        <p:txBody>
+          <a:bodyPr rtlCol="0" anchor="ctr"/>
+          <a:lstStyle/>
+          <a:p>
+            <a:pPr algn="ctr"/>
+          </a:p>
+        </p:txBody>
+      </p:sp>
+      <p:sp>
+        <p:nvSpPr>
+          <p:cNvPr id="19" name="TextBox 18"/>
+          <p:cNvSpPr txBox="1"/>
+          <p:nvPr/>
+        </p:nvSpPr>
+        <p:spPr>
+          <a:xfrm>
+            <a:off x="1234439" y="8860536"/>
+            <a:ext cx="9784080" cy="320040"/>
+          </a:xfrm>
+          <a:prstGeom prst="rect">
+            <a:avLst/>
+          </a:prstGeom>
+          <a:noFill/>
+        </p:spPr>
+        <p:txBody>
+          <a:bodyPr wrap="square" lIns="36576" rIns="36576" tIns="18288" bIns="18288" anchor="t">
+            <a:spAutoFit/>
+          </a:bodyPr>
+          <a:lstStyle/>
+          <a:p>
+            <a:r>
+              <a:rPr sz="1800" b="1">
+                <a:solidFill>
+                  <a:srgbClr val="5B636E"/>
+                </a:solidFill>
+                <a:latin typeface="Aptos"/>
+              </a:rPr>
+              <a:t>Task contract</a:t>
+            </a:r>
+          </a:p>
+        </p:txBody>
+      </p:sp>
+      <p:sp>
+        <p:nvSpPr>
+          <p:cNvPr id="20" name="TextBox 19"/>
+          <p:cNvSpPr txBox="1"/>
+          <p:nvPr/>
+        </p:nvSpPr>
+        <p:spPr>
+          <a:xfrm>
+            <a:off x="1234439" y="9235440"/>
+            <a:ext cx="9784080" cy="1554480"/>
+          </a:xfrm>
+          <a:prstGeom prst="rect">
+            <a:avLst/>
+          </a:prstGeom>
+          <a:noFill/>
+        </p:spPr>
+        <p:txBody>
+          <a:bodyPr wrap="square" lIns="45720" rIns="45720" tIns="18288">
+            <a:spAutoFit/>
+          </a:bodyPr>
+          <a:lstStyle/>
+          <a:p>
+            <a:pPr>
+              <a:spcAft>
+                <a:spcPts val="400"/>
+              </a:spcAft>
+              <a:defRPr sz="1400">
+                <a:solidFill>
+                  <a:srgbClr val="1F2328"/>
+                </a:solidFill>
+                <a:latin typeface="Aptos"/>
+              </a:defRPr>
+            </a:pPr>
+            <a:r>
+              <a:t>Input: public scenario + causal claim only.</a:t>
+            </a:r>
+          </a:p>
+          <a:p>
+            <a:pPr>
+              <a:spcAft>
+                <a:spcPts val="400"/>
+              </a:spcAft>
+              <a:defRPr sz="1400">
+                <a:solidFill>
+                  <a:srgbClr val="1F2328"/>
+                </a:solidFill>
+                <a:latin typeface="Aptos"/>
+              </a:defRPr>
+            </a:pPr>
+            <a:r>
+              <a:t>Hidden: SCM, labels, and hidden variables.</a:t>
+            </a:r>
+          </a:p>
+          <a:p>
+            <a:pPr>
+              <a:spcAft>
+                <a:spcPts val="400"/>
+              </a:spcAft>
+              <a:defRPr sz="1400">
+                <a:solidFill>
+                  <a:srgbClr val="1F2328"/>
+                </a:solidFill>
+                <a:latin typeface="Aptos"/>
+              </a:defRPr>
+            </a:pPr>
+            <a:r>
+              <a:t>Risk metric: unsafe acceptance plus wise refusal.</a:t>
+            </a:r>
+          </a:p>
+        </p:txBody>
+      </p:sp>
+      <p:sp>
+        <p:nvSpPr>
+          <p:cNvPr id="21" name="Rounded Rectangle 20"/>
+          <p:cNvSpPr/>
+          <p:nvPr/>
+        </p:nvSpPr>
+        <p:spPr>
+          <a:xfrm>
+            <a:off x="795528" y="11667744"/>
+            <a:ext cx="10652760" cy="6336792"/>
+          </a:xfrm>
+          <a:prstGeom prst="roundRect">
+            <a:avLst>
+              <a:gd name="adj" fmla="val 4000"/>
+            </a:avLst>
+          </a:prstGeom>
+          <a:solidFill>
+            <a:srgbClr val="FFFFFF"/>
+          </a:solidFill>
+          <a:ln w="10160">
+            <a:solidFill>
+              <a:srgbClr val="D2D8E0"/>
+            </a:solidFill>
+          </a:ln>
+        </p:spPr>
+        <p:style>
+          <a:lnRef idx="1">
+            <a:schemeClr val="accent1"/>
+          </a:lnRef>
+          <a:fillRef idx="3">
+            <a:schemeClr val="accent1"/>
+          </a:fillRef>
+          <a:effectRef idx="2">
+            <a:schemeClr val="accent1"/>
+          </a:effectRef>
+          <a:fontRef idx="minor">
+            <a:schemeClr val="lt1"/>
+          </a:fontRef>
+        </p:style>
+        <p:txBody>
+          <a:bodyPr rtlCol="0" anchor="ctr"/>
+          <a:lstStyle/>
+          <a:p>
+            <a:pPr algn="ctr"/>
+          </a:p>
+        </p:txBody>
+      </p:sp>
+      <p:sp>
+        <p:nvSpPr>
+          <p:cNvPr id="22" name="Rounded Rectangle 21"/>
+          <p:cNvSpPr/>
+          <p:nvPr/>
+        </p:nvSpPr>
+        <p:spPr>
+          <a:xfrm>
+            <a:off x="969264" y="11868912"/>
+            <a:ext cx="10305288" cy="557784"/>
+          </a:xfrm>
+          <a:prstGeom prst="roundRect">
+            <a:avLst>
+              <a:gd name="adj" fmla="val 8000"/>
+            </a:avLst>
+          </a:prstGeom>
+          <a:solidFill>
+            <a:srgbClr val="EAF2FF"/>
+          </a:solidFill>
+          <a:ln>
+            <a:solidFill>
+              <a:srgbClr val="EAF2FF"/>
+            </a:solidFill>
+          </a:ln>
+        </p:spPr>
+        <p:style>
+          <a:lnRef idx="1">
+            <a:schemeClr val="accent1"/>
+          </a:lnRef>
+          <a:fillRef idx="3">
+            <a:schemeClr val="accent1"/>
+          </a:fillRef>
+          <a:effectRef idx="2">
+            <a:schemeClr val="accent1"/>
+          </a:effectRef>
+          <a:fontRef idx="minor">
+            <a:schemeClr val="lt1"/>
+          </a:fontRef>
+        </p:style>
+        <p:txBody>
+          <a:bodyPr rtlCol="0" anchor="ctr"/>
+          <a:lstStyle/>
+          <a:p>
+            <a:pPr algn="ctr"/>
+          </a:p>
+        </p:txBody>
+      </p:sp>
+      <p:sp>
+        <p:nvSpPr>
+          <p:cNvPr id="23" name="TextBox 22"/>
+          <p:cNvSpPr txBox="1"/>
+          <p:nvPr/>
+        </p:nvSpPr>
+        <p:spPr>
+          <a:xfrm>
+            <a:off x="1124712" y="11914632"/>
+            <a:ext cx="9994392" cy="402336"/>
+          </a:xfrm>
+          <a:prstGeom prst="rect">
+            <a:avLst/>
+          </a:prstGeom>
+          <a:noFill/>
+        </p:spPr>
+        <p:txBody>
+          <a:bodyPr wrap="square" lIns="36576" rIns="36576" tIns="18288" bIns="18288" anchor="t">
+            <a:spAutoFit/>
+          </a:bodyPr>
+          <a:lstStyle/>
+          <a:p>
+            <a:r>
+              <a:rPr sz="2500" b="1">
+                <a:solidFill>
+                  <a:srgbClr val="163B6C"/>
+                </a:solidFill>
+                <a:latin typeface="Aptos"/>
+              </a:rPr>
+              <a:t>2. Method Overview</a:t>
+            </a:r>
+          </a:p>
+        </p:txBody>
+      </p:sp>
+      <p:sp>
+        <p:nvSpPr>
+          <p:cNvPr id="24" name="TextBox 23"/>
+          <p:cNvSpPr txBox="1"/>
+          <p:nvPr/>
+        </p:nvSpPr>
+        <p:spPr>
+          <a:xfrm>
+            <a:off x="1078992" y="12454128"/>
+            <a:ext cx="10076688" cy="914400"/>
+          </a:xfrm>
+          <a:prstGeom prst="rect">
+            <a:avLst/>
+          </a:prstGeom>
+          <a:noFill/>
+        </p:spPr>
+        <p:txBody>
+          <a:bodyPr wrap="square" lIns="36576" rIns="36576" tIns="18288" bIns="18288" anchor="t">
+            <a:spAutoFit/>
+          </a:bodyPr>
+          <a:lstStyle/>
+          <a:p>
+            <a:r>
+              <a:rPr sz="1600" b="0">
+                <a:solidFill>
+                  <a:srgbClr val="1F2328"/>
+                </a:solidFill>
+                <a:latin typeface="Aptos"/>
+              </a:rPr>
+              <a:t>The verifier turns a claim into an assumption ledger, searches for public-compatible counter-SCM witnesses, and uses Pearl-style tools as supporting evidence before issuing a selective verdict.</a:t>
+            </a:r>
+          </a:p>
+        </p:txBody>
+      </p:sp>
+      <p:sp>
+        <p:nvSpPr>
+          <p:cNvPr id="25" name="Rectangle 24"/>
+          <p:cNvSpPr/>
+          <p:nvPr/>
+        </p:nvSpPr>
+        <p:spPr>
+          <a:xfrm>
+            <a:off x="1097280" y="13716000"/>
+            <a:ext cx="2743200" cy="960120"/>
+          </a:xfrm>
+          <a:prstGeom prst="rect">
+            <a:avLst/>
+          </a:prstGeom>
+          <a:solidFill>
+            <a:srgbClr val="FAFCFF"/>
+          </a:solidFill>
+          <a:ln w="13970">
+            <a:solidFill>
+              <a:srgbClr val="B7791F"/>
+            </a:solidFill>
+          </a:ln>
+        </p:spPr>
+        <p:style>
+          <a:lnRef idx="1">
+            <a:schemeClr val="accent1"/>
+          </a:lnRef>
+          <a:fillRef idx="3">
+            <a:schemeClr val="accent1"/>
+          </a:fillRef>
+          <a:effectRef idx="2">
+            <a:schemeClr val="accent1"/>
+          </a:effectRef>
+          <a:fontRef idx="minor">
+            <a:schemeClr val="lt1"/>
+          </a:fontRef>
+        </p:style>
+        <p:txBody>
+          <a:bodyPr rtlCol="0" anchor="ctr" wrap="square" lIns="54864" rIns="54864" tIns="27432" bIns="27432"/>
+          <a:lstStyle/>
+          <a:p>
+            <a:pPr algn="ctr"/>
+            <a:r>
+              <a:rPr sz="1500" b="1">
+                <a:solidFill>
+                  <a:srgbClr val="1F2328"/>
+                </a:solidFill>
+                <a:latin typeface="Aptos"/>
+              </a:rPr>
+              <a:t>Claim
++ scenario</a:t>
+            </a:r>
+          </a:p>
+        </p:txBody>
+      </p:sp>
+      <p:sp>
+        <p:nvSpPr>
+          <p:cNvPr id="26" name="TextBox 25"/>
+          <p:cNvSpPr txBox="1"/>
+          <p:nvPr/>
+        </p:nvSpPr>
+        <p:spPr>
+          <a:xfrm>
+            <a:off x="3950208" y="14081760"/>
+            <a:ext cx="256032" cy="182880"/>
+          </a:xfrm>
+          <a:prstGeom prst="rect">
+            <a:avLst/>
+          </a:prstGeom>
+          <a:noFill/>
+        </p:spPr>
+        <p:txBody>
+          <a:bodyPr wrap="square" lIns="36576" rIns="36576" tIns="18288" bIns="18288" anchor="t">
+            <a:spAutoFit/>
+          </a:bodyPr>
+          <a:lstStyle/>
+          <a:p>
+            <a:pPr algn="ctr"/>
+            <a:r>
+              <a:rPr sz="1200" b="1">
+                <a:solidFill>
+                  <a:srgbClr val="145388"/>
+                </a:solidFill>
+                <a:latin typeface="Aptos"/>
+              </a:rPr>
+              <a:t>-&gt;</a:t>
+            </a:r>
+          </a:p>
+        </p:txBody>
+      </p:sp>
+      <p:sp>
+        <p:nvSpPr>
+          <p:cNvPr id="27" name="Rectangle 26"/>
+          <p:cNvSpPr/>
+          <p:nvPr/>
+        </p:nvSpPr>
+        <p:spPr>
+          <a:xfrm>
+            <a:off x="4343400" y="13716000"/>
+            <a:ext cx="2743200" cy="960120"/>
+          </a:xfrm>
+          <a:prstGeom prst="rect">
+            <a:avLst/>
+          </a:prstGeom>
+          <a:solidFill>
+            <a:srgbClr val="FAFCFF"/>
+          </a:solidFill>
+          <a:ln w="13970">
+            <a:solidFill>
+              <a:srgbClr val="163B6C"/>
+            </a:solidFill>
+          </a:ln>
+        </p:spPr>
+        <p:style>
+          <a:lnRef idx="1">
+            <a:schemeClr val="accent1"/>
+          </a:lnRef>
+          <a:fillRef idx="3">
+            <a:schemeClr val="accent1"/>
+          </a:fillRef>
+          <a:effectRef idx="2">
+            <a:schemeClr val="accent1"/>
+          </a:effectRef>
+          <a:fontRef idx="minor">
+            <a:schemeClr val="lt1"/>
+          </a:fontRef>
+        </p:style>
+        <p:txBody>
+          <a:bodyPr rtlCol="0" anchor="ctr" wrap="square" lIns="54864" rIns="54864" tIns="27432" bIns="27432"/>
+          <a:lstStyle/>
+          <a:p>
+            <a:pPr algn="ctr"/>
+            <a:r>
+              <a:rPr sz="1500" b="1">
+                <a:solidFill>
+                  <a:srgbClr val="1F2328"/>
+                </a:solidFill>
+                <a:latin typeface="Aptos"/>
+              </a:rPr>
+              <a:t>Parser</a:t>
+            </a:r>
+          </a:p>
+        </p:txBody>
+      </p:sp>
+      <p:sp>
+        <p:nvSpPr>
+          <p:cNvPr id="28" name="TextBox 27"/>
+          <p:cNvSpPr txBox="1"/>
+          <p:nvPr/>
+        </p:nvSpPr>
+        <p:spPr>
+          <a:xfrm>
+            <a:off x="7196328" y="14081760"/>
+            <a:ext cx="256032" cy="182880"/>
+          </a:xfrm>
+          <a:prstGeom prst="rect">
+            <a:avLst/>
+          </a:prstGeom>
+          <a:noFill/>
+        </p:spPr>
+        <p:txBody>
+          <a:bodyPr wrap="square" lIns="36576" rIns="36576" tIns="18288" bIns="18288" anchor="t">
+            <a:spAutoFit/>
+          </a:bodyPr>
+          <a:lstStyle/>
+          <a:p>
+            <a:pPr algn="ctr"/>
+            <a:r>
+              <a:rPr sz="1200" b="1">
+                <a:solidFill>
+                  <a:srgbClr val="145388"/>
+                </a:solidFill>
+                <a:latin typeface="Aptos"/>
+              </a:rPr>
+              <a:t>-&gt;</a:t>
+            </a:r>
+          </a:p>
+        </p:txBody>
+      </p:sp>
+      <p:sp>
+        <p:nvSpPr>
+          <p:cNvPr id="29" name="Rectangle 28"/>
+          <p:cNvSpPr/>
+          <p:nvPr/>
+        </p:nvSpPr>
+        <p:spPr>
+          <a:xfrm>
+            <a:off x="7589519" y="13716000"/>
+            <a:ext cx="2743200" cy="960120"/>
+          </a:xfrm>
+          <a:prstGeom prst="rect">
+            <a:avLst/>
+          </a:prstGeom>
+          <a:solidFill>
+            <a:srgbClr val="FAFCFF"/>
+          </a:solidFill>
+          <a:ln w="13970">
+            <a:solidFill>
+              <a:srgbClr val="163B6C"/>
+            </a:solidFill>
+          </a:ln>
+        </p:spPr>
+        <p:style>
+          <a:lnRef idx="1">
+            <a:schemeClr val="accent1"/>
+          </a:lnRef>
+          <a:fillRef idx="3">
+            <a:schemeClr val="accent1"/>
+          </a:fillRef>
+          <a:effectRef idx="2">
+            <a:schemeClr val="accent1"/>
+          </a:effectRef>
+          <a:fontRef idx="minor">
+            <a:schemeClr val="lt1"/>
+          </a:fontRef>
+        </p:style>
+        <p:txBody>
+          <a:bodyPr rtlCol="0" anchor="ctr" wrap="square" lIns="54864" rIns="54864" tIns="27432" bIns="27432"/>
+          <a:lstStyle/>
+          <a:p>
+            <a:pPr algn="ctr"/>
+            <a:r>
+              <a:rPr sz="1500" b="1">
+                <a:solidFill>
+                  <a:srgbClr val="1F2328"/>
+                </a:solidFill>
+                <a:latin typeface="Aptos"/>
+              </a:rPr>
+              <a:t>Assumption
+ledger</a:t>
+            </a:r>
+          </a:p>
+        </p:txBody>
+      </p:sp>
+      <p:sp>
+        <p:nvSpPr>
+          <p:cNvPr id="30" name="Rectangle 29"/>
+          <p:cNvSpPr/>
+          <p:nvPr/>
+        </p:nvSpPr>
+        <p:spPr>
+          <a:xfrm>
+            <a:off x="1097280" y="15133320"/>
+            <a:ext cx="2743200" cy="960120"/>
+          </a:xfrm>
+          <a:prstGeom prst="rect">
+            <a:avLst/>
+          </a:prstGeom>
+          <a:solidFill>
+            <a:srgbClr val="FAFCFF"/>
+          </a:solidFill>
+          <a:ln w="13970">
+            <a:solidFill>
+              <a:srgbClr val="163B6C"/>
+            </a:solidFill>
+          </a:ln>
+        </p:spPr>
+        <p:style>
+          <a:lnRef idx="1">
+            <a:schemeClr val="accent1"/>
+          </a:lnRef>
+          <a:fillRef idx="3">
+            <a:schemeClr val="accent1"/>
+          </a:fillRef>
+          <a:effectRef idx="2">
+            <a:schemeClr val="accent1"/>
+          </a:effectRef>
+          <a:fontRef idx="minor">
+            <a:schemeClr val="lt1"/>
+          </a:fontRef>
+        </p:style>
+        <p:txBody>
+          <a:bodyPr rtlCol="0" anchor="ctr" wrap="square" lIns="54864" rIns="54864" tIns="27432" bIns="27432"/>
+          <a:lstStyle/>
+          <a:p>
+            <a:pPr algn="ctr"/>
+            <a:r>
+              <a:rPr sz="1500" b="1">
+                <a:solidFill>
+                  <a:srgbClr val="1F2328"/>
+                </a:solidFill>
+                <a:latin typeface="Aptos"/>
+              </a:rPr>
+              <a:t>Countermodel
+search</a:t>
+            </a:r>
+          </a:p>
+        </p:txBody>
+      </p:sp>
+      <p:sp>
+        <p:nvSpPr>
+          <p:cNvPr id="31" name="TextBox 30"/>
+          <p:cNvSpPr txBox="1"/>
+          <p:nvPr/>
+        </p:nvSpPr>
+        <p:spPr>
+          <a:xfrm>
+            <a:off x="3950208" y="15499080"/>
+            <a:ext cx="256032" cy="182880"/>
+          </a:xfrm>
+          <a:prstGeom prst="rect">
+            <a:avLst/>
+          </a:prstGeom>
+          <a:noFill/>
+        </p:spPr>
+        <p:txBody>
+          <a:bodyPr wrap="square" lIns="36576" rIns="36576" tIns="18288" bIns="18288" anchor="t">
+            <a:spAutoFit/>
+          </a:bodyPr>
+          <a:lstStyle/>
+          <a:p>
+            <a:pPr algn="ctr"/>
+            <a:r>
+              <a:rPr sz="1200" b="1">
+                <a:solidFill>
+                  <a:srgbClr val="145388"/>
+                </a:solidFill>
+                <a:latin typeface="Aptos"/>
+              </a:rPr>
+              <a:t>-&gt;</a:t>
+            </a:r>
+          </a:p>
+        </p:txBody>
+      </p:sp>
+      <p:sp>
+        <p:nvSpPr>
+          <p:cNvPr id="32" name="Rectangle 31"/>
+          <p:cNvSpPr/>
+          <p:nvPr/>
+        </p:nvSpPr>
+        <p:spPr>
+          <a:xfrm>
+            <a:off x="4343400" y="15133320"/>
+            <a:ext cx="2743200" cy="960120"/>
+          </a:xfrm>
+          <a:prstGeom prst="rect">
+            <a:avLst/>
+          </a:prstGeom>
+          <a:solidFill>
+            <a:srgbClr val="FAFCFF"/>
+          </a:solidFill>
+          <a:ln w="13970">
+            <a:solidFill>
+              <a:srgbClr val="163B6C"/>
+            </a:solidFill>
+          </a:ln>
+        </p:spPr>
+        <p:style>
+          <a:lnRef idx="1">
+            <a:schemeClr val="accent1"/>
+          </a:lnRef>
+          <a:fillRef idx="3">
+            <a:schemeClr val="accent1"/>
+          </a:fillRef>
+          <a:effectRef idx="2">
+            <a:schemeClr val="accent1"/>
+          </a:effectRef>
+          <a:fontRef idx="minor">
+            <a:schemeClr val="lt1"/>
+          </a:fontRef>
+        </p:style>
+        <p:txBody>
+          <a:bodyPr rtlCol="0" anchor="ctr" wrap="square" lIns="54864" rIns="54864" tIns="27432" bIns="27432"/>
+          <a:lstStyle/>
+          <a:p>
+            <a:pPr algn="ctr"/>
+            <a:r>
+              <a:rPr sz="1500" b="1">
+                <a:solidFill>
+                  <a:srgbClr val="1F2328"/>
+                </a:solidFill>
+                <a:latin typeface="Aptos"/>
+              </a:rPr>
+              <a:t>Tool-backed
+adjudication</a:t>
+            </a:r>
+          </a:p>
+        </p:txBody>
+      </p:sp>
+      <p:sp>
+        <p:nvSpPr>
+          <p:cNvPr id="33" name="TextBox 32"/>
+          <p:cNvSpPr txBox="1"/>
+          <p:nvPr/>
+        </p:nvSpPr>
+        <p:spPr>
+          <a:xfrm>
+            <a:off x="7196328" y="15499080"/>
+            <a:ext cx="256032" cy="182880"/>
+          </a:xfrm>
+          <a:prstGeom prst="rect">
+            <a:avLst/>
+          </a:prstGeom>
+          <a:noFill/>
+        </p:spPr>
+        <p:txBody>
+          <a:bodyPr wrap="square" lIns="36576" rIns="36576" tIns="18288" bIns="18288" anchor="t">
+            <a:spAutoFit/>
+          </a:bodyPr>
+          <a:lstStyle/>
+          <a:p>
+            <a:pPr algn="ctr"/>
+            <a:r>
+              <a:rPr sz="1200" b="1">
+                <a:solidFill>
+                  <a:srgbClr val="145388"/>
+                </a:solidFill>
+                <a:latin typeface="Aptos"/>
+              </a:rPr>
+              <a:t>-&gt;</a:t>
+            </a:r>
+          </a:p>
+        </p:txBody>
+      </p:sp>
+      <p:sp>
+        <p:nvSpPr>
+          <p:cNvPr id="34" name="Rectangle 33"/>
+          <p:cNvSpPr/>
+          <p:nvPr/>
+        </p:nvSpPr>
+        <p:spPr>
+          <a:xfrm>
+            <a:off x="7589519" y="15133320"/>
+            <a:ext cx="2743200" cy="960120"/>
+          </a:xfrm>
+          <a:prstGeom prst="rect">
+            <a:avLst/>
+          </a:prstGeom>
+          <a:solidFill>
+            <a:srgbClr val="FAFCFF"/>
+          </a:solidFill>
+          <a:ln w="13970">
+            <a:solidFill>
+              <a:srgbClr val="12805C"/>
+            </a:solidFill>
+          </a:ln>
+        </p:spPr>
+        <p:style>
+          <a:lnRef idx="1">
+            <a:schemeClr val="accent1"/>
+          </a:lnRef>
+          <a:fillRef idx="3">
+            <a:schemeClr val="accent1"/>
+          </a:fillRef>
+          <a:effectRef idx="2">
+            <a:schemeClr val="accent1"/>
+          </a:effectRef>
+          <a:fontRef idx="minor">
+            <a:schemeClr val="lt1"/>
+          </a:fontRef>
+        </p:style>
+        <p:txBody>
+          <a:bodyPr rtlCol="0" anchor="ctr" wrap="square" lIns="54864" rIns="54864" tIns="27432" bIns="27432"/>
+          <a:lstStyle/>
+          <a:p>
+            <a:pPr algn="ctr"/>
+            <a:r>
+              <a:rPr sz="1500" b="1">
+                <a:solidFill>
+                  <a:srgbClr val="1F2328"/>
+                </a:solidFill>
+                <a:latin typeface="Aptos"/>
+              </a:rPr>
+              <a:t>Verdict
++ witness</a:t>
+            </a:r>
+          </a:p>
+        </p:txBody>
+      </p:sp>
+      <p:sp>
+        <p:nvSpPr>
+          <p:cNvPr id="35" name="TextBox 34"/>
+          <p:cNvSpPr txBox="1"/>
+          <p:nvPr/>
+        </p:nvSpPr>
+        <p:spPr>
+          <a:xfrm>
+            <a:off x="1078992" y="16779240"/>
+            <a:ext cx="10076688" cy="320040"/>
+          </a:xfrm>
+          <a:prstGeom prst="rect">
+            <a:avLst/>
+          </a:prstGeom>
+          <a:noFill/>
+        </p:spPr>
+        <p:txBody>
+          <a:bodyPr wrap="square" lIns="36576" rIns="36576" tIns="18288" bIns="18288" anchor="t">
+            <a:spAutoFit/>
+          </a:bodyPr>
+          <a:lstStyle/>
+          <a:p>
+            <a:r>
+              <a:rPr sz="1300" b="0">
+                <a:solidFill>
+                  <a:srgbClr val="5B636E"/>
+                </a:solidFill>
+                <a:latin typeface="Aptos"/>
+              </a:rPr>
+              <a:t>Counter-SCM witnesses are diagnostic certificates, not leaked gold evidence.</a:t>
+            </a:r>
+          </a:p>
+        </p:txBody>
+      </p:sp>
+      <p:sp>
+        <p:nvSpPr>
+          <p:cNvPr id="36" name="Rounded Rectangle 35"/>
+          <p:cNvSpPr/>
+          <p:nvPr/>
+        </p:nvSpPr>
+        <p:spPr>
+          <a:xfrm>
+            <a:off x="795528" y="18324576"/>
+            <a:ext cx="10652760" cy="6620256"/>
+          </a:xfrm>
+          <a:prstGeom prst="roundRect">
+            <a:avLst>
+              <a:gd name="adj" fmla="val 4000"/>
+            </a:avLst>
+          </a:prstGeom>
+          <a:solidFill>
+            <a:srgbClr val="FFFFFF"/>
+          </a:solidFill>
+          <a:ln w="10160">
+            <a:solidFill>
+              <a:srgbClr val="D2D8E0"/>
+            </a:solidFill>
+          </a:ln>
+        </p:spPr>
+        <p:style>
+          <a:lnRef idx="1">
+            <a:schemeClr val="accent1"/>
+          </a:lnRef>
+          <a:fillRef idx="3">
+            <a:schemeClr val="accent1"/>
+          </a:fillRef>
+          <a:effectRef idx="2">
+            <a:schemeClr val="accent1"/>
+          </a:effectRef>
+          <a:fontRef idx="minor">
+            <a:schemeClr val="lt1"/>
+          </a:fontRef>
+        </p:style>
+        <p:txBody>
+          <a:bodyPr rtlCol="0" anchor="ctr"/>
+          <a:lstStyle/>
+          <a:p>
+            <a:pPr algn="ctr"/>
+          </a:p>
+        </p:txBody>
+      </p:sp>
+      <p:sp>
+        <p:nvSpPr>
+          <p:cNvPr id="37" name="Rounded Rectangle 36"/>
+          <p:cNvSpPr/>
+          <p:nvPr/>
+        </p:nvSpPr>
+        <p:spPr>
+          <a:xfrm>
+            <a:off x="969264" y="18525744"/>
+            <a:ext cx="10305288" cy="557784"/>
+          </a:xfrm>
+          <a:prstGeom prst="roundRect">
+            <a:avLst>
+              <a:gd name="adj" fmla="val 8000"/>
+            </a:avLst>
+          </a:prstGeom>
+          <a:solidFill>
+            <a:srgbClr val="EAF2FF"/>
+          </a:solidFill>
+          <a:ln>
+            <a:solidFill>
+              <a:srgbClr val="EAF2FF"/>
+            </a:solidFill>
+          </a:ln>
+        </p:spPr>
+        <p:style>
+          <a:lnRef idx="1">
+            <a:schemeClr val="accent1"/>
+          </a:lnRef>
+          <a:fillRef idx="3">
+            <a:schemeClr val="accent1"/>
+          </a:fillRef>
+          <a:effectRef idx="2">
+            <a:schemeClr val="accent1"/>
+          </a:effectRef>
+          <a:fontRef idx="minor">
+            <a:schemeClr val="lt1"/>
+          </a:fontRef>
+        </p:style>
+        <p:txBody>
+          <a:bodyPr rtlCol="0" anchor="ctr"/>
+          <a:lstStyle/>
+          <a:p>
+            <a:pPr algn="ctr"/>
+          </a:p>
+        </p:txBody>
+      </p:sp>
+      <p:sp>
+        <p:nvSpPr>
+          <p:cNvPr id="38" name="TextBox 37"/>
+          <p:cNvSpPr txBox="1"/>
+          <p:nvPr/>
+        </p:nvSpPr>
+        <p:spPr>
+          <a:xfrm>
+            <a:off x="1124712" y="18571464"/>
+            <a:ext cx="9994392" cy="402336"/>
+          </a:xfrm>
+          <a:prstGeom prst="rect">
+            <a:avLst/>
+          </a:prstGeom>
+          <a:noFill/>
+        </p:spPr>
+        <p:txBody>
+          <a:bodyPr wrap="square" lIns="36576" rIns="36576" tIns="18288" bIns="18288" anchor="t">
+            <a:spAutoFit/>
+          </a:bodyPr>
+          <a:lstStyle/>
+          <a:p>
+            <a:r>
+              <a:rPr sz="2500" b="1">
+                <a:solidFill>
+                  <a:srgbClr val="163B6C"/>
+                </a:solidFill>
+                <a:latin typeface="Aptos"/>
+              </a:rPr>
+              <a:t>3. Setup / Data / Tasks</a:t>
+            </a:r>
+          </a:p>
+        </p:txBody>
+      </p:sp>
+      <p:sp>
+        <p:nvSpPr>
+          <p:cNvPr id="39" name="Rounded Rectangle 38"/>
+          <p:cNvSpPr/>
+          <p:nvPr/>
+        </p:nvSpPr>
+        <p:spPr>
+          <a:xfrm>
+            <a:off x="1069848" y="19238976"/>
+            <a:ext cx="10113264" cy="2788920"/>
+          </a:xfrm>
+          <a:prstGeom prst="roundRect">
+            <a:avLst>
+              <a:gd name="adj" fmla="val 4000"/>
+            </a:avLst>
+          </a:prstGeom>
+          <a:solidFill>
+            <a:srgbClr val="FFF8E6"/>
+          </a:solidFill>
+          <a:ln w="8255">
+            <a:solidFill>
+              <a:srgbClr val="D2D8E0"/>
+            </a:solidFill>
+          </a:ln>
+        </p:spPr>
+        <p:style>
+          <a:lnRef idx="1">
+            <a:schemeClr val="accent1"/>
+          </a:lnRef>
+          <a:fillRef idx="3">
+            <a:schemeClr val="accent1"/>
+          </a:fillRef>
+          <a:effectRef idx="2">
+            <a:schemeClr val="accent1"/>
+          </a:effectRef>
+          <a:fontRef idx="minor">
+            <a:schemeClr val="lt1"/>
+          </a:fontRef>
+        </p:style>
+        <p:txBody>
+          <a:bodyPr rtlCol="0" anchor="ctr"/>
+          <a:lstStyle/>
+          <a:p>
+            <a:pPr algn="ctr"/>
+          </a:p>
+        </p:txBody>
+      </p:sp>
+      <p:sp>
+        <p:nvSpPr>
+          <p:cNvPr id="40" name="TextBox 39"/>
+          <p:cNvSpPr txBox="1"/>
+          <p:nvPr/>
+        </p:nvSpPr>
+        <p:spPr>
+          <a:xfrm>
+            <a:off x="1234439" y="19366992"/>
+            <a:ext cx="9784080" cy="320040"/>
+          </a:xfrm>
+          <a:prstGeom prst="rect">
+            <a:avLst/>
+          </a:prstGeom>
+          <a:noFill/>
+        </p:spPr>
+        <p:txBody>
+          <a:bodyPr wrap="square" lIns="36576" rIns="36576" tIns="18288" bIns="18288" anchor="t">
+            <a:spAutoFit/>
+          </a:bodyPr>
+          <a:lstStyle/>
+          <a:p>
+            <a:r>
+              <a:rPr sz="1800" b="1">
+                <a:solidFill>
+                  <a:srgbClr val="5B636E"/>
+                </a:solidFill>
+                <a:latin typeface="Aptos"/>
+              </a:rPr>
+              <a:t>Frozen experiment snapshot</a:t>
+            </a:r>
+          </a:p>
+        </p:txBody>
+      </p:sp>
+      <p:sp>
+        <p:nvSpPr>
+          <p:cNvPr id="41" name="TextBox 40"/>
+          <p:cNvSpPr txBox="1"/>
+          <p:nvPr/>
+        </p:nvSpPr>
+        <p:spPr>
+          <a:xfrm>
+            <a:off x="1234439" y="19741896"/>
+            <a:ext cx="9784080" cy="2194560"/>
+          </a:xfrm>
+          <a:prstGeom prst="rect">
+            <a:avLst/>
+          </a:prstGeom>
+          <a:noFill/>
+        </p:spPr>
+        <p:txBody>
+          <a:bodyPr wrap="square" lIns="45720" rIns="45720" tIns="18288">
+            <a:spAutoFit/>
+          </a:bodyPr>
+          <a:lstStyle/>
+          <a:p>
+            <a:pPr>
+              <a:spcAft>
+                <a:spcPts val="400"/>
+              </a:spcAft>
+              <a:defRPr sz="1500">
+                <a:solidFill>
+                  <a:srgbClr val="1F2328"/>
+                </a:solidFill>
+                <a:latin typeface="Aptos"/>
+              </a:defRPr>
+            </a:pPr>
+            <a:r>
+              <a:t>Synthetic benchmark families with train/dev/test_iid/test_ood splits.</a:t>
+            </a:r>
+          </a:p>
+          <a:p>
+            <a:pPr>
+              <a:spcAft>
+                <a:spcPts val="400"/>
+              </a:spcAft>
+              <a:defRPr sz="1500">
+                <a:solidFill>
+                  <a:srgbClr val="1F2328"/>
+                </a:solidFill>
+                <a:latin typeface="Aptos"/>
+              </a:defRPr>
+            </a:pPr>
+            <a:r>
+              <a:t>Three seeds; 10 cases per family; difficulty 0.55.</a:t>
+            </a:r>
+          </a:p>
+          <a:p>
+            <a:pPr>
+              <a:spcAft>
+                <a:spcPts val="400"/>
+              </a:spcAft>
+              <a:defRPr sz="1500">
+                <a:solidFill>
+                  <a:srgbClr val="1F2328"/>
+                </a:solidFill>
+                <a:latin typeface="Aptos"/>
+              </a:defRPr>
+            </a:pPr>
+            <a:r>
+              <a:t>API baseline matrix: 5 models, 1245 predictions.</a:t>
+            </a:r>
+          </a:p>
+          <a:p>
+            <a:pPr>
+              <a:spcAft>
+                <a:spcPts val="400"/>
+              </a:spcAft>
+              <a:defRPr sz="1500">
+                <a:solidFill>
+                  <a:srgbClr val="1F2328"/>
+                </a:solidFill>
+                <a:latin typeface="Aptos"/>
+              </a:defRPr>
+            </a:pPr>
+            <a:r>
+              <a:t>All poster numbers are generated from frozen JSON artifacts.</a:t>
+            </a:r>
+          </a:p>
+        </p:txBody>
+      </p:sp>
+      <p:sp>
+        <p:nvSpPr>
+          <p:cNvPr id="42" name="Rounded Rectangle 41"/>
+          <p:cNvSpPr/>
+          <p:nvPr/>
+        </p:nvSpPr>
+        <p:spPr>
+          <a:xfrm>
+            <a:off x="1069848" y="22311360"/>
+            <a:ext cx="10113264" cy="2148840"/>
+          </a:xfrm>
+          <a:prstGeom prst="roundRect">
+            <a:avLst>
+              <a:gd name="adj" fmla="val 4000"/>
+            </a:avLst>
+          </a:prstGeom>
+          <a:solidFill>
+            <a:srgbClr val="EAF2FF"/>
+          </a:solidFill>
+          <a:ln w="8255">
+            <a:solidFill>
+              <a:srgbClr val="D2D8E0"/>
+            </a:solidFill>
+          </a:ln>
+        </p:spPr>
+        <p:style>
+          <a:lnRef idx="1">
+            <a:schemeClr val="accent1"/>
+          </a:lnRef>
+          <a:fillRef idx="3">
+            <a:schemeClr val="accent1"/>
+          </a:fillRef>
+          <a:effectRef idx="2">
+            <a:schemeClr val="accent1"/>
+          </a:effectRef>
+          <a:fontRef idx="minor">
+            <a:schemeClr val="lt1"/>
+          </a:fontRef>
+        </p:style>
+        <p:txBody>
+          <a:bodyPr rtlCol="0" anchor="ctr"/>
+          <a:lstStyle/>
+          <a:p>
+            <a:pPr algn="ctr"/>
+          </a:p>
+        </p:txBody>
+      </p:sp>
+      <p:sp>
+        <p:nvSpPr>
+          <p:cNvPr id="43" name="TextBox 42"/>
+          <p:cNvSpPr txBox="1"/>
+          <p:nvPr/>
+        </p:nvSpPr>
+        <p:spPr>
+          <a:xfrm>
+            <a:off x="1234439" y="22439376"/>
+            <a:ext cx="9784080" cy="320040"/>
+          </a:xfrm>
+          <a:prstGeom prst="rect">
+            <a:avLst/>
+          </a:prstGeom>
+          <a:noFill/>
+        </p:spPr>
+        <p:txBody>
+          <a:bodyPr wrap="square" lIns="36576" rIns="36576" tIns="18288" bIns="18288" anchor="t">
+            <a:spAutoFit/>
+          </a:bodyPr>
+          <a:lstStyle/>
+          <a:p>
+            <a:r>
+              <a:rPr sz="1800" b="1">
+                <a:solidFill>
+                  <a:srgbClr val="5B636E"/>
+                </a:solidFill>
+                <a:latin typeface="Aptos"/>
+              </a:rPr>
+              <a:t>Validity boundary</a:t>
+            </a:r>
+          </a:p>
+        </p:txBody>
+      </p:sp>
+      <p:sp>
+        <p:nvSpPr>
+          <p:cNvPr id="44" name="TextBox 43"/>
+          <p:cNvSpPr txBox="1"/>
+          <p:nvPr/>
+        </p:nvSpPr>
+        <p:spPr>
+          <a:xfrm>
+            <a:off x="1234439" y="22814280"/>
+            <a:ext cx="9784080" cy="1554480"/>
+          </a:xfrm>
+          <a:prstGeom prst="rect">
+            <a:avLst/>
+          </a:prstGeom>
+          <a:noFill/>
+        </p:spPr>
+        <p:txBody>
+          <a:bodyPr wrap="square" lIns="45720" rIns="45720" tIns="18288">
+            <a:spAutoFit/>
+          </a:bodyPr>
+          <a:lstStyle/>
+          <a:p>
+            <a:pPr>
+              <a:spcAft>
+                <a:spcPts val="400"/>
+              </a:spcAft>
+              <a:defRPr sz="1500">
+                <a:solidFill>
+                  <a:srgbClr val="1F2328"/>
+                </a:solidFill>
+                <a:latin typeface="Aptos"/>
+              </a:defRPr>
+            </a:pPr>
+            <a:r>
+              <a:t>Prompt-protocol-specific API baselines, not universal LLM claims.</a:t>
+            </a:r>
+          </a:p>
+          <a:p>
+            <a:pPr>
+              <a:spcAft>
+                <a:spcPts val="400"/>
+              </a:spcAft>
+              <a:defRPr sz="1500">
+                <a:solidFill>
+                  <a:srgbClr val="1F2328"/>
+                </a:solidFill>
+                <a:latin typeface="Aptos"/>
+              </a:defRPr>
+            </a:pPr>
+            <a:r>
+              <a:t>Graph/mechanism OOD buckets are saturated smoke tests.</a:t>
+            </a:r>
+          </a:p>
+          <a:p>
+            <a:pPr>
+              <a:spcAft>
+                <a:spcPts val="400"/>
+              </a:spcAft>
+              <a:defRPr sz="1500">
+                <a:solidFill>
+                  <a:srgbClr val="1F2328"/>
+                </a:solidFill>
+                <a:latin typeface="Aptos"/>
+              </a:defRPr>
+            </a:pPr>
+            <a:r>
+              <a:t>Release requires larger synthetic runs and real-grounded dual audit.</a:t>
+            </a:r>
+          </a:p>
+        </p:txBody>
+      </p:sp>
+      <p:sp>
+        <p:nvSpPr>
+          <p:cNvPr id="45" name="Rounded Rectangle 44"/>
+          <p:cNvSpPr/>
+          <p:nvPr/>
+        </p:nvSpPr>
+        <p:spPr>
+          <a:xfrm>
+            <a:off x="11951208" y="3995928"/>
+            <a:ext cx="10652760" cy="21406104"/>
+          </a:xfrm>
+          <a:prstGeom prst="roundRect">
+            <a:avLst>
+              <a:gd name="adj" fmla="val 4000"/>
+            </a:avLst>
+          </a:prstGeom>
+          <a:solidFill>
+            <a:srgbClr val="FFFFFF"/>
+          </a:solidFill>
+          <a:ln w="10160">
+            <a:solidFill>
+              <a:srgbClr val="D2D8E0"/>
+            </a:solidFill>
+          </a:ln>
+        </p:spPr>
+        <p:style>
+          <a:lnRef idx="1">
+            <a:schemeClr val="accent1"/>
+          </a:lnRef>
+          <a:fillRef idx="3">
+            <a:schemeClr val="accent1"/>
+          </a:fillRef>
+          <a:effectRef idx="2">
+            <a:schemeClr val="accent1"/>
+          </a:effectRef>
+          <a:fontRef idx="minor">
+            <a:schemeClr val="lt1"/>
+          </a:fontRef>
+        </p:style>
+        <p:txBody>
+          <a:bodyPr rtlCol="0" anchor="ctr"/>
+          <a:lstStyle/>
+          <a:p>
+            <a:pPr algn="ctr"/>
+          </a:p>
+        </p:txBody>
+      </p:sp>
+      <p:sp>
+        <p:nvSpPr>
+          <p:cNvPr id="46" name="Rounded Rectangle 45"/>
+          <p:cNvSpPr/>
+          <p:nvPr/>
+        </p:nvSpPr>
+        <p:spPr>
+          <a:xfrm>
+            <a:off x="12124944" y="4197096"/>
+            <a:ext cx="10305288" cy="557784"/>
+          </a:xfrm>
+          <a:prstGeom prst="roundRect">
+            <a:avLst>
+              <a:gd name="adj" fmla="val 8000"/>
+            </a:avLst>
+          </a:prstGeom>
+          <a:solidFill>
+            <a:srgbClr val="EAF2FF"/>
+          </a:solidFill>
+          <a:ln>
+            <a:solidFill>
+              <a:srgbClr val="EAF2FF"/>
+            </a:solidFill>
+          </a:ln>
+        </p:spPr>
+        <p:style>
+          <a:lnRef idx="1">
+            <a:schemeClr val="accent1"/>
+          </a:lnRef>
+          <a:fillRef idx="3">
+            <a:schemeClr val="accent1"/>
+          </a:fillRef>
+          <a:effectRef idx="2">
+            <a:schemeClr val="accent1"/>
+          </a:effectRef>
+          <a:fontRef idx="minor">
+            <a:schemeClr val="lt1"/>
+          </a:fontRef>
+        </p:style>
+        <p:txBody>
+          <a:bodyPr rtlCol="0" anchor="ctr"/>
+          <a:lstStyle/>
+          <a:p>
+            <a:pPr algn="ctr"/>
+          </a:p>
+        </p:txBody>
+      </p:sp>
+      <p:sp>
+        <p:nvSpPr>
+          <p:cNvPr id="47" name="TextBox 46"/>
+          <p:cNvSpPr txBox="1"/>
+          <p:nvPr/>
+        </p:nvSpPr>
+        <p:spPr>
+          <a:xfrm>
+            <a:off x="12280392" y="4242816"/>
+            <a:ext cx="9994392" cy="402336"/>
+          </a:xfrm>
+          <a:prstGeom prst="rect">
+            <a:avLst/>
+          </a:prstGeom>
+          <a:noFill/>
+        </p:spPr>
+        <p:txBody>
+          <a:bodyPr wrap="square" lIns="36576" rIns="36576" tIns="18288" bIns="18288" anchor="t">
+            <a:spAutoFit/>
+          </a:bodyPr>
+          <a:lstStyle/>
+          <a:p>
+            <a:r>
+              <a:rPr sz="2500" b="1">
+                <a:solidFill>
+                  <a:srgbClr val="163B6C"/>
+                </a:solidFill>
+                <a:latin typeface="Aptos"/>
+              </a:rPr>
+              <a:t>4. Main Technical Details</a:t>
+            </a:r>
+          </a:p>
+        </p:txBody>
+      </p:sp>
+      <p:sp>
+        <p:nvSpPr>
+          <p:cNvPr id="48" name="TextBox 47"/>
+          <p:cNvSpPr txBox="1"/>
+          <p:nvPr/>
+        </p:nvSpPr>
+        <p:spPr>
+          <a:xfrm>
+            <a:off x="12243816" y="4791456"/>
+            <a:ext cx="10076688" cy="1005840"/>
+          </a:xfrm>
+          <a:prstGeom prst="rect">
+            <a:avLst/>
+          </a:prstGeom>
+          <a:noFill/>
+        </p:spPr>
+        <p:txBody>
+          <a:bodyPr wrap="square" lIns="36576" rIns="36576" tIns="18288" bIns="18288" anchor="t">
+            <a:spAutoFit/>
+          </a:bodyPr>
+          <a:lstStyle/>
+          <a:p>
+            <a:r>
+              <a:rPr sz="1600" b="0">
+                <a:solidFill>
+                  <a:srgbClr val="1F2328"/>
+                </a:solidFill>
+                <a:latin typeface="Aptos"/>
+              </a:rPr>
+              <a:t>The technical object is selective causal verification: accept identifiable valid/invalid claims, but refuse when public evidence admits multiple compatible causal worlds.</a:t>
+            </a:r>
+          </a:p>
+        </p:txBody>
+      </p:sp>
+      <p:sp>
+        <p:nvSpPr>
+          <p:cNvPr id="49" name="Rounded Rectangle 48"/>
+          <p:cNvSpPr/>
+          <p:nvPr/>
+        </p:nvSpPr>
+        <p:spPr>
+          <a:xfrm>
+            <a:off x="12225528" y="5961888"/>
+            <a:ext cx="10113264" cy="1783080"/>
+          </a:xfrm>
+          <a:prstGeom prst="roundRect">
+            <a:avLst>
+              <a:gd name="adj" fmla="val 4000"/>
+            </a:avLst>
+          </a:prstGeom>
+          <a:solidFill>
+            <a:srgbClr val="EAF2FF"/>
+          </a:solidFill>
+          <a:ln w="10160">
+            <a:solidFill>
+              <a:srgbClr val="5B8DEF"/>
+            </a:solidFill>
+          </a:ln>
+        </p:spPr>
+        <p:style>
+          <a:lnRef idx="1">
+            <a:schemeClr val="accent1"/>
+          </a:lnRef>
+          <a:fillRef idx="3">
+            <a:schemeClr val="accent1"/>
+          </a:fillRef>
+          <a:effectRef idx="2">
+            <a:schemeClr val="accent1"/>
+          </a:effectRef>
+          <a:fontRef idx="minor">
+            <a:schemeClr val="lt1"/>
+          </a:fontRef>
+        </p:style>
+        <p:txBody>
+          <a:bodyPr rtlCol="0" anchor="ctr"/>
+          <a:lstStyle/>
+          <a:p>
+            <a:pPr algn="ctr"/>
+          </a:p>
+        </p:txBody>
+      </p:sp>
+      <p:sp>
+        <p:nvSpPr>
+          <p:cNvPr id="50" name="TextBox 49"/>
+          <p:cNvSpPr txBox="1"/>
+          <p:nvPr/>
+        </p:nvSpPr>
+        <p:spPr>
+          <a:xfrm>
+            <a:off x="12454128" y="6245352"/>
+            <a:ext cx="9646920" cy="502920"/>
+          </a:xfrm>
+          <a:prstGeom prst="rect">
+            <a:avLst/>
+          </a:prstGeom>
+          <a:noFill/>
+        </p:spPr>
+        <p:txBody>
+          <a:bodyPr wrap="square" lIns="36576" rIns="36576" tIns="18288" bIns="18288" anchor="t">
+            <a:spAutoFit/>
+          </a:bodyPr>
+          <a:lstStyle/>
+          <a:p>
+            <a:pPr algn="ctr"/>
+            <a:r>
+              <a:rPr sz="1800" b="1">
+                <a:solidFill>
+                  <a:srgbClr val="2060B4"/>
+                </a:solidFill>
+                <a:latin typeface="Aptos"/>
+              </a:rPr>
+              <a:t>Selective target: maximize OOD accuracy while minimizing unsafe acceptance and over-refusal.</a:t>
+            </a:r>
+          </a:p>
+        </p:txBody>
+      </p:sp>
+      <p:sp>
+        <p:nvSpPr>
+          <p:cNvPr id="51" name="TextBox 50"/>
+          <p:cNvSpPr txBox="1"/>
+          <p:nvPr/>
+        </p:nvSpPr>
+        <p:spPr>
+          <a:xfrm>
+            <a:off x="12481560" y="6812280"/>
+            <a:ext cx="9601200" cy="320040"/>
+          </a:xfrm>
+          <a:prstGeom prst="rect">
+            <a:avLst/>
+          </a:prstGeom>
+          <a:noFill/>
+        </p:spPr>
+        <p:txBody>
+          <a:bodyPr wrap="square" lIns="36576" rIns="36576" tIns="18288" bIns="18288" anchor="t">
+            <a:spAutoFit/>
+          </a:bodyPr>
+          <a:lstStyle/>
+          <a:p>
+            <a:pPr algn="ctr"/>
+            <a:r>
+              <a:rPr sz="1300" b="0">
+                <a:solidFill>
+                  <a:srgbClr val="5B636E"/>
+                </a:solidFill>
+                <a:latin typeface="Aptos"/>
+              </a:rPr>
+              <a:t>Key mechanism: public-compatible countermodels witness missing identification assumptions.</a:t>
+            </a:r>
+          </a:p>
+        </p:txBody>
+      </p:sp>
+      <p:sp>
+        <p:nvSpPr>
+          <p:cNvPr id="52" name="Rounded Rectangle 51"/>
+          <p:cNvSpPr/>
+          <p:nvPr/>
+        </p:nvSpPr>
+        <p:spPr>
+          <a:xfrm>
+            <a:off x="12225528" y="8001000"/>
+            <a:ext cx="10113264" cy="2743200"/>
+          </a:xfrm>
+          <a:prstGeom prst="roundRect">
+            <a:avLst>
+              <a:gd name="adj" fmla="val 4000"/>
+            </a:avLst>
+          </a:prstGeom>
+          <a:solidFill>
+            <a:srgbClr val="EAF7EE"/>
+          </a:solidFill>
+          <a:ln w="8255">
+            <a:solidFill>
+              <a:srgbClr val="D2D8E0"/>
+            </a:solidFill>
+          </a:ln>
+        </p:spPr>
+        <p:style>
+          <a:lnRef idx="1">
+            <a:schemeClr val="accent1"/>
+          </a:lnRef>
+          <a:fillRef idx="3">
+            <a:schemeClr val="accent1"/>
+          </a:fillRef>
+          <a:effectRef idx="2">
+            <a:schemeClr val="accent1"/>
+          </a:effectRef>
+          <a:fontRef idx="minor">
+            <a:schemeClr val="lt1"/>
+          </a:fontRef>
+        </p:style>
+        <p:txBody>
+          <a:bodyPr rtlCol="0" anchor="ctr"/>
+          <a:lstStyle/>
+          <a:p>
+            <a:pPr algn="ctr"/>
+          </a:p>
+        </p:txBody>
+      </p:sp>
+      <p:sp>
+        <p:nvSpPr>
+          <p:cNvPr id="53" name="TextBox 52"/>
+          <p:cNvSpPr txBox="1"/>
+          <p:nvPr/>
+        </p:nvSpPr>
+        <p:spPr>
+          <a:xfrm>
+            <a:off x="12390119" y="8129016"/>
+            <a:ext cx="9784080" cy="320040"/>
+          </a:xfrm>
+          <a:prstGeom prst="rect">
+            <a:avLst/>
+          </a:prstGeom>
+          <a:noFill/>
+        </p:spPr>
+        <p:txBody>
+          <a:bodyPr wrap="square" lIns="36576" rIns="36576" tIns="18288" bIns="18288" anchor="t">
+            <a:spAutoFit/>
+          </a:bodyPr>
+          <a:lstStyle/>
+          <a:p>
+            <a:r>
+              <a:rPr sz="1800" b="1">
+                <a:solidFill>
+                  <a:srgbClr val="5B636E"/>
+                </a:solidFill>
+                <a:latin typeface="Aptos"/>
+              </a:rPr>
+              <a:t>Interpretation</a:t>
+            </a:r>
+          </a:p>
+        </p:txBody>
+      </p:sp>
+      <p:sp>
+        <p:nvSpPr>
+          <p:cNvPr id="54" name="TextBox 53"/>
+          <p:cNvSpPr txBox="1"/>
+          <p:nvPr/>
+        </p:nvSpPr>
+        <p:spPr>
+          <a:xfrm>
+            <a:off x="12390119" y="8503920"/>
+            <a:ext cx="9784080" cy="2148840"/>
+          </a:xfrm>
+          <a:prstGeom prst="rect">
+            <a:avLst/>
+          </a:prstGeom>
+          <a:noFill/>
+        </p:spPr>
+        <p:txBody>
+          <a:bodyPr wrap="square" lIns="45720" rIns="45720" tIns="18288">
+            <a:spAutoFit/>
+          </a:bodyPr>
+          <a:lstStyle/>
+          <a:p>
+            <a:pPr>
+              <a:spcAft>
+                <a:spcPts val="400"/>
+              </a:spcAft>
+              <a:defRPr sz="1400">
+                <a:solidFill>
+                  <a:srgbClr val="1F2328"/>
+                </a:solidFill>
+                <a:latin typeface="Aptos"/>
+              </a:defRPr>
+            </a:pPr>
+            <a:r>
+              <a:t>A countermodel witness supports UNIDENTIFIABLE rather than forcing binary validity.</a:t>
+            </a:r>
+          </a:p>
+          <a:p>
+            <a:pPr>
+              <a:spcAft>
+                <a:spcPts val="400"/>
+              </a:spcAft>
+              <a:defRPr sz="1400">
+                <a:solidFill>
+                  <a:srgbClr val="1F2328"/>
+                </a:solidFill>
+                <a:latin typeface="Aptos"/>
+              </a:defRPr>
+            </a:pPr>
+            <a:r>
+              <a:t>Pearl-style tools constrain the verifier but do not expose evaluator-only labels.</a:t>
+            </a:r>
+          </a:p>
+          <a:p>
+            <a:pPr>
+              <a:spcAft>
+                <a:spcPts val="400"/>
+              </a:spcAft>
+              <a:defRPr sz="1400">
+                <a:solidFill>
+                  <a:srgbClr val="1F2328"/>
+                </a:solidFill>
+                <a:latin typeface="Aptos"/>
+              </a:defRPr>
+            </a:pPr>
+            <a:r>
+              <a:t>The design targets unsafe acceptance without collapsing into blanket refusal.</a:t>
+            </a:r>
+          </a:p>
+        </p:txBody>
+      </p:sp>
+      <p:sp>
+        <p:nvSpPr>
+          <p:cNvPr id="55" name="Rectangle 54"/>
+          <p:cNvSpPr/>
+          <p:nvPr/>
+        </p:nvSpPr>
+        <p:spPr>
+          <a:xfrm>
+            <a:off x="12225528" y="11018520"/>
+            <a:ext cx="10113264" cy="4709160"/>
+          </a:xfrm>
+          <a:prstGeom prst="rect">
+            <a:avLst/>
+          </a:prstGeom>
+          <a:solidFill>
+            <a:srgbClr val="FFFFFF"/>
+          </a:solidFill>
+          <a:ln w="10160">
+            <a:solidFill>
+              <a:srgbClr val="5B8DEF"/>
+            </a:solidFill>
+          </a:ln>
+        </p:spPr>
+        <p:style>
+          <a:lnRef idx="1">
+            <a:schemeClr val="accent1"/>
+          </a:lnRef>
+          <a:fillRef idx="3">
+            <a:schemeClr val="accent1"/>
+          </a:fillRef>
+          <a:effectRef idx="2">
+            <a:schemeClr val="accent1"/>
+          </a:effectRef>
+          <a:fontRef idx="minor">
+            <a:schemeClr val="lt1"/>
+          </a:fontRef>
+        </p:style>
+        <p:txBody>
+          <a:bodyPr rtlCol="0" anchor="ctr"/>
+          <a:lstStyle/>
+          <a:p>
+            <a:pPr algn="ctr"/>
+          </a:p>
+        </p:txBody>
+      </p:sp>
       <p:pic>
         <p:nvPicPr>
-          <p:cNvPr id="19" name="Picture 18" descr="main_chart.png"/>
+          <p:cNvPr id="56" name="Picture 55" descr="ood_chart.png"/>
           <p:cNvPicPr>
             <a:picLocks noChangeAspect="1"/>
           </p:cNvPicPr>
@@ -3836,8 +5494,8 @@
         </p:blipFill>
         <p:spPr>
           <a:xfrm>
-            <a:off x="4892040" y="1298448"/>
-            <a:ext cx="4800600" cy="2468880"/>
+            <a:off x="12733020" y="11201400"/>
+            <a:ext cx="9098280" cy="4549140"/>
           </a:xfrm>
           <a:prstGeom prst="rect">
             <a:avLst/>
@@ -3846,128 +5504,27 @@
       </p:pic>
       <p:sp>
         <p:nvSpPr>
-          <p:cNvPr id="20" name="TextBox 19"/>
-          <p:cNvSpPr txBox="1"/>
-          <p:nvPr/>
-        </p:nvSpPr>
-        <p:spPr>
-          <a:xfrm>
-            <a:off x="5029200" y="4096512"/>
-            <a:ext cx="4434840" cy="777240"/>
-          </a:xfrm>
-          <a:prstGeom prst="rect">
-            <a:avLst/>
-          </a:prstGeom>
-          <a:noFill/>
-        </p:spPr>
-        <p:txBody>
-          <a:bodyPr wrap="none" lIns="45720" rIns="45720" tIns="18288">
-            <a:spAutoFit/>
-          </a:bodyPr>
-          <a:lstStyle/>
-          <a:p>
-            <a:pPr>
-              <a:spcAft>
-                <a:spcPts val="400"/>
-              </a:spcAft>
-              <a:defRPr sz="1200">
-                <a:solidFill>
-                  <a:srgbClr val="1F2328"/>
-                </a:solidFill>
-                <a:latin typeface="Aptos"/>
-              </a:defRPr>
-            </a:pPr>
-            <a:r>
-              <a:t>Ours: OOD acc 0.891, unsafe accept 0.000.</a:t>
-            </a:r>
-          </a:p>
-          <a:p>
-            <a:pPr>
-              <a:spcAft>
-                <a:spcPts val="400"/>
-              </a:spcAft>
-              <a:defRPr sz="1200">
-                <a:solidFill>
-                  <a:srgbClr val="1F2328"/>
-                </a:solidFill>
-                <a:latin typeface="Aptos"/>
-              </a:defRPr>
-            </a:pPr>
-            <a:r>
-              <a:t>GPT-5.5 prompt baseline: OOD acc 0.545, unsafe accept 0.071.</a:t>
-            </a:r>
-          </a:p>
-          <a:p>
-            <a:pPr>
-              <a:spcAft>
-                <a:spcPts val="400"/>
-              </a:spcAft>
-              <a:defRPr sz="1200">
-                <a:solidFill>
-                  <a:srgbClr val="1F2328"/>
-                </a:solidFill>
-                <a:latin typeface="Aptos"/>
-              </a:defRPr>
-            </a:pPr>
-            <a:r>
-              <a:t>Interpretation: current prompt baselines expose the selective-refusal gap.</a:t>
-            </a:r>
-          </a:p>
-        </p:txBody>
-      </p:sp>
-      <p:sp>
-        <p:nvSpPr>
-          <p:cNvPr id="21" name="TextBox 20"/>
-          <p:cNvSpPr txBox="1"/>
-          <p:nvPr/>
-        </p:nvSpPr>
-        <p:spPr>
-          <a:xfrm>
-            <a:off x="4983480" y="5166360"/>
-            <a:ext cx="4572000" cy="228600"/>
-          </a:xfrm>
-          <a:prstGeom prst="rect">
-            <a:avLst/>
-          </a:prstGeom>
-          <a:noFill/>
-        </p:spPr>
-        <p:txBody>
-          <a:bodyPr wrap="none" lIns="36576" rIns="36576" tIns="18288" bIns="18288" anchor="t">
-            <a:spAutoFit/>
-          </a:bodyPr>
-          <a:lstStyle/>
-          <a:p>
-            <a:r>
-              <a:rPr sz="1600" b="1">
-                <a:solidFill>
-                  <a:srgbClr val="145388"/>
-                </a:solidFill>
-                <a:latin typeface="Aptos"/>
-              </a:rPr>
-              <a:t>Ablation</a:t>
-            </a:r>
-          </a:p>
-        </p:txBody>
-      </p:sp>
-      <p:sp>
-        <p:nvSpPr>
-          <p:cNvPr id="22" name="Rectangle 21"/>
+          <p:cNvPr id="57" name="Rounded Rectangle 56"/>
           <p:cNvSpPr/>
           <p:nvPr/>
         </p:nvSpPr>
         <p:spPr>
           <a:xfrm>
-            <a:off x="4983480" y="5422392"/>
-            <a:ext cx="4572000" cy="13716"/>
-          </a:xfrm>
-          <a:prstGeom prst="rect">
-            <a:avLst/>
+            <a:off x="12225528" y="16139159"/>
+            <a:ext cx="10113264" cy="2194560"/>
+          </a:xfrm>
+          <a:prstGeom prst="roundRect">
+            <a:avLst>
+              <a:gd name="adj" fmla="val 4000"/>
+            </a:avLst>
           </a:prstGeom>
           <a:solidFill>
-            <a:srgbClr val="145388"/>
+            <a:srgbClr val="FFF8E6"/>
           </a:solidFill>
-          <a:ln>
-            <a:noFill/>
+          <a:ln w="8255">
+            <a:solidFill>
+              <a:srgbClr val="D2D8E0"/>
+            </a:solidFill>
           </a:ln>
         </p:spPr>
         <p:style>
@@ -3992,9 +5549,159 @@
           </a:p>
         </p:txBody>
       </p:sp>
+      <p:sp>
+        <p:nvSpPr>
+          <p:cNvPr id="58" name="TextBox 57"/>
+          <p:cNvSpPr txBox="1"/>
+          <p:nvPr/>
+        </p:nvSpPr>
+        <p:spPr>
+          <a:xfrm>
+            <a:off x="12390119" y="16267176"/>
+            <a:ext cx="9784080" cy="320040"/>
+          </a:xfrm>
+          <a:prstGeom prst="rect">
+            <a:avLst/>
+          </a:prstGeom>
+          <a:noFill/>
+        </p:spPr>
+        <p:txBody>
+          <a:bodyPr wrap="square" lIns="36576" rIns="36576" tIns="18288" bIns="18288" anchor="t">
+            <a:spAutoFit/>
+          </a:bodyPr>
+          <a:lstStyle/>
+          <a:p>
+            <a:r>
+              <a:rPr sz="1800" b="1">
+                <a:solidFill>
+                  <a:srgbClr val="5B636E"/>
+                </a:solidFill>
+                <a:latin typeface="Aptos"/>
+              </a:rPr>
+              <a:t>OOD stress reading</a:t>
+            </a:r>
+          </a:p>
+        </p:txBody>
+      </p:sp>
+      <p:sp>
+        <p:nvSpPr>
+          <p:cNvPr id="59" name="TextBox 58"/>
+          <p:cNvSpPr txBox="1"/>
+          <p:nvPr/>
+        </p:nvSpPr>
+        <p:spPr>
+          <a:xfrm>
+            <a:off x="12390119" y="16642080"/>
+            <a:ext cx="9784080" cy="1600200"/>
+          </a:xfrm>
+          <a:prstGeom prst="rect">
+            <a:avLst/>
+          </a:prstGeom>
+          <a:noFill/>
+        </p:spPr>
+        <p:txBody>
+          <a:bodyPr wrap="square" lIns="45720" rIns="45720" tIns="18288">
+            <a:spAutoFit/>
+          </a:bodyPr>
+          <a:lstStyle/>
+          <a:p>
+            <a:pPr>
+              <a:spcAft>
+                <a:spcPts val="400"/>
+              </a:spcAft>
+              <a:defRPr sz="1500">
+                <a:solidFill>
+                  <a:srgbClr val="1F2328"/>
+                </a:solidFill>
+                <a:latin typeface="Aptos"/>
+              </a:defRPr>
+            </a:pPr>
+            <a:r>
+              <a:t>Paired-flip is the clearest current failure slice: acc 0.439.</a:t>
+            </a:r>
+          </a:p>
+          <a:p>
+            <a:pPr>
+              <a:spcAft>
+                <a:spcPts val="400"/>
+              </a:spcAft>
+              <a:defRPr sz="1500">
+                <a:solidFill>
+                  <a:srgbClr val="1F2328"/>
+                </a:solidFill>
+                <a:latin typeface="Aptos"/>
+              </a:defRPr>
+            </a:pPr>
+            <a:r>
+              <a:t>Graph/mechanism buckets are saturated smoke tests.</a:t>
+            </a:r>
+          </a:p>
+          <a:p>
+            <a:pPr>
+              <a:spcAft>
+                <a:spcPts val="400"/>
+              </a:spcAft>
+              <a:defRPr sz="1500">
+                <a:solidFill>
+                  <a:srgbClr val="1F2328"/>
+                </a:solidFill>
+                <a:latin typeface="Aptos"/>
+              </a:defRPr>
+            </a:pPr>
+            <a:r>
+              <a:t>Use these buckets as diagnostics, not final robustness proof.</a:t>
+            </a:r>
+          </a:p>
+        </p:txBody>
+      </p:sp>
+      <p:sp>
+        <p:nvSpPr>
+          <p:cNvPr id="60" name="Rectangle 59"/>
+          <p:cNvSpPr/>
+          <p:nvPr/>
+        </p:nvSpPr>
+        <p:spPr>
+          <a:xfrm>
+            <a:off x="12225528" y="18790920"/>
+            <a:ext cx="10113264" cy="5166360"/>
+          </a:xfrm>
+          <a:prstGeom prst="rect">
+            <a:avLst/>
+          </a:prstGeom>
+          <a:solidFill>
+            <a:srgbClr val="FFFFFF"/>
+          </a:solidFill>
+          <a:ln w="10160">
+            <a:solidFill>
+              <a:srgbClr val="5B8DEF"/>
+            </a:solidFill>
+          </a:ln>
+        </p:spPr>
+        <p:style>
+          <a:lnRef idx="1">
+            <a:schemeClr val="accent1"/>
+          </a:lnRef>
+          <a:fillRef idx="3">
+            <a:schemeClr val="accent1"/>
+          </a:fillRef>
+          <a:effectRef idx="2">
+            <a:schemeClr val="accent1"/>
+          </a:effectRef>
+          <a:fontRef idx="minor">
+            <a:schemeClr val="lt1"/>
+          </a:fontRef>
+        </p:style>
+        <p:txBody>
+          <a:bodyPr rtlCol="0" anchor="ctr"/>
+          <a:lstStyle/>
+          <a:p>
+            <a:pPr algn="ctr"/>
+          </a:p>
+        </p:txBody>
+      </p:sp>
       <p:pic>
         <p:nvPicPr>
-          <p:cNvPr id="23" name="Picture 22" descr="ablation_chart.png"/>
+          <p:cNvPr id="61" name="Picture 60" descr="ablation_chart.png"/>
           <p:cNvPicPr>
             <a:picLocks noChangeAspect="1"/>
           </p:cNvPicPr>
@@ -4008,8 +5715,8 @@
         </p:blipFill>
         <p:spPr>
           <a:xfrm>
-            <a:off x="4892040" y="5486400"/>
-            <a:ext cx="4800600" cy="2468880"/>
+            <a:off x="12687300" y="18973800"/>
+            <a:ext cx="9189720" cy="4529219"/>
           </a:xfrm>
           <a:prstGeom prst="rect">
             <a:avLst/>
@@ -4018,14 +5725,14 @@
       </p:pic>
       <p:sp>
         <p:nvSpPr>
-          <p:cNvPr id="24" name="TextBox 23"/>
+          <p:cNvPr id="62" name="TextBox 61"/>
           <p:cNvSpPr txBox="1"/>
           <p:nvPr/>
         </p:nvSpPr>
         <p:spPr>
           <a:xfrm>
-            <a:off x="9921240" y="960120"/>
-            <a:ext cx="4297680" cy="228600"/>
+            <a:off x="12527280" y="24094440"/>
+            <a:ext cx="9509760" cy="320040"/>
           </a:xfrm>
           <a:prstGeom prst="rect">
             <a:avLst/>
@@ -4033,42 +5740,47 @@
           <a:noFill/>
         </p:spPr>
         <p:txBody>
-          <a:bodyPr wrap="none" lIns="36576" rIns="36576" tIns="18288" bIns="18288" anchor="t">
+          <a:bodyPr wrap="square" lIns="36576" rIns="36576" tIns="18288" bIns="18288" anchor="t">
             <a:spAutoFit/>
           </a:bodyPr>
           <a:lstStyle/>
           <a:p>
-            <a:r>
-              <a:rPr sz="1600" b="1">
-                <a:solidFill>
-                  <a:srgbClr val="145388"/>
+            <a:pPr algn="ctr"/>
+            <a:r>
+              <a:rPr sz="1200" b="0">
+                <a:solidFill>
+                  <a:srgbClr val="5B636E"/>
                 </a:solidFill>
                 <a:latin typeface="Aptos"/>
               </a:rPr>
-              <a:t>OOD Stress</a:t>
-            </a:r>
-          </a:p>
-        </p:txBody>
-      </p:sp>
-      <p:sp>
-        <p:nvSpPr>
-          <p:cNvPr id="25" name="Rectangle 24"/>
+              <a:t>Ablation uses four frozen component variants; bubble size encodes OOD accuracy.</a:t>
+            </a:r>
+          </a:p>
+        </p:txBody>
+      </p:sp>
+      <p:sp>
+        <p:nvSpPr>
+          <p:cNvPr id="63" name="Rounded Rectangle 62"/>
           <p:cNvSpPr/>
           <p:nvPr/>
         </p:nvSpPr>
         <p:spPr>
           <a:xfrm>
-            <a:off x="9921240" y="1216152"/>
-            <a:ext cx="4297680" cy="13716"/>
-          </a:xfrm>
-          <a:prstGeom prst="rect">
-            <a:avLst/>
+            <a:off x="23116032" y="3995928"/>
+            <a:ext cx="10652760" cy="8887968"/>
+          </a:xfrm>
+          <a:prstGeom prst="roundRect">
+            <a:avLst>
+              <a:gd name="adj" fmla="val 4000"/>
+            </a:avLst>
           </a:prstGeom>
           <a:solidFill>
-            <a:srgbClr val="145388"/>
+            <a:srgbClr val="FFFFFF"/>
           </a:solidFill>
-          <a:ln>
-            <a:noFill/>
+          <a:ln w="10160">
+            <a:solidFill>
+              <a:srgbClr val="D2D8E0"/>
+            </a:solidFill>
           </a:ln>
         </p:spPr>
         <p:style>
@@ -4093,9 +5805,169 @@
           </a:p>
         </p:txBody>
       </p:sp>
+      <p:sp>
+        <p:nvSpPr>
+          <p:cNvPr id="64" name="Rounded Rectangle 63"/>
+          <p:cNvSpPr/>
+          <p:nvPr/>
+        </p:nvSpPr>
+        <p:spPr>
+          <a:xfrm>
+            <a:off x="23289768" y="4197096"/>
+            <a:ext cx="10305288" cy="557784"/>
+          </a:xfrm>
+          <a:prstGeom prst="roundRect">
+            <a:avLst>
+              <a:gd name="adj" fmla="val 8000"/>
+            </a:avLst>
+          </a:prstGeom>
+          <a:solidFill>
+            <a:srgbClr val="EAF2FF"/>
+          </a:solidFill>
+          <a:ln>
+            <a:solidFill>
+              <a:srgbClr val="EAF2FF"/>
+            </a:solidFill>
+          </a:ln>
+        </p:spPr>
+        <p:style>
+          <a:lnRef idx="1">
+            <a:schemeClr val="accent1"/>
+          </a:lnRef>
+          <a:fillRef idx="3">
+            <a:schemeClr val="accent1"/>
+          </a:fillRef>
+          <a:effectRef idx="2">
+            <a:schemeClr val="accent1"/>
+          </a:effectRef>
+          <a:fontRef idx="minor">
+            <a:schemeClr val="lt1"/>
+          </a:fontRef>
+        </p:style>
+        <p:txBody>
+          <a:bodyPr rtlCol="0" anchor="ctr"/>
+          <a:lstStyle/>
+          <a:p>
+            <a:pPr algn="ctr"/>
+          </a:p>
+        </p:txBody>
+      </p:sp>
+      <p:sp>
+        <p:nvSpPr>
+          <p:cNvPr id="65" name="TextBox 64"/>
+          <p:cNvSpPr txBox="1"/>
+          <p:nvPr/>
+        </p:nvSpPr>
+        <p:spPr>
+          <a:xfrm>
+            <a:off x="23445216" y="4242816"/>
+            <a:ext cx="9994392" cy="402336"/>
+          </a:xfrm>
+          <a:prstGeom prst="rect">
+            <a:avLst/>
+          </a:prstGeom>
+          <a:noFill/>
+        </p:spPr>
+        <p:txBody>
+          <a:bodyPr wrap="square" lIns="36576" rIns="36576" tIns="18288" bIns="18288" anchor="t">
+            <a:spAutoFit/>
+          </a:bodyPr>
+          <a:lstStyle/>
+          <a:p>
+            <a:r>
+              <a:rPr sz="2500" b="1">
+                <a:solidFill>
+                  <a:srgbClr val="163B6C"/>
+                </a:solidFill>
+                <a:latin typeface="Aptos"/>
+              </a:rPr>
+              <a:t>5. Main Results / Examples</a:t>
+            </a:r>
+          </a:p>
+        </p:txBody>
+      </p:sp>
+      <p:sp>
+        <p:nvSpPr>
+          <p:cNvPr id="66" name="TextBox 65"/>
+          <p:cNvSpPr txBox="1"/>
+          <p:nvPr/>
+        </p:nvSpPr>
+        <p:spPr>
+          <a:xfrm>
+            <a:off x="23399496" y="4791456"/>
+            <a:ext cx="10076688" cy="868680"/>
+          </a:xfrm>
+          <a:prstGeom prst="rect">
+            <a:avLst/>
+          </a:prstGeom>
+          <a:noFill/>
+        </p:spPr>
+        <p:txBody>
+          <a:bodyPr wrap="square" lIns="36576" rIns="36576" tIns="18288" bIns="18288" anchor="t">
+            <a:spAutoFit/>
+          </a:bodyPr>
+          <a:lstStyle/>
+          <a:p>
+            <a:r>
+              <a:rPr sz="1600" b="0">
+                <a:solidFill>
+                  <a:srgbClr val="1F2328"/>
+                </a:solidFill>
+                <a:latin typeface="Aptos"/>
+              </a:rPr>
+              <a:t>The strongest quantitative evidence is the selective OOD tradeoff, followed by bucket-level stress tests and component ablations.</a:t>
+            </a:r>
+          </a:p>
+        </p:txBody>
+      </p:sp>
+      <p:sp>
+        <p:nvSpPr>
+          <p:cNvPr id="67" name="Rectangle 66"/>
+          <p:cNvSpPr/>
+          <p:nvPr/>
+        </p:nvSpPr>
+        <p:spPr>
+          <a:xfrm>
+            <a:off x="23381208" y="5623560"/>
+            <a:ext cx="10113264" cy="4663440"/>
+          </a:xfrm>
+          <a:prstGeom prst="rect">
+            <a:avLst/>
+          </a:prstGeom>
+          <a:solidFill>
+            <a:srgbClr val="FFFFFF"/>
+          </a:solidFill>
+          <a:ln w="10160">
+            <a:solidFill>
+              <a:srgbClr val="5B8DEF"/>
+            </a:solidFill>
+          </a:ln>
+        </p:spPr>
+        <p:style>
+          <a:lnRef idx="1">
+            <a:schemeClr val="accent1"/>
+          </a:lnRef>
+          <a:fillRef idx="3">
+            <a:schemeClr val="accent1"/>
+          </a:fillRef>
+          <a:effectRef idx="2">
+            <a:schemeClr val="accent1"/>
+          </a:effectRef>
+          <a:fontRef idx="minor">
+            <a:schemeClr val="lt1"/>
+          </a:fontRef>
+        </p:style>
+        <p:txBody>
+          <a:bodyPr rtlCol="0" anchor="ctr"/>
+          <a:lstStyle/>
+          <a:p>
+            <a:pPr algn="ctr"/>
+          </a:p>
+        </p:txBody>
+      </p:sp>
       <p:pic>
         <p:nvPicPr>
-          <p:cNvPr id="26" name="Picture 25" descr="ood_chart.png"/>
+          <p:cNvPr id="68" name="Picture 67" descr="main_chart.png"/>
           <p:cNvPicPr>
             <a:picLocks noChangeAspect="1"/>
           </p:cNvPicPr>
@@ -4109,8 +5981,8 @@
         </p:blipFill>
         <p:spPr>
           <a:xfrm>
-            <a:off x="9829800" y="1298448"/>
-            <a:ext cx="4572000" cy="2351314"/>
+            <a:off x="23980140" y="5806440"/>
+            <a:ext cx="8915400" cy="4839789"/>
           </a:xfrm>
           <a:prstGeom prst="rect">
             <a:avLst/>
@@ -4119,112 +5991,27 @@
       </p:pic>
       <p:sp>
         <p:nvSpPr>
-          <p:cNvPr id="27" name="TextBox 26"/>
-          <p:cNvSpPr txBox="1"/>
-          <p:nvPr/>
-        </p:nvSpPr>
-        <p:spPr>
-          <a:xfrm>
-            <a:off x="10012680" y="4096512"/>
-            <a:ext cx="3977639" cy="640080"/>
-          </a:xfrm>
-          <a:prstGeom prst="rect">
-            <a:avLst/>
-          </a:prstGeom>
-          <a:noFill/>
-        </p:spPr>
-        <p:txBody>
-          <a:bodyPr wrap="none" lIns="45720" rIns="45720" tIns="18288">
-            <a:spAutoFit/>
-          </a:bodyPr>
-          <a:lstStyle/>
-          <a:p>
-            <a:pPr>
-              <a:spcAft>
-                <a:spcPts val="400"/>
-              </a:spcAft>
-              <a:defRPr sz="1200">
-                <a:solidFill>
-                  <a:srgbClr val="1F2328"/>
-                </a:solidFill>
-                <a:latin typeface="Aptos"/>
-              </a:defRPr>
-            </a:pPr>
-            <a:r>
-              <a:t>Paired-flip is the clearest current failure slice: acc 0.439.</a:t>
-            </a:r>
-          </a:p>
-          <a:p>
-            <a:pPr>
-              <a:spcAft>
-                <a:spcPts val="400"/>
-              </a:spcAft>
-              <a:defRPr sz="1200">
-                <a:solidFill>
-                  <a:srgbClr val="1F2328"/>
-                </a:solidFill>
-                <a:latin typeface="Aptos"/>
-              </a:defRPr>
-            </a:pPr>
-            <a:r>
-              <a:t>Graph/mechanism buckets are saturated smoke tests, not headline robustness evidence.</a:t>
-            </a:r>
-          </a:p>
-        </p:txBody>
-      </p:sp>
-      <p:sp>
-        <p:nvSpPr>
-          <p:cNvPr id="28" name="TextBox 27"/>
-          <p:cNvSpPr txBox="1"/>
-          <p:nvPr/>
-        </p:nvSpPr>
-        <p:spPr>
-          <a:xfrm>
-            <a:off x="9921240" y="5074920"/>
-            <a:ext cx="4297680" cy="228600"/>
-          </a:xfrm>
-          <a:prstGeom prst="rect">
-            <a:avLst/>
-          </a:prstGeom>
-          <a:noFill/>
-        </p:spPr>
-        <p:txBody>
-          <a:bodyPr wrap="none" lIns="36576" rIns="36576" tIns="18288" bIns="18288" anchor="t">
-            <a:spAutoFit/>
-          </a:bodyPr>
-          <a:lstStyle/>
-          <a:p>
-            <a:r>
-              <a:rPr sz="1600" b="1">
-                <a:solidFill>
-                  <a:srgbClr val="145388"/>
-                </a:solidFill>
-                <a:latin typeface="Aptos"/>
-              </a:rPr>
-              <a:t>Validity Gates</a:t>
-            </a:r>
-          </a:p>
-        </p:txBody>
-      </p:sp>
-      <p:sp>
-        <p:nvSpPr>
-          <p:cNvPr id="29" name="Rectangle 28"/>
+          <p:cNvPr id="69" name="Rounded Rectangle 68"/>
           <p:cNvSpPr/>
           <p:nvPr/>
         </p:nvSpPr>
         <p:spPr>
           <a:xfrm>
-            <a:off x="9921240" y="5330952"/>
-            <a:ext cx="4297680" cy="13716"/>
-          </a:xfrm>
-          <a:prstGeom prst="rect">
-            <a:avLst/>
+            <a:off x="23381208" y="10561320"/>
+            <a:ext cx="10113264" cy="1965960"/>
+          </a:xfrm>
+          <a:prstGeom prst="roundRect">
+            <a:avLst>
+              <a:gd name="adj" fmla="val 4000"/>
+            </a:avLst>
           </a:prstGeom>
           <a:solidFill>
-            <a:srgbClr val="145388"/>
+            <a:srgbClr val="FFF8E6"/>
           </a:solidFill>
-          <a:ln>
-            <a:noFill/>
+          <a:ln w="8255">
+            <a:solidFill>
+              <a:srgbClr val="D2D8E0"/>
+            </a:solidFill>
           </a:ln>
         </p:spPr>
         <p:style>
@@ -4251,22 +6038,129 @@
       </p:sp>
       <p:sp>
         <p:nvSpPr>
-          <p:cNvPr id="30" name="Rounded Rectangle 29"/>
+          <p:cNvPr id="70" name="TextBox 69"/>
+          <p:cNvSpPr txBox="1"/>
+          <p:nvPr/>
+        </p:nvSpPr>
+        <p:spPr>
+          <a:xfrm>
+            <a:off x="23545800" y="10689336"/>
+            <a:ext cx="9784080" cy="320040"/>
+          </a:xfrm>
+          <a:prstGeom prst="rect">
+            <a:avLst/>
+          </a:prstGeom>
+          <a:noFill/>
+        </p:spPr>
+        <p:txBody>
+          <a:bodyPr wrap="square" lIns="36576" rIns="36576" tIns="18288" bIns="18288" anchor="t">
+            <a:spAutoFit/>
+          </a:bodyPr>
+          <a:lstStyle/>
+          <a:p>
+            <a:r>
+              <a:rPr sz="1800" b="1">
+                <a:solidFill>
+                  <a:srgbClr val="5B636E"/>
+                </a:solidFill>
+                <a:latin typeface="Aptos"/>
+              </a:rPr>
+              <a:t>Result caption</a:t>
+            </a:r>
+          </a:p>
+        </p:txBody>
+      </p:sp>
+      <p:sp>
+        <p:nvSpPr>
+          <p:cNvPr id="71" name="TextBox 70"/>
+          <p:cNvSpPr txBox="1"/>
+          <p:nvPr/>
+        </p:nvSpPr>
+        <p:spPr>
+          <a:xfrm>
+            <a:off x="23545800" y="11064240"/>
+            <a:ext cx="9784080" cy="1371600"/>
+          </a:xfrm>
+          <a:prstGeom prst="rect">
+            <a:avLst/>
+          </a:prstGeom>
+          <a:noFill/>
+        </p:spPr>
+        <p:txBody>
+          <a:bodyPr wrap="square" lIns="45720" rIns="45720" tIns="18288">
+            <a:spAutoFit/>
+          </a:bodyPr>
+          <a:lstStyle/>
+          <a:p>
+            <a:pPr>
+              <a:spcAft>
+                <a:spcPts val="400"/>
+              </a:spcAft>
+              <a:defRPr sz="1400">
+                <a:solidFill>
+                  <a:srgbClr val="1F2328"/>
+                </a:solidFill>
+                <a:latin typeface="Aptos"/>
+              </a:defRPr>
+            </a:pPr>
+            <a:r>
+              <a:t>Ours: OOD acc 0.891, unsafe accept 0.000.</a:t>
+            </a:r>
+          </a:p>
+          <a:p>
+            <a:pPr>
+              <a:spcAft>
+                <a:spcPts val="400"/>
+              </a:spcAft>
+              <a:defRPr sz="1400">
+                <a:solidFill>
+                  <a:srgbClr val="1F2328"/>
+                </a:solidFill>
+                <a:latin typeface="Aptos"/>
+              </a:defRPr>
+            </a:pPr>
+            <a:r>
+              <a:t>GPT-5.5 prompt baseline: OOD acc 0.545, unsafe accept 0.071.</a:t>
+            </a:r>
+          </a:p>
+          <a:p>
+            <a:pPr>
+              <a:spcAft>
+                <a:spcPts val="400"/>
+              </a:spcAft>
+              <a:defRPr sz="1400">
+                <a:solidFill>
+                  <a:srgbClr val="1F2328"/>
+                </a:solidFill>
+                <a:latin typeface="Aptos"/>
+              </a:defRPr>
+            </a:pPr>
+            <a:r>
+              <a:t>The evidence supports a prototype diagnostic claim, not a final benchmark release.</a:t>
+            </a:r>
+          </a:p>
+        </p:txBody>
+      </p:sp>
+      <p:sp>
+        <p:nvSpPr>
+          <p:cNvPr id="72" name="Rounded Rectangle 71"/>
           <p:cNvSpPr/>
           <p:nvPr/>
         </p:nvSpPr>
         <p:spPr>
           <a:xfrm>
-            <a:off x="9921240" y="5440680"/>
-            <a:ext cx="4297680" cy="2176272"/>
+            <a:off x="23116032" y="13322808"/>
+            <a:ext cx="10652760" cy="12006072"/>
           </a:xfrm>
           <a:prstGeom prst="roundRect">
-            <a:avLst/>
+            <a:avLst>
+              <a:gd name="adj" fmla="val 4000"/>
+            </a:avLst>
           </a:prstGeom>
           <a:solidFill>
-            <a:srgbClr val="FAFCFF"/>
+            <a:srgbClr val="FFFFFF"/>
           </a:solidFill>
-          <a:ln w="9525">
+          <a:ln w="10160">
             <a:solidFill>
               <a:srgbClr val="D2D8E0"/>
             </a:solidFill>
@@ -4296,14 +6190,61 @@
       </p:sp>
       <p:sp>
         <p:nvSpPr>
-          <p:cNvPr id="31" name="TextBox 30"/>
+          <p:cNvPr id="73" name="Rounded Rectangle 72"/>
+          <p:cNvSpPr/>
+          <p:nvPr/>
+        </p:nvSpPr>
+        <p:spPr>
+          <a:xfrm>
+            <a:off x="23289768" y="13523976"/>
+            <a:ext cx="10305288" cy="557784"/>
+          </a:xfrm>
+          <a:prstGeom prst="roundRect">
+            <a:avLst>
+              <a:gd name="adj" fmla="val 8000"/>
+            </a:avLst>
+          </a:prstGeom>
+          <a:solidFill>
+            <a:srgbClr val="EAF2FF"/>
+          </a:solidFill>
+          <a:ln>
+            <a:solidFill>
+              <a:srgbClr val="EAF2FF"/>
+            </a:solidFill>
+          </a:ln>
+        </p:spPr>
+        <p:style>
+          <a:lnRef idx="1">
+            <a:schemeClr val="accent1"/>
+          </a:lnRef>
+          <a:fillRef idx="3">
+            <a:schemeClr val="accent1"/>
+          </a:fillRef>
+          <a:effectRef idx="2">
+            <a:schemeClr val="accent1"/>
+          </a:effectRef>
+          <a:fontRef idx="minor">
+            <a:schemeClr val="lt1"/>
+          </a:fontRef>
+        </p:style>
+        <p:txBody>
+          <a:bodyPr rtlCol="0" anchor="ctr"/>
+          <a:lstStyle/>
+          <a:p>
+            <a:pPr algn="ctr"/>
+          </a:p>
+        </p:txBody>
+      </p:sp>
+      <p:sp>
+        <p:nvSpPr>
+          <p:cNvPr id="74" name="TextBox 73"/>
           <p:cNvSpPr txBox="1"/>
           <p:nvPr/>
         </p:nvSpPr>
         <p:spPr>
           <a:xfrm>
-            <a:off x="10104120" y="5596128"/>
-            <a:ext cx="4023360" cy="1828800"/>
+            <a:off x="23445216" y="13569696"/>
+            <a:ext cx="9994392" cy="402336"/>
           </a:xfrm>
           <a:prstGeom prst="rect">
             <a:avLst/>
@@ -4311,7 +6252,356 @@
           <a:noFill/>
         </p:spPr>
         <p:txBody>
-          <a:bodyPr wrap="none" lIns="45720" rIns="45720" tIns="18288">
+          <a:bodyPr wrap="square" lIns="36576" rIns="36576" tIns="18288" bIns="18288" anchor="t">
+            <a:spAutoFit/>
+          </a:bodyPr>
+          <a:lstStyle/>
+          <a:p>
+            <a:r>
+              <a:rPr sz="2500" b="1">
+                <a:solidFill>
+                  <a:srgbClr val="163B6C"/>
+                </a:solidFill>
+                <a:latin typeface="Aptos"/>
+              </a:rPr>
+              <a:t>Examples</a:t>
+            </a:r>
+          </a:p>
+        </p:txBody>
+      </p:sp>
+      <p:sp>
+        <p:nvSpPr>
+          <p:cNvPr id="75" name="Rounded Rectangle 74"/>
+          <p:cNvSpPr/>
+          <p:nvPr/>
+        </p:nvSpPr>
+        <p:spPr>
+          <a:xfrm>
+            <a:off x="23399496" y="14374368"/>
+            <a:ext cx="4965192" cy="5806440"/>
+          </a:xfrm>
+          <a:prstGeom prst="roundRect">
+            <a:avLst>
+              <a:gd name="adj" fmla="val 4000"/>
+            </a:avLst>
+          </a:prstGeom>
+          <a:solidFill>
+            <a:srgbClr val="EAF2FF"/>
+          </a:solidFill>
+          <a:ln w="10160">
+            <a:solidFill>
+              <a:srgbClr val="D2D8E0"/>
+            </a:solidFill>
+          </a:ln>
+        </p:spPr>
+        <p:style>
+          <a:lnRef idx="1">
+            <a:schemeClr val="accent1"/>
+          </a:lnRef>
+          <a:fillRef idx="3">
+            <a:schemeClr val="accent1"/>
+          </a:fillRef>
+          <a:effectRef idx="2">
+            <a:schemeClr val="accent1"/>
+          </a:effectRef>
+          <a:fontRef idx="minor">
+            <a:schemeClr val="lt1"/>
+          </a:fontRef>
+        </p:style>
+        <p:txBody>
+          <a:bodyPr rtlCol="0" anchor="ctr"/>
+          <a:lstStyle/>
+          <a:p>
+            <a:pPr algn="ctr"/>
+          </a:p>
+        </p:txBody>
+      </p:sp>
+      <p:sp>
+        <p:nvSpPr>
+          <p:cNvPr id="76" name="TextBox 75"/>
+          <p:cNvSpPr txBox="1"/>
+          <p:nvPr/>
+        </p:nvSpPr>
+        <p:spPr>
+          <a:xfrm>
+            <a:off x="23545800" y="14520672"/>
+            <a:ext cx="4654296" cy="320040"/>
+          </a:xfrm>
+          <a:prstGeom prst="rect">
+            <a:avLst/>
+          </a:prstGeom>
+          <a:noFill/>
+        </p:spPr>
+        <p:txBody>
+          <a:bodyPr wrap="square" lIns="36576" rIns="36576" tIns="18288" bIns="18288" anchor="t">
+            <a:spAutoFit/>
+          </a:bodyPr>
+          <a:lstStyle/>
+          <a:p>
+            <a:r>
+              <a:rPr sz="1500" b="1">
+                <a:solidFill>
+                  <a:srgbClr val="5B636E"/>
+                </a:solidFill>
+                <a:latin typeface="Aptos"/>
+              </a:rPr>
+              <a:t>Example A: unidentifiable claim</a:t>
+            </a:r>
+          </a:p>
+        </p:txBody>
+      </p:sp>
+      <p:sp>
+        <p:nvSpPr>
+          <p:cNvPr id="77" name="TextBox 76"/>
+          <p:cNvSpPr txBox="1"/>
+          <p:nvPr/>
+        </p:nvSpPr>
+        <p:spPr>
+          <a:xfrm>
+            <a:off x="23545800" y="15041880"/>
+            <a:ext cx="4617720" cy="4480560"/>
+          </a:xfrm>
+          <a:prstGeom prst="rect">
+            <a:avLst/>
+          </a:prstGeom>
+          <a:noFill/>
+        </p:spPr>
+        <p:txBody>
+          <a:bodyPr wrap="square" lIns="36576" rIns="36576" tIns="18288" bIns="18288" anchor="t">
+            <a:spAutoFit/>
+          </a:bodyPr>
+          <a:lstStyle/>
+          <a:p>
+            <a:r>
+              <a:rPr sz="1300" b="0">
+                <a:solidFill>
+                  <a:srgbClr val="1F2328"/>
+                </a:solidFill>
+                <a:latin typeface="Aptos"/>
+              </a:rPr>
+              <a:t>Claim: association between therapy_flag and yield_score is treated as causal.
+Gold label: UNIDENTIFIABLE.
+Reason: public evidence leaves confounding or reverse causality open.</a:t>
+            </a:r>
+          </a:p>
+        </p:txBody>
+      </p:sp>
+      <p:sp>
+        <p:nvSpPr>
+          <p:cNvPr id="78" name="Rounded Rectangle 77"/>
+          <p:cNvSpPr/>
+          <p:nvPr/>
+        </p:nvSpPr>
+        <p:spPr>
+          <a:xfrm>
+            <a:off x="28529280" y="14374368"/>
+            <a:ext cx="4965192" cy="5806440"/>
+          </a:xfrm>
+          <a:prstGeom prst="roundRect">
+            <a:avLst>
+              <a:gd name="adj" fmla="val 4000"/>
+            </a:avLst>
+          </a:prstGeom>
+          <a:solidFill>
+            <a:srgbClr val="EAF7EE"/>
+          </a:solidFill>
+          <a:ln w="10160">
+            <a:solidFill>
+              <a:srgbClr val="D2D8E0"/>
+            </a:solidFill>
+          </a:ln>
+        </p:spPr>
+        <p:style>
+          <a:lnRef idx="1">
+            <a:schemeClr val="accent1"/>
+          </a:lnRef>
+          <a:fillRef idx="3">
+            <a:schemeClr val="accent1"/>
+          </a:fillRef>
+          <a:effectRef idx="2">
+            <a:schemeClr val="accent1"/>
+          </a:effectRef>
+          <a:fontRef idx="minor">
+            <a:schemeClr val="lt1"/>
+          </a:fontRef>
+        </p:style>
+        <p:txBody>
+          <a:bodyPr rtlCol="0" anchor="ctr"/>
+          <a:lstStyle/>
+          <a:p>
+            <a:pPr algn="ctr"/>
+          </a:p>
+        </p:txBody>
+      </p:sp>
+      <p:sp>
+        <p:nvSpPr>
+          <p:cNvPr id="79" name="TextBox 78"/>
+          <p:cNvSpPr txBox="1"/>
+          <p:nvPr/>
+        </p:nvSpPr>
+        <p:spPr>
+          <a:xfrm>
+            <a:off x="28684728" y="14520672"/>
+            <a:ext cx="4654296" cy="320040"/>
+          </a:xfrm>
+          <a:prstGeom prst="rect">
+            <a:avLst/>
+          </a:prstGeom>
+          <a:noFill/>
+        </p:spPr>
+        <p:txBody>
+          <a:bodyPr wrap="square" lIns="36576" rIns="36576" tIns="18288" bIns="18288" anchor="t">
+            <a:spAutoFit/>
+          </a:bodyPr>
+          <a:lstStyle/>
+          <a:p>
+            <a:r>
+              <a:rPr sz="1500" b="1">
+                <a:solidFill>
+                  <a:srgbClr val="5B636E"/>
+                </a:solidFill>
+                <a:latin typeface="Aptos"/>
+              </a:rPr>
+              <a:t>Example B: verifier response</a:t>
+            </a:r>
+          </a:p>
+        </p:txBody>
+      </p:sp>
+      <p:sp>
+        <p:nvSpPr>
+          <p:cNvPr id="80" name="TextBox 79"/>
+          <p:cNvSpPr txBox="1"/>
+          <p:nvPr/>
+        </p:nvSpPr>
+        <p:spPr>
+          <a:xfrm>
+            <a:off x="28684728" y="15041880"/>
+            <a:ext cx="4617720" cy="4480560"/>
+          </a:xfrm>
+          <a:prstGeom prst="rect">
+            <a:avLst/>
+          </a:prstGeom>
+          <a:noFill/>
+        </p:spPr>
+        <p:txBody>
+          <a:bodyPr wrap="square" lIns="36576" rIns="36576" tIns="18288" bIns="18288" anchor="t">
+            <a:spAutoFit/>
+          </a:bodyPr>
+          <a:lstStyle/>
+          <a:p>
+            <a:r>
+              <a:rPr sz="1300" b="0">
+                <a:solidFill>
+                  <a:srgbClr val="1F2328"/>
+                </a:solidFill>
+                <a:latin typeface="Aptos"/>
+              </a:rPr>
+              <a:t>Output: refuse the causal conclusion.
+Witness: construct a public-compatible counter-SCM.
+Takeaway: refusal is evidence-sensitive, not blanket abstention.</a:t>
+            </a:r>
+          </a:p>
+        </p:txBody>
+      </p:sp>
+      <p:sp>
+        <p:nvSpPr>
+          <p:cNvPr id="81" name="Rounded Rectangle 80"/>
+          <p:cNvSpPr/>
+          <p:nvPr/>
+        </p:nvSpPr>
+        <p:spPr>
+          <a:xfrm>
+            <a:off x="23381208" y="20619720"/>
+            <a:ext cx="10113264" cy="2880360"/>
+          </a:xfrm>
+          <a:prstGeom prst="roundRect">
+            <a:avLst>
+              <a:gd name="adj" fmla="val 4000"/>
+            </a:avLst>
+          </a:prstGeom>
+          <a:solidFill>
+            <a:srgbClr val="FFF8E6"/>
+          </a:solidFill>
+          <a:ln w="8255">
+            <a:solidFill>
+              <a:srgbClr val="D2D8E0"/>
+            </a:solidFill>
+          </a:ln>
+        </p:spPr>
+        <p:style>
+          <a:lnRef idx="1">
+            <a:schemeClr val="accent1"/>
+          </a:lnRef>
+          <a:fillRef idx="3">
+            <a:schemeClr val="accent1"/>
+          </a:fillRef>
+          <a:effectRef idx="2">
+            <a:schemeClr val="accent1"/>
+          </a:effectRef>
+          <a:fontRef idx="minor">
+            <a:schemeClr val="lt1"/>
+          </a:fontRef>
+        </p:style>
+        <p:txBody>
+          <a:bodyPr rtlCol="0" anchor="ctr"/>
+          <a:lstStyle/>
+          <a:p>
+            <a:pPr algn="ctr"/>
+          </a:p>
+        </p:txBody>
+      </p:sp>
+      <p:sp>
+        <p:nvSpPr>
+          <p:cNvPr id="82" name="TextBox 81"/>
+          <p:cNvSpPr txBox="1"/>
+          <p:nvPr/>
+        </p:nvSpPr>
+        <p:spPr>
+          <a:xfrm>
+            <a:off x="23545800" y="20747736"/>
+            <a:ext cx="9784080" cy="320040"/>
+          </a:xfrm>
+          <a:prstGeom prst="rect">
+            <a:avLst/>
+          </a:prstGeom>
+          <a:noFill/>
+        </p:spPr>
+        <p:txBody>
+          <a:bodyPr wrap="square" lIns="36576" rIns="36576" tIns="18288" bIns="18288" anchor="t">
+            <a:spAutoFit/>
+          </a:bodyPr>
+          <a:lstStyle/>
+          <a:p>
+            <a:r>
+              <a:rPr sz="1800" b="1">
+                <a:solidFill>
+                  <a:srgbClr val="5B636E"/>
+                </a:solidFill>
+                <a:latin typeface="Aptos"/>
+              </a:rPr>
+              <a:t>Validity gates before release</a:t>
+            </a:r>
+          </a:p>
+        </p:txBody>
+      </p:sp>
+      <p:sp>
+        <p:nvSpPr>
+          <p:cNvPr id="83" name="TextBox 82"/>
+          <p:cNvSpPr txBox="1"/>
+          <p:nvPr/>
+        </p:nvSpPr>
+        <p:spPr>
+          <a:xfrm>
+            <a:off x="23545800" y="21122640"/>
+            <a:ext cx="9784080" cy="2286000"/>
+          </a:xfrm>
+          <a:prstGeom prst="rect">
+            <a:avLst/>
+          </a:prstGeom>
+          <a:noFill/>
+        </p:spPr>
+        <p:txBody>
+          <a:bodyPr wrap="square" lIns="45720" rIns="45720" tIns="18288">
             <a:spAutoFit/>
           </a:bodyPr>
           <a:lstStyle/>
@@ -4320,7 +6610,7 @@
               <a:spcAft>
                 <a:spcPts val="400"/>
               </a:spcAft>
-              <a:defRPr sz="800">
+              <a:defRPr sz="1400">
                 <a:solidFill>
                   <a:srgbClr val="1F2328"/>
                 </a:solidFill>
@@ -4328,7 +6618,7 @@
               </a:defRPr>
             </a:pPr>
             <a:r>
-              <a:t>Leakage control: oracle-positive reaches 1.000/1.000; score gain is contamination.</a:t>
+              <a:t>Leakage check: oracle-positive 1.000/1.000; gain is contamination.</a:t>
             </a:r>
           </a:p>
           <a:p>
@@ -4336,7 +6626,7 @@
               <a:spcAft>
                 <a:spcPts val="400"/>
               </a:spcAft>
-              <a:defRPr sz="800">
+              <a:defRPr sz="1400">
                 <a:solidFill>
                   <a:srgbClr val="1F2328"/>
                 </a:solidFill>
@@ -4344,7 +6634,7 @@
               </a:defRPr>
             </a:pPr>
             <a:r>
-              <a:t>LLM matrix: 5 models, n=1245, failed=0, parse=0, fallback=0; best OOD GPT-5.5 acc=0.545, unsafe=0.071.</a:t>
+              <a:t>API baselines: 5 models, 1245 predictions; best OOD GPT-5.5 acc 0.545, unsafe 0.071.</a:t>
             </a:r>
           </a:p>
           <a:p>
@@ -4352,7 +6642,7 @@
               <a:spcAft>
                 <a:spcPts val="400"/>
               </a:spcAft>
-              <a:defRPr sz="800">
+              <a:defRPr sz="1400">
                 <a:solidFill>
                   <a:srgbClr val="1F2328"/>
                 </a:solidFill>
@@ -4360,37 +6650,21 @@
               </a:defRPr>
             </a:pPr>
             <a:r>
-              <a:t>Release gates: larger synthetic runs, real-grounded dual audit, frozen model versions.</a:t>
-            </a:r>
-          </a:p>
-          <a:p>
-            <a:pPr>
-              <a:spcAft>
-                <a:spcPts val="400"/>
-              </a:spcAft>
-              <a:defRPr sz="800">
-                <a:solidFill>
-                  <a:srgbClr val="1F2328"/>
-                </a:solidFill>
-                <a:latin typeface="Aptos"/>
-              </a:defRPr>
-            </a:pPr>
-            <a:r>
-              <a:t>Current status: prototype evidence, not a mature benchmark release.</a:t>
-            </a:r>
-          </a:p>
-        </p:txBody>
-      </p:sp>
-      <p:sp>
-        <p:nvSpPr>
-          <p:cNvPr id="32" name="TextBox 31"/>
+              <a:t>Next gates: larger synthetic runs, real-grounded dual audit, frozen model versions.</a:t>
+            </a:r>
+          </a:p>
+        </p:txBody>
+      </p:sp>
+      <p:sp>
+        <p:nvSpPr>
+          <p:cNvPr id="84" name="TextBox 83"/>
           <p:cNvSpPr txBox="1"/>
           <p:nvPr/>
         </p:nvSpPr>
         <p:spPr>
           <a:xfrm>
-            <a:off x="411480" y="7818120"/>
-            <a:ext cx="13807440" cy="219456"/>
+            <a:off x="23408640" y="24185880"/>
+            <a:ext cx="9966960" cy="292608"/>
           </a:xfrm>
           <a:prstGeom prst="rect">
             <a:avLst/>
@@ -4398,20 +6672,20 @@
           <a:noFill/>
         </p:spPr>
         <p:txBody>
-          <a:bodyPr wrap="none" lIns="36576" rIns="36576" tIns="18288" bIns="18288" anchor="t">
+          <a:bodyPr wrap="square" lIns="36576" rIns="36576" tIns="18288" bIns="18288" anchor="t">
             <a:spAutoFit/>
           </a:bodyPr>
           <a:lstStyle/>
           <a:p>
             <a:pPr algn="ctr"/>
             <a:r>
-              <a:rPr sz="900" b="0">
+              <a:rPr sz="1100" b="0">
                 <a:solidFill>
                   <a:srgbClr val="5B636E"/>
                 </a:solidFill>
                 <a:latin typeface="Aptos"/>
               </a:rPr>
-              <a:t>Manifest: outputs/paper_facing/manifest.json | LLM matrix: full_llm_baseline_matrix_completed | Poster generated from frozen JSON artifacts</a:t>
+              <a:t>Frozen artifact manifest: outputs/paper_facing/manifest.json | full_llm_baseline_matrix_completed</a:t>
             </a:r>
           </a:p>
         </p:txBody>

</xml_diff>